<commit_message>
docs: finalize OpenAI validation and presentation
</commit_message>
<xml_diff>
--- a/output/presentations/transformer-spec-review-presentation.pptx
+++ b/output/presentations/transformer-spec-review-presentation.pptx
@@ -2,30 +2,30 @@
 <file path=ppt/presentation.xml><?xml version="1.0" encoding="utf-8"?>
 <p:presentation xmlns:p="http://schemas.openxmlformats.org/presentationml/2006/main">
   <p:sldMasterIdLst>
-    <p:sldMasterId xmlns:r="http://schemas.openxmlformats.org/officeDocument/2006/relationships" id="2147483648" r:id="Rd53550e5b278406f"/>
+    <p:sldMasterId xmlns:r="http://schemas.openxmlformats.org/officeDocument/2006/relationships" id="2147483648" r:id="R4bf1340fdbf74b6a"/>
   </p:sldMasterIdLst>
   <p:notesMasterIdLst>
-    <p:notesMasterId xmlns:r="http://schemas.openxmlformats.org/officeDocument/2006/relationships" r:id="Rcfa017f284b64db2"/>
+    <p:notesMasterId xmlns:r="http://schemas.openxmlformats.org/officeDocument/2006/relationships" r:id="Ra5e1873709314fb8"/>
   </p:notesMasterIdLst>
   <p:sldIdLst>
-    <p:sldId xmlns:r="http://schemas.openxmlformats.org/officeDocument/2006/relationships" id="256" r:id="Rf943121e190940d0"/>
-    <p:sldId xmlns:r="http://schemas.openxmlformats.org/officeDocument/2006/relationships" id="257" r:id="Re84793dec79a417d"/>
-    <p:sldId xmlns:r="http://schemas.openxmlformats.org/officeDocument/2006/relationships" id="258" r:id="R7b767de5e5664a73"/>
-    <p:sldId xmlns:r="http://schemas.openxmlformats.org/officeDocument/2006/relationships" id="259" r:id="R4b50d62257d14258"/>
-    <p:sldId xmlns:r="http://schemas.openxmlformats.org/officeDocument/2006/relationships" id="260" r:id="Rbaf66b52f7cc4723"/>
-    <p:sldId xmlns:r="http://schemas.openxmlformats.org/officeDocument/2006/relationships" id="261" r:id="R44939a02c13f4223"/>
-    <p:sldId xmlns:r="http://schemas.openxmlformats.org/officeDocument/2006/relationships" id="262" r:id="Re86c7813800548dd"/>
-    <p:sldId xmlns:r="http://schemas.openxmlformats.org/officeDocument/2006/relationships" id="263" r:id="Rca2064e6028e466a"/>
-    <p:sldId xmlns:r="http://schemas.openxmlformats.org/officeDocument/2006/relationships" id="264" r:id="Rebfb1a0d357849d7"/>
-    <p:sldId xmlns:r="http://schemas.openxmlformats.org/officeDocument/2006/relationships" id="265" r:id="Rb8b3b68eafbd4295"/>
-    <p:sldId xmlns:r="http://schemas.openxmlformats.org/officeDocument/2006/relationships" id="266" r:id="Reac6673a28524ba8"/>
-    <p:sldId xmlns:r="http://schemas.openxmlformats.org/officeDocument/2006/relationships" id="267" r:id="Rd184ba32c507420f"/>
-    <p:sldId xmlns:r="http://schemas.openxmlformats.org/officeDocument/2006/relationships" id="268" r:id="R3dc8feb6500e414c"/>
-    <p:sldId xmlns:r="http://schemas.openxmlformats.org/officeDocument/2006/relationships" id="269" r:id="Rca61dc7158fe4856"/>
-    <p:sldId xmlns:r="http://schemas.openxmlformats.org/officeDocument/2006/relationships" id="270" r:id="R372de70b7bf04575"/>
-    <p:sldId xmlns:r="http://schemas.openxmlformats.org/officeDocument/2006/relationships" id="271" r:id="Rc32bbc50947a4c48"/>
-    <p:sldId xmlns:r="http://schemas.openxmlformats.org/officeDocument/2006/relationships" id="272" r:id="R1cebcaaa0c504c6e"/>
-    <p:sldId xmlns:r="http://schemas.openxmlformats.org/officeDocument/2006/relationships" id="273" r:id="R78905bb2985c4805"/>
+    <p:sldId xmlns:r="http://schemas.openxmlformats.org/officeDocument/2006/relationships" id="256" r:id="Rbb670d6ace194cdf"/>
+    <p:sldId xmlns:r="http://schemas.openxmlformats.org/officeDocument/2006/relationships" id="257" r:id="R34703501f57f4eea"/>
+    <p:sldId xmlns:r="http://schemas.openxmlformats.org/officeDocument/2006/relationships" id="258" r:id="Rd591afa647864aec"/>
+    <p:sldId xmlns:r="http://schemas.openxmlformats.org/officeDocument/2006/relationships" id="259" r:id="R6883505e3f594929"/>
+    <p:sldId xmlns:r="http://schemas.openxmlformats.org/officeDocument/2006/relationships" id="260" r:id="R87e64e5082a54a6b"/>
+    <p:sldId xmlns:r="http://schemas.openxmlformats.org/officeDocument/2006/relationships" id="261" r:id="Re05df6207b874055"/>
+    <p:sldId xmlns:r="http://schemas.openxmlformats.org/officeDocument/2006/relationships" id="262" r:id="Re85dc68893304d5a"/>
+    <p:sldId xmlns:r="http://schemas.openxmlformats.org/officeDocument/2006/relationships" id="263" r:id="R9c4342c4c95a476f"/>
+    <p:sldId xmlns:r="http://schemas.openxmlformats.org/officeDocument/2006/relationships" id="264" r:id="R6018f2f3ed7e4402"/>
+    <p:sldId xmlns:r="http://schemas.openxmlformats.org/officeDocument/2006/relationships" id="265" r:id="Rdd90de80656745e1"/>
+    <p:sldId xmlns:r="http://schemas.openxmlformats.org/officeDocument/2006/relationships" id="266" r:id="Rc6aa489ee62d4fdc"/>
+    <p:sldId xmlns:r="http://schemas.openxmlformats.org/officeDocument/2006/relationships" id="267" r:id="R93ac106e67194b44"/>
+    <p:sldId xmlns:r="http://schemas.openxmlformats.org/officeDocument/2006/relationships" id="268" r:id="R84c06c198bb5458a"/>
+    <p:sldId xmlns:r="http://schemas.openxmlformats.org/officeDocument/2006/relationships" id="269" r:id="R0bc45d243310488a"/>
+    <p:sldId xmlns:r="http://schemas.openxmlformats.org/officeDocument/2006/relationships" id="270" r:id="R1535d811a7e244ba"/>
+    <p:sldId xmlns:r="http://schemas.openxmlformats.org/officeDocument/2006/relationships" id="271" r:id="R4aa850c92039424c"/>
+    <p:sldId xmlns:r="http://schemas.openxmlformats.org/officeDocument/2006/relationships" id="272" r:id="R6241c7b38a30450b"/>
+    <p:sldId xmlns:r="http://schemas.openxmlformats.org/officeDocument/2006/relationships" id="273" r:id="R1f8c980409ed4ddf"/>
   </p:sldIdLst>
   <p:sldSz cx="12192000" cy="6858000"/>
   <p:notesSz cx="6858000" cy="9144000"/>
@@ -529,17 +529,12 @@
           <a:lstStyle xmlns:a="http://schemas.openxmlformats.org/drawingml/2006/main"/>
           <a:p xmlns:a="http://schemas.openxmlformats.org/drawingml/2006/main">
             <a:r>
-              <a:t>[부록 · 5분 본 발표에서는 넘기지 않습니다]</a:t>
+              <a:t>[부록] AI는 검색 계획과 값·단위를 제안합니다. 코드가 검색 실행·인용 검증·단위 정규화·변경 적용·최종 상태 비교를 수행합니다. 담당자가 적용할 변경과 원문을 확인합니다. 최종 실행은 OpenAI gpt-4o-mini이며 Ollama는 선택 가능한 별도 실행 방식입니다. 사람의 체크는 실제 결재나 승인 권한 인증이 아닙니다.</a:t>
             </a:r>
           </a:p>
           <a:p xmlns:a="http://schemas.openxmlformats.org/drawingml/2006/main">
             <a:r>
-              <a:t>처리 주체를 나눈 것이 핵심 설계입니다. AI는 첫 호출에서 지정된 항목과 별칭으로 검색 계획을 만들고, 두 번째 호출에서 검색된 원문의 값과 단위를 제안합니다. 검색 실행과 인용 검증, 단위 정규화, 변경 적용, 최종 상태 비교는 코드가 수행합니다. 담당자는 적용할 변경 기준과 결과의 원문을 확인합니다. 정상 추출 경로는 최대 두 번의 모델 호출이며, 사람의 체크가 실제 전자결재나 승인 권한 인증은 아닙니다.</a:t>
-            </a:r>
-          </a:p>
-          <a:p xmlns:a="http://schemas.openxmlformats.org/drawingml/2006/main">
-            <a:r>
-              <a:t>출처: extraction_agent.py:300,497,573,613,632; review.py:113; web/app.js:556.</a:t>
+              <a:t>출처: extraction_agent.py301,498,574,624,643; review.py113; llm_backend.py199.</a:t>
             </a:r>
           </a:p>
         </p:txBody>
@@ -609,22 +604,12 @@
           <a:lstStyle xmlns:a="http://schemas.openxmlformats.org/drawingml/2006/main"/>
           <a:p xmlns:a="http://schemas.openxmlformats.org/drawingml/2006/main">
             <a:r>
-              <a:t>[부록 · 5분 본 발표에서는 넘기지 않습니다]</a:t>
+              <a:t>[부록] 키워드와 별칭으로 원문을 찾아 다음 AI 요청에 전달하는 제한된 RAG입니다. 모델 출력은 JSON 구조와 원문·값·단위로 검증하고 불명확하면 보류합니다. request_fn 의존성 주입으로 실패와 경계 조건을 시험합니다. PDF·추출·비교·API·보고서를 분리했으며 OpenAI/Ollama 제공업체 선택과 서버측 키 설정을 지원합니다. OpenAI는 외부 전송·과금 동의 후 실행하고 실패 시 자동으로 다른 제공업체를 부르지 않습니다. Multi-Agent·MCP·LangGraph·LangSmith·벡터 검색은 미사용입니다.</a:t>
             </a:r>
           </a:p>
           <a:p xmlns:a="http://schemas.openxmlformats.org/drawingml/2006/main">
             <a:r>
-              <a:t>기술 요소는 많이 나열하기보다 문제에 필요한 것을 선택했습니다. 현재 RAG는 임베딩 벡터가 아니라 키워드와 별칭으로 원문을 찾아 AI에 전달하는 제한된 검색 방식입니다. 모델 출력은 JSON 스키마와 원문으로 검사하며, 주파수처럼 값이 없으면 임의로 채우지 않습니다. request_fn을 주입해 실제 모델 없이 오류와 경계 조건을 시험합니다. 웹 API, 추출, 비교, 보고서도 모듈로 분리했습니다. Multi-Agent, MCP, LangSmith는 구현하지 않았습니다.</a:t>
-            </a:r>
-          </a:p>
-          <a:p xmlns:a="http://schemas.openxmlformats.org/drawingml/2006/main">
-            <a:r>
-              <a:t>출처: extraction_agent.py:300,497,573; web_app.py; report.py; tests/test_extraction_agent.py.</a:t>
-            </a:r>
-          </a:p>
-          <a:p xmlns:a="http://schemas.openxmlformats.org/drawingml/2006/main">
-            <a:r>
-              <a:t>선택하지 않은 기술도 이유를 설명합니다. 문서 3종·고정된 검토 항목에서는 역할별 여러 에이전트와 외부 도구 서버가 꼭 필요하지 않았습니다. request_fn 주입과 제한된 순차 흐름으로 검증을 단순하게 유지했습니다. 로컬 실행 기록으로 개발 경로를 확인하지만 외부 LangSmith 관측 체계는 연결하지 않았습니다.</a:t>
+              <a:t>출처: extraction_agent.py301,498,574,600; llm_backend.py199; web_app.py; report.py; tests/test_extraction_agent.py.</a:t>
             </a:r>
           </a:p>
         </p:txBody>
@@ -694,17 +679,12 @@
           <a:lstStyle xmlns:a="http://schemas.openxmlformats.org/drawingml/2006/main"/>
           <a:p xmlns:a="http://schemas.openxmlformats.org/drawingml/2006/main">
             <a:r>
-              <a:t>[부록 · 5분 본 발표에서는 넘기지 않습니다]</a:t>
+              <a:t>[부록] 2026-10-21 OpenAI gpt-4o-mini로 공개 합성 V01~V03을 각 2회 실제 호출했습니다. V01 21/21값 채택·9일치1불일치, V02 20/21값 채택·9일치1검토, V03 22/22값 채택·8일치2불일치입니다. V02 주파수는 미기재라 actual=null, evidence_complete=false로 보류한 정상 결과입니다. 원문 연결60개·무효0과 의미·근거 완전성은 다릅니다. 세 사례30항목의 기대 상태 일치는 소량 합성 수용시험이지 현업 모델 정확도가 아닙니다. Python444, DOM71(근거12·복구45·보고서14)은 모델 없는 모의 자동검사입니다.</a:t>
             </a:r>
           </a:p>
           <a:p xmlns:a="http://schemas.openxmlformats.org/drawingml/2006/main">
             <a:r>
-              <a:t>세 가지 가상 문서를 실제 모델과 화면으로 확인했습니다. V01은 팬 전원 불일치 한 개, V02는 주파수 미기재에 따른 확인 필요 한 개, V03는 탭절환기 방식과 설치 구분 불일치 두 개였습니다. 각 행은 열 개 검토 항목의 상태 수이며 AI 정확도 비율이 아닙니다. 이와 별도로 전체 파이썬 자동 검사 385개와 모의 화면 검사 65개를 다시 실행해 통과했습니다. 자동 검사는 코드의 규칙과 실패 대응을 확인한 것이고 실제 회사 문서의 모델 정확도나 업무시간 절감률은 아직 측정하지 않았습니다.</a:t>
-            </a:r>
-          </a:p>
-          <a:p xmlns:a="http://schemas.openxmlformats.org/drawingml/2006/main">
-            <a:r>
-              <a:t>출처: docs/publication.md, 2026-10-21 자동검사 재검증. 실제 모델·외부 서비스 신규 호출은 0회입니다. V01/V02/V03 결과는 앞서 확인한 실제 시연 기록입니다. DOM 세부: 근거12, 복구39, 보고서14. 결과 합계: 각 행10.</a:t>
+              <a:t>출처: reports/openai-validation-20261021.json; output/openai-v01-result.png,openai-v02-result.png,openai-v03-result.png. 실행 코드887da6e. 과거 F01~F06/F04는 별도 Ollama 기록입니다.</a:t>
             </a:r>
           </a:p>
         </p:txBody>
@@ -774,17 +754,12 @@
           <a:lstStyle xmlns:a="http://schemas.openxmlformats.org/drawingml/2006/main"/>
           <a:p xmlns:a="http://schemas.openxmlformats.org/drawingml/2006/main">
             <a:r>
-              <a:t>[부록 · 5분 본 발표에서는 넘기지 않습니다]</a:t>
+              <a:t>[부록] 형식을 제한해 원문·값 검증을 쉽게 만들었지만 실제 회사의 다양한 양식·스캔·도면은 바로 지원하지 않습니다. 모호한 값을 보류하면 잘못된 확정을 피하는 데 도움이 되지만 담당자의 확인 부담이 늘어납니다. 최종은 OpenAI API이며 서버에 키를 보관하고 외부 전송·과금 동의를 받습니다. Ollama는 선택 가능한 별도 방식이고 오류 시 자동 전환하지 않습니다. 지원 범위 밖 표현을 놓칠 수 있어 독립 문서 평가와 동일 입력의 호출·검색 방식·비용·지연 비교가 필요합니다.</a:t>
             </a:r>
           </a:p>
           <a:p xmlns:a="http://schemas.openxmlformats.org/drawingml/2006/main">
             <a:r>
-              <a:t>먼저 문서 형식을 제한해 원문과 값을 검증하기 쉽게 만들었지만, 실제 회사의 다양한 문서를 바로 넣을 수는 없습니다. 두 번째로 확실하지 않은 값은 보류하는 쪽으로 설계했습니다. 잘못된 확정을 줄이려는 선택이지만 사람의 확인 부담이 늘고 정상적인 조건 표현도 보류될 수 있습니다. 세 번째로 로컬 모델과 키워드 검색을 사용해 외부 AI API 없이 실행하지만, 지원하지 않는 표현을 놓칠 수 있고 PC 성능에 따라 시간이 달라집니다. 후속 과제는 실제 양식의 독립 평가와 단일 호출·2회 호출·검색 방식의 동일 입력 비교입니다.</a:t>
-            </a:r>
-          </a:p>
-          <a:p xmlns:a="http://schemas.openxmlformats.org/drawingml/2006/main">
-            <a:r>
-              <a:t>출처: README.md 지원 범위, extraction_agent.py 검증 경로, docs/publication.md.</a:t>
+              <a:t>출처: README.md; docs/ai-backends.md; reports/openai-validation-20261021.json.</a:t>
             </a:r>
           </a:p>
         </p:txBody>
@@ -867,6 +842,11 @@
               <a:t>출처: reports/evidence-before-after-20261020T111053Z-4e8705ae.json; scripts/measure_evidence_before_after.py; tests/test_evidence_binding.py. 입력과 응답 해시, 출처 차이는 측정보고서에 기록했습니다.</a:t>
             </a:r>
           </a:p>
+          <a:p xmlns:a="http://schemas.openxmlformats.org/drawingml/2006/main">
+            <a:r>
+              <a:t>이 자료는 과거 Ollama F04의 기록 비교입니다. 현재 OpenAI의 정확도·속도·비용 개선 실험으로 해석하지 않습니다.</a:t>
+            </a:r>
+          </a:p>
         </p:txBody>
       </p:sp>
       <p:sp>
@@ -937,6 +917,11 @@
               <a:t>[부록 · F04 수정 후 화면] output/evidence-conflict-fix.png의 실제 기존 화면을 비율 유지해 삽입했습니다. 400 V와 440 V가 함께 있는 내부 인계서의 두 근거를 확인 필요 상태로 노출합니다. 판정은 기존에도 확인 필요였고 그 상태는 유지했습니다. 앞 장은 동일 PDF·당시 저장된 모델 응답을 고정한 현재 코드 재생과 이전 저장 결과의 제한된 비교입니다. 이 화면은 수정 후 화면만 존재합니다. 이전 소스를 새로 실행하거나 수정 전 UI 화면을 확보한 정식 전후 성능 실험은 아닙니다. 지연·비용·정확도 개선 수치는 주장하지 않습니다.</a:t>
             </a:r>
           </a:p>
+          <a:p xmlns:a="http://schemas.openxmlformats.org/drawingml/2006/main">
+            <a:r>
+              <a:t>화면은 과거 Ollama F04 저장 기록을 이용한 수정 후 근거 표시 사례이며 OpenAI 신규 실행 화면이 아닙니다.</a:t>
+            </a:r>
+          </a:p>
         </p:txBody>
       </p:sp>
       <p:sp>
@@ -1004,17 +989,12 @@
           <a:lstStyle xmlns:a="http://schemas.openxmlformats.org/drawingml/2006/main"/>
           <a:p xmlns:a="http://schemas.openxmlformats.org/drawingml/2006/main">
             <a:r>
-              <a:t>[부록 · 5분 본 발표에서는 넘기지 않습니다]</a:t>
+              <a:t>[부록] 오른쪽은 OpenAI V03 실제 저장 결과 보고서 상단 발췌입니다. 8일치2불일치이며 탭절환기와 설치 구분의 변경 미반영을 확인했습니다. 보고서를 열 때 모델을 다시 부르거나 저장값을 바꾸지 않습니다. 브라우저 인쇄·PDF 저장 기능이 있지만 이번 OpenAI 기록의 인쇄 저장 실험은 하지 않았습니다. 과거 V03 Chrome9쪽 인쇄 시험은 Ollama 기록으로 별도 표기합니다.</a:t>
             </a:r>
           </a:p>
           <a:p xmlns:a="http://schemas.openxmlformats.org/drawingml/2006/main">
             <a:r>
-              <a:t>마지막으로 담당자가 결과와 원문을 확인하면 회의용 보고서를 열 수 있습니다. 저장된 판정과 인용을 그대로 보여주며 모델을 다시 부르거나 원본 기록을 바꾸지 않습니다. V03 기록을 크롬에서 아홉 쪽 PDF로 저장했고, 원문 인용 스무 개와 저장 파일 스물두 개가 유지되는 것을 확인했습니다. 이 서비스가 제공하는 가치는 여러 문서의 차이와 근거를 한 흐름에서 확인하도록 돕는 것입니다. 설계 승인과 최종 판단은 담당자에게 남겼습니다. 감사합니다.</a:t>
-            </a:r>
-          </a:p>
-          <a:p xmlns:a="http://schemas.openxmlformats.org/drawingml/2006/main">
-            <a:r>
-              <a:t>출처: report.py; docs/meeting-report.md. 이미지: output/meeting-report-preview.png. 공개 저장소: https://github.com/seogdo/transformer-spec-review</a:t>
+              <a:t>출처: report.py; docs/meeting-report.md; reports/openai-validation-20261021.json; output/openai-v03-result.png.</a:t>
             </a:r>
           </a:p>
         </p:txBody>
@@ -1190,6 +1170,11 @@
           <a:p xmlns:a="http://schemas.openxmlformats.org/drawingml/2006/main">
             <a:r>
               <a:t>출처: README.md; extraction_agent.py; web_app.py; docs/publication.md.</a:t>
+            </a:r>
+          </a:p>
+          <a:p xmlns:a="http://schemas.openxmlformats.org/drawingml/2006/main">
+            <a:r>
+              <a:t>최종 실행 제공업체는 OpenAI API·gpt-4o-mini입니다. 실제 API6회 완료는 세 가상 사례의 동작 확인이며 AI 품질 우위를 의미하지 않습니다. Ollama는 선택 가능한 별도 실행 방식이고 F04의 기존 비교는 해당 과거 기록입니다.</a:t>
             </a:r>
           </a:p>
         </p:txBody>
@@ -1399,17 +1384,17 @@
           <a:lstStyle xmlns:a="http://schemas.openxmlformats.org/drawingml/2006/main"/>
           <a:p xmlns:a="http://schemas.openxmlformats.org/drawingml/2006/main">
             <a:r>
-              <a:t>[0:50–2:00 / 본 발표 4장] 이 화면은 직접 만든 가상 문서로 사전에 실제 실행한 결과입니다. 변경 합의서의 팬 전원 요구는 440 V인데 내부 인계표에는 380 V가 남아 있습니다. 결과는 아홉 항목 일치와 한 항목 불일치였습니다. 문서명, 페이지, 양쪽 원문을 함께 확인하고 검토 기록을 보관합니다. 회의용 보고서 기능은 부록에 있습니다.</a:t>
+              <a:t>[0:50–2:00 / 본 발표 4장] 직접 만든 가상 V01 문서로 OpenAI의 gpt-4o-mini를 실제 호출한 결과입니다. 두 요청이 완료됐고 제안된 21개 값이 원문 검증을 통과했습니다. 팬 전원 요구 440 V와 인계값 380 V의 차이를 코드가 비교해 9일치·1불일치로 표시했습니다. 오른쪽은 실제 저장된 회의용 보고서 상단 발췌이고 왼쪽은 같은 기록의 핵심 값입니다.</a:t>
             </a:r>
           </a:p>
           <a:p xmlns:a="http://schemas.openxmlformats.org/drawingml/2006/main">
             <a:r>
-              <a:t>[1:25부터 같은 화면 유지] Python 자동 검사 385개와 화면 모의 검사 65개를 통과했지만 실제 회사 문서의 AI 정확도는 아닙니다. 구현하면서 답을 만드는 것만큼 근거를 연결하고 애매한 값을 보류하는 과정이 중요하다는 점을 확인했습니다. 지정 형식의 가상 텍스트 PDF를 지원하며 다음에는 독립 문서 평가와 검색 방식·처리 지연 비교가 필요합니다. 설계 승인과 안전 판단은 수행하지 않습니다.</a:t>
+              <a:t>Python 자동 검사 444개와 화면 모의 검사 71개는 코드 검증이며 현업 AI 정확도는 아닙니다. 근거 연결과 불명확한 값의 보류가 중요했습니다. 현재는 지정 형식의 가상 텍스트 PDF만 지원하고 외부 전송·과금에 동의한 자료만 사용합니다. 후속 과제는 독립 문서 평가와 검색 방식·비용·지연 비교입니다. 설계 승인은 수행하지 않습니다.</a:t>
             </a:r>
           </a:p>
           <a:p xmlns:a="http://schemas.openxmlformats.org/drawingml/2006/main">
             <a:r>
-              <a:t>2:00에 반드시 다음 코드 설명으로 전환합니다. 실시간 AI 추출 대기는 5분에 포함하지 않습니다.</a:t>
+              <a:t>2:00에 코드 설명으로 전환합니다. 출처: reports/openai-validation-20261021.json; output/openai-v01-result.png. 실행 코드 887da6e. 실시간 AI 대기는 본 발표에서 제외합니다.</a:t>
             </a:r>
           </a:p>
         </p:txBody>
@@ -1479,12 +1464,12 @@
           <a:lstStyle xmlns:a="http://schemas.openxmlformats.org/drawingml/2006/main"/>
           <a:p xmlns:a="http://schemas.openxmlformats.org/drawingml/2006/main">
             <a:r>
-              <a:t>[2:00–2:45 / 본 발표 5장] extract_upload에서 첫 모델 호출로 검색 계획을 받고 Python이 내부 검색 함수를 실행합니다. 근거가 있으면 두 번째 호출로 값을 제안받고 검증합니다. 근거가 없으면 두 번째 호출을 생략합니다. 추출 작업 한 번은 최대 2회, 전체 90초 예산이며 시간 초과는 실패 처리합니다. 이 순서는 직접 구현한 Python 제어 흐름이지 LangGraph 실행 그래프가 아닙니다. Multi-Agent·MCP·LangGraph·LangSmith는 미사용입니다. MCP 연결 대신 내부 검색 함수를 직접 호출했습니다. 별도 AI 구조 확인 버튼은 추가 모델 요청 경로입니다.</a:t>
+              <a:t>[2:00–2:45 / 본 발표 5장] extract_upload에서 서버 시작 설정에 맞는 OpenAI 요청 함수를 선택합니다. 첫 호출로 검색 계획을 받고 Python이 내부 검색을 실행합니다. 근거가 있으면 두 번째 호출로 값을 제안받고 원문과 검증하며 없으면 생략합니다. 최대 2회와 전체 90초 예산을 검사하고 다른 제공업체로 자동 전환하지 않습니다. 직접 작성한 Python 제어 흐름이며 Multi-Agent·MCP·LangGraph·LangSmith는 미사용입니다. 별도 AI 구조 확인 버튼은 추가 모델 요청 경로입니다.</a:t>
             </a:r>
           </a:p>
           <a:p xmlns:a="http://schemas.openxmlformats.org/drawingml/2006/main">
             <a:r>
-              <a:t>실제 코드: extraction_agent.py 573·593·599–604·613·621·623·632·672행. 표는 실행 순서를 설명한 요약이며 실행 로그나 프레임워크 그래프 화면이 아닙니다. 정형 모드는 AI 단계를 거치지 않습니다.</a:t>
+              <a:t>실제 발췌 extraction_agent.py607–612행, 요청 선택600행, 실제 요청614행, 검색 계획624행, 검색632행, 추출643행, 거절684행. OpenAI 연결은 llm_backend.py199행입니다. 서버 측 키만 사용하고 화면·보고서에 키를 포함하지 않습니다. 정형 모드는 AI 단계를 거치지 않습니다.</a:t>
             </a:r>
           </a:p>
         </p:txBody>
@@ -1554,12 +1539,12 @@
           <a:lstStyle xmlns:a="http://schemas.openxmlformats.org/drawingml/2006/main"/>
           <a:p xmlns:a="http://schemas.openxmlformats.org/drawingml/2006/main">
             <a:r>
-              <a:t>[2:45–3:30 / 본 발표 6장] _search_documents의 입력은 문서 ID, 검토 항목과 검색어입니다. 지정 별칭으로 찾은 원문에 검색어 포함 점수를 매기고 페이지와 위치 순으로 정렬합니다. 검색 요청별 상위 두 개를 문자 예산 안에서 반환하며 문서 ID, 페이지, 인용문을 보존합니다. 반환한 근거는 다음 AI 추출 요청에 전달합니다. 이 부분이 검색 기반 생성 경로이며 임베딩 벡터 검색은 아닙니다. 검색에서 놓친 정보까지 알아낸다고 보장하지 않습니다.</a:t>
+              <a:t>[2:45–3:30 / 본 발표 6장] _search_documents는 문서 ID·항목·검색어를 받습니다. 지정 별칭으로 찾은 원문에 검색어 포함 점수를 매기고 페이지와 위치 순으로 정렬합니다. 요청별 상위 두 근거를 문자 예산 안에서 반환하고 문서 ID·페이지·인용문을 보존합니다. 그 근거를 다음 AI 추출 요청에 전달하는 키워드 기반 RAG입니다. 임베딩·벡터 DB는 쓰지 않았고 검색에서 놓친 정보까지 알아낸다고 보장하지 않습니다.</a:t>
             </a:r>
           </a:p>
           <a:p xmlns:a="http://schemas.openxmlformats.org/drawingml/2006/main">
             <a:r>
-              <a:t>실제 발췌 extraction_agent.py 314–322행. 전체 검색 300행, 결과 필드 구성 323–325행, 두 번째 AI 요청의 검색 결과 전달 654행입니다. 공통 들여쓰기만 제거했습니다.</a:t>
+              <a:t>실제 발췌 extraction_agent.py315–323행. 함수301행, 근거 필드324–326행, 다음 호출의 근거 전달665행. 공통 들여쓰기만 제거했습니다.</a:t>
             </a:r>
           </a:p>
         </p:txBody>
@@ -1629,12 +1614,12 @@
           <a:lstStyle xmlns:a="http://schemas.openxmlformats.org/drawingml/2006/main"/>
           <a:p xmlns:a="http://schemas.openxmlformats.org/drawingml/2006/main">
             <a:r>
-              <a:t>[3:30–4:15 / 본 발표 7장] _validate_proposal은 AI 인용이 실제 페이지와 검색 결과에 있는지 확인합니다. 화면의 수치 분기에서는 원문과 인용에 같은 값과 단위가 있는지, 해당 항목명에 직접 연결되는지를 검사합니다. 숫자가 문서 어딘가에 있다는 이유만으로 채택하지 않습니다. 미확정이나 부정 문맥, 여러 값과 조건이 있으면 거절 이유를 남기고 보류합니다. 확인되지 않은 값을 코드가 대신 만들어 넣지는 않습니다.</a:t>
+              <a:t>[3:30–4:15 / 본 발표 7장] _validate_proposal은 인용이 실제 페이지와 검색 결과에 있는지 검사합니다. 화면의 수치 분기에서는 원문·인용의 값과 단위, 해당 항목명에 직접 연결되는지를 확인합니다. 숫자가 문서 어딘가에 있다는 이유만으로 채택하지 않습니다. 미확정·부정·중복·조건 충돌이면 거절 이유를 남기고 보류합니다. V02 미기재 주파수처럼 확인되지 않은 값을 코드가 대신 채우지 않습니다.</a:t>
             </a:r>
           </a:p>
           <a:p xmlns:a="http://schemas.openxmlformats.org/drawingml/2006/main">
             <a:r>
-              <a:t>실제 발췌 extraction_agent.py 544–551행. 전체 검증 497행, 보류 처리 672행입니다. 공통 들여쓰기만 제거했습니다.</a:t>
+              <a:t>실제 발췌 extraction_agent.py545–552행, 함수498행, 거절된 제안 보류684행. 공통 들여쓰기만 제거했습니다.</a:t>
             </a:r>
           </a:p>
         </p:txBody>
@@ -1779,12 +1764,12 @@
           <a:lstStyle xmlns:a="http://schemas.openxmlformats.org/drawingml/2006/main"/>
           <a:p xmlns:a="http://schemas.openxmlformats.org/drawingml/2006/main">
             <a:r>
-              <a:t>[4:40–5:00 / 본 발표 9장] request_fn에 고정 응답 함수를 넣으면 실제 AI 없이 같은 조건을 반복 검사할 수 있습니다. 예시 검사는 두 번의 요청과 입력 보존을 확인합니다. PDF 처리, 추출, 비교와 API를 모듈로 나누고 불확실한 값은 담당자에게 남기도록 구현했습니다. 감사합니다.</a:t>
+              <a:t>[4:40–5:00 / 본 발표 9장] request_fn에 고정 응답을 넣으면 실제 API 없이 같은 조건을 반복 검사할 수 있습니다. 주입 실행은 실제 OpenAI 호출로 표시하지 않습니다. 예시 검사는 두 요청과 입력 보존을 확인합니다. PDF·추출·비교·연결 모듈을 분리했고 불확실한 값은 담당자에게 남겼습니다. 감사합니다.</a:t>
             </a:r>
           </a:p>
           <a:p xmlns:a="http://schemas.openxmlformats.org/drawingml/2006/main">
             <a:r>
-              <a:t>실제 발췌 tests/test_extraction_agent.py 86–94행. 주입 지점 extraction_agent.py 573·593행입니다. 이 예시는 정상 경로 2회 호출을 확인하는 모의 시험이며 모델 정확도가 아닙니다. 이후는 질문·보충용 부록입니다.</a:t>
+              <a:t>실제 발췌 tests/test_extraction_agent.py128–136행. 주입 지점 extraction_agent.py600행, 주입 실행 구분 테스트102행. 모의 시험은 모델 정확도를 측정하지 않습니다. 이후 9장은 질의응답용 부록입니다.</a:t>
             </a:r>
           </a:p>
         </p:txBody>
@@ -4227,12 +4212,12 @@
   </p:cSld>
   <p:clrMap bg1="lt1" tx1="dk1" bg2="lt2" tx2="dk2" accent1="accent1" accent2="accent2" accent3="accent3" accent4="accent4" accent5="accent5" accent6="accent6" hlink="hlink" folHlink="folHlink"/>
   <p:sldLayoutIdLst>
-    <p:sldLayoutId xmlns:r="http://schemas.openxmlformats.org/officeDocument/2006/relationships" id="2147483649" r:id="R7cd3c6e0ee374621"/>
-    <p:sldLayoutId xmlns:r="http://schemas.openxmlformats.org/officeDocument/2006/relationships" id="2147483650" r:id="R29ebc3afeb234e44"/>
-    <p:sldLayoutId xmlns:r="http://schemas.openxmlformats.org/officeDocument/2006/relationships" id="2147483651" r:id="R947255428c24431f"/>
-    <p:sldLayoutId xmlns:r="http://schemas.openxmlformats.org/officeDocument/2006/relationships" id="2147483652" r:id="Rd5961f54179e4a25"/>
-    <p:sldLayoutId xmlns:r="http://schemas.openxmlformats.org/officeDocument/2006/relationships" id="2147483653" r:id="R0e94ebba658049d6"/>
-    <p:sldLayoutId xmlns:r="http://schemas.openxmlformats.org/officeDocument/2006/relationships" id="2147483654" r:id="R0e638cd72c4942d9"/>
+    <p:sldLayoutId xmlns:r="http://schemas.openxmlformats.org/officeDocument/2006/relationships" id="2147483649" r:id="Rf87fbf0c311c4b6d"/>
+    <p:sldLayoutId xmlns:r="http://schemas.openxmlformats.org/officeDocument/2006/relationships" id="2147483650" r:id="R4402ac0bdd7b4f1f"/>
+    <p:sldLayoutId xmlns:r="http://schemas.openxmlformats.org/officeDocument/2006/relationships" id="2147483651" r:id="R0220ee43c48e4fb0"/>
+    <p:sldLayoutId xmlns:r="http://schemas.openxmlformats.org/officeDocument/2006/relationships" id="2147483652" r:id="R00ca359eef0e4222"/>
+    <p:sldLayoutId xmlns:r="http://schemas.openxmlformats.org/officeDocument/2006/relationships" id="2147483653" r:id="R854c610036b3404b"/>
+    <p:sldLayoutId xmlns:r="http://schemas.openxmlformats.org/officeDocument/2006/relationships" id="2147483654" r:id="R53f8c1d817054ddc"/>
   </p:sldLayoutIdLst>
   <p:txStyles>
     <p:titleStyle>
@@ -5349,6 +5334,7 @@
               </a:defRPr>
             </a:defPPr>
             <a:lvl1pPr>
+              <a:buNone/>
               <a:defRPr sz="1725" b="0">
                 <a:solidFill>
                   <a:srgbClr val="B7CFC9"/>
@@ -5359,6 +5345,7 @@
               </a:defRPr>
             </a:lvl1pPr>
             <a:lvl2pPr>
+              <a:buNone/>
               <a:defRPr sz="1725" b="0">
                 <a:solidFill>
                   <a:srgbClr val="B7CFC9"/>
@@ -5369,6 +5356,7 @@
               </a:defRPr>
             </a:lvl2pPr>
             <a:lvl3pPr>
+              <a:buNone/>
               <a:defRPr sz="1725" b="0">
                 <a:solidFill>
                   <a:srgbClr val="B7CFC9"/>
@@ -5379,6 +5367,7 @@
               </a:defRPr>
             </a:lvl3pPr>
             <a:lvl4pPr>
+              <a:buNone/>
               <a:defRPr sz="1725" b="0">
                 <a:solidFill>
                   <a:srgbClr val="B7CFC9"/>
@@ -5389,6 +5378,7 @@
               </a:defRPr>
             </a:lvl4pPr>
             <a:lvl5pPr>
+              <a:buNone/>
               <a:defRPr sz="1725" b="0">
                 <a:solidFill>
                   <a:srgbClr val="B7CFC9"/>
@@ -5399,6 +5389,7 @@
               </a:defRPr>
             </a:lvl5pPr>
             <a:lvl6pPr>
+              <a:buNone/>
               <a:defRPr sz="1725" b="0">
                 <a:solidFill>
                   <a:srgbClr val="B7CFC9"/>
@@ -5409,6 +5400,7 @@
               </a:defRPr>
             </a:lvl6pPr>
             <a:lvl7pPr>
+              <a:buNone/>
               <a:defRPr sz="1725" b="0">
                 <a:solidFill>
                   <a:srgbClr val="B7CFC9"/>
@@ -5419,6 +5411,7 @@
               </a:defRPr>
             </a:lvl7pPr>
             <a:lvl8pPr>
+              <a:buNone/>
               <a:defRPr sz="1725" b="0">
                 <a:solidFill>
                   <a:srgbClr val="B7CFC9"/>
@@ -5429,6 +5422,7 @@
               </a:defRPr>
             </a:lvl8pPr>
             <a:lvl9pPr>
+              <a:buNone/>
               <a:defRPr sz="1725" b="0">
                 <a:solidFill>
                   <a:srgbClr val="B7CFC9"/>
@@ -5441,6 +5435,7 @@
           </a:lstStyle>
           <a:p xmlns:a="http://schemas.openxmlformats.org/drawingml/2006/main">
             <a:pPr>
+              <a:buNone/>
               <a:defRPr sz="1725" b="0">
                 <a:solidFill>
                   <a:srgbClr val="B7CFC9"/>
@@ -7520,7 +7515,7 @@
           <p:cNvPr id="3" name="">
             <a:extLst xmlns:a="http://schemas.openxmlformats.org/drawingml/2006/main">
               <a:ext uri="{FF2B5EF4-FFF2-40B4-BE49-F238E27FC236}">
-                <a16:creationId xmlns:a16="http://schemas.microsoft.com/office/drawing/2014/main" id="{11F69E9E-F9CA-4075-B281-8A3C49FCA940}"/>
+                <a16:creationId xmlns:a16="http://schemas.microsoft.com/office/drawing/2014/main" id="{7383FED1-AB08-4B7B-8900-126BC5B4EDCF}"/>
               </a:ext>
             </a:extLst>
           </p:cNvPr>
@@ -8315,7 +8310,7 @@
                 <a:ea typeface="Arial Unicode MS"/>
                 <a:cs typeface="Arial Unicode MS"/>
               </a:rPr>
-              <a:t>부록: 확인한 동작과 검증 범위</a:t>
+              <a:t>부록: OpenAI 실제 실행과 검증 범위</a:t>
             </a:r>
           </a:p>
         </p:txBody>
@@ -8493,7 +8488,7 @@
           <p:cNvPr id="3" name="">
             <a:extLst xmlns:a="http://schemas.openxmlformats.org/drawingml/2006/main">
               <a:ext uri="{FF2B5EF4-FFF2-40B4-BE49-F238E27FC236}">
-                <a16:creationId xmlns:a16="http://schemas.microsoft.com/office/drawing/2014/main" id="{C84E2823-35FE-445B-9191-51042F233CC0}"/>
+                <a16:creationId xmlns:a16="http://schemas.microsoft.com/office/drawing/2014/main" id="{4C935696-14A1-44E3-9AC3-EDBCE62CE3D7}"/>
               </a:ext>
             </a:extLst>
           </p:cNvPr>
@@ -9464,51 +9459,7 @@
                 <a:ea typeface="Arial Unicode MS"/>
                 <a:cs typeface="Arial Unicode MS"/>
               </a:rPr>
-              <a:t>자동 검사 </a:t>
-            </a:r>
-            <a:r>
-              <a:rPr sz="2325" b="1">
-                <a:solidFill>
-                  <a:srgbClr val="15796D"/>
-                </a:solidFill>
-                <a:latin typeface="Arial Unicode MS"/>
-                <a:ea typeface="Arial Unicode MS"/>
-                <a:cs typeface="Arial Unicode MS"/>
-              </a:rPr>
-              <a:t>385</a:t>
-            </a:r>
-            <a:r>
-              <a:rPr sz="2325" b="1">
-                <a:solidFill>
-                  <a:srgbClr val="15796D"/>
-                </a:solidFill>
-                <a:latin typeface="Arial Unicode MS"/>
-                <a:ea typeface="Arial Unicode MS"/>
-                <a:cs typeface="Arial Unicode MS"/>
-              </a:rPr>
-              <a:t>개 통과     화면 모의 검사 </a:t>
-            </a:r>
-            <a:r>
-              <a:rPr sz="2325" b="1">
-                <a:solidFill>
-                  <a:srgbClr val="15796D"/>
-                </a:solidFill>
-                <a:latin typeface="Arial Unicode MS"/>
-                <a:ea typeface="Arial Unicode MS"/>
-                <a:cs typeface="Arial Unicode MS"/>
-              </a:rPr>
-              <a:t>65</a:t>
-            </a:r>
-            <a:r>
-              <a:rPr sz="2325" b="1">
-                <a:solidFill>
-                  <a:srgbClr val="15796D"/>
-                </a:solidFill>
-                <a:latin typeface="Arial Unicode MS"/>
-                <a:ea typeface="Arial Unicode MS"/>
-                <a:cs typeface="Arial Unicode MS"/>
-              </a:rPr>
-              <a:t>개 통과</a:t>
+              <a:t>Python 444개 통과     화면 모의 검사 71개 통과</a:t>
             </a:r>
           </a:p>
         </p:txBody>
@@ -9676,7 +9627,7 @@
                 <a:ea typeface="Arial Unicode MS"/>
                 <a:cs typeface="Arial Unicode MS"/>
               </a:rPr>
-              <a:t>직접 만든 가상 사례의 동작 확인입니다.</a:t>
+              <a:t>2026-10-21 · gpt-4o-mini · 실제 API 6/6회 완료</a:t>
             </a:r>
           </a:p>
           <a:p xmlns:a="http://schemas.openxmlformats.org/drawingml/2006/main">
@@ -9700,7 +9651,7 @@
                 <a:ea typeface="Arial Unicode MS"/>
                 <a:cs typeface="Arial Unicode MS"/>
               </a:rPr>
-              <a:t>실제 회사 문서의 정확도와 시간 절감률은 측정하지 않았습니다.</a:t>
+              <a:t>직접 만든 3개 사례의 확인이며 현업 정확도·시간 절감률은 미측정입니다.</a:t>
             </a:r>
           </a:p>
         </p:txBody>
@@ -10075,7 +10026,7 @@
           <p:cNvPr id="3" name="">
             <a:extLst xmlns:a="http://schemas.openxmlformats.org/drawingml/2006/main">
               <a:ext uri="{FF2B5EF4-FFF2-40B4-BE49-F238E27FC236}">
-                <a16:creationId xmlns:a16="http://schemas.microsoft.com/office/drawing/2014/main" id="{DC0260B9-001F-4DA0-84D3-9C569FCDDB58}"/>
+                <a16:creationId xmlns:a16="http://schemas.microsoft.com/office/drawing/2014/main" id="{AF8CC578-602B-4229-B785-A079F1BC5118}"/>
               </a:ext>
             </a:extLst>
           </p:cNvPr>
@@ -10476,7 +10427,7 @@
                           <a:ea typeface="Arial Unicode MS"/>
                           <a:cs typeface="Arial Unicode MS"/>
                         </a:rPr>
-                        <a:t>로컬 모델과 키워드 검색</a:t>
+                        <a:t>API 선택과 키워드 검색</a:t>
                       </a:r>
                     </a:p>
                   </a:txBody>
@@ -10518,7 +10469,7 @@
                           <a:ea typeface="Arial Unicode MS"/>
                           <a:cs typeface="Arial Unicode MS"/>
                         </a:rPr>
-                        <a:t>표현의 범위와 실행 환경에 영향</a:t>
+                        <a:t>외부 전송·비용·검색 표현 제한</a:t>
                       </a:r>
                     </a:p>
                   </a:txBody>
@@ -11143,7 +11094,7 @@
           <p:cNvPr id="3" name="">
             <a:extLst xmlns:a="http://schemas.openxmlformats.org/drawingml/2006/main">
               <a:ext uri="{FF2B5EF4-FFF2-40B4-BE49-F238E27FC236}">
-                <a16:creationId xmlns:a16="http://schemas.microsoft.com/office/drawing/2014/main" id="{A166D1EC-FB69-4F6A-A135-03C9CD8FA81E}"/>
+                <a16:creationId xmlns:a16="http://schemas.microsoft.com/office/drawing/2014/main" id="{F4376342-3670-48B8-8110-126ABF82545C}"/>
               </a:ext>
             </a:extLst>
           </p:cNvPr>
@@ -11812,7 +11763,7 @@
                 <a:ea typeface="Arial Unicode MS"/>
                 <a:cs typeface="Arial Unicode MS"/>
               </a:rPr>
-              <a:t>동일 PDF·당시 모델 응답 2개를 사용했습니다.</a:t>
+              <a:t>과거 Ollama F04의 동일 PDF·저장 응답 2개를 사용했습니다.</a:t>
             </a:r>
           </a:p>
           <a:p xmlns:a="http://schemas.openxmlformats.org/drawingml/2006/main">
@@ -11836,7 +11787,7 @@
                 <a:ea typeface="Arial Unicode MS"/>
                 <a:cs typeface="Arial Unicode MS"/>
               </a:rPr>
-              <a:t>현재 코드는 오프라인 재생했으며, 실제 모델 호출은 0회입니다.</a:t>
+              <a:t>당시 수정 코드로 오프라인 재생했으며 신규 모델 호출은 0회입니다.</a:t>
             </a:r>
           </a:p>
         </p:txBody>
@@ -12081,6 +12032,7 @@
               </a:defRPr>
             </a:defPPr>
             <a:lvl1pPr>
+              <a:buNone/>
               <a:defRPr sz="3225" b="1">
                 <a:solidFill>
                   <a:srgbClr val="173C46"/>
@@ -12091,6 +12043,7 @@
               </a:defRPr>
             </a:lvl1pPr>
             <a:lvl2pPr>
+              <a:buNone/>
               <a:defRPr sz="3225" b="1">
                 <a:solidFill>
                   <a:srgbClr val="173C46"/>
@@ -12101,6 +12054,7 @@
               </a:defRPr>
             </a:lvl2pPr>
             <a:lvl3pPr>
+              <a:buNone/>
               <a:defRPr sz="3225" b="1">
                 <a:solidFill>
                   <a:srgbClr val="173C46"/>
@@ -12111,6 +12065,7 @@
               </a:defRPr>
             </a:lvl3pPr>
             <a:lvl4pPr>
+              <a:buNone/>
               <a:defRPr sz="3225" b="1">
                 <a:solidFill>
                   <a:srgbClr val="173C46"/>
@@ -12121,6 +12076,7 @@
               </a:defRPr>
             </a:lvl4pPr>
             <a:lvl5pPr>
+              <a:buNone/>
               <a:defRPr sz="3225" b="1">
                 <a:solidFill>
                   <a:srgbClr val="173C46"/>
@@ -12131,6 +12087,7 @@
               </a:defRPr>
             </a:lvl5pPr>
             <a:lvl6pPr>
+              <a:buNone/>
               <a:defRPr sz="3225" b="1">
                 <a:solidFill>
                   <a:srgbClr val="173C46"/>
@@ -12141,6 +12098,7 @@
               </a:defRPr>
             </a:lvl6pPr>
             <a:lvl7pPr>
+              <a:buNone/>
               <a:defRPr sz="3225" b="1">
                 <a:solidFill>
                   <a:srgbClr val="173C46"/>
@@ -12151,6 +12109,7 @@
               </a:defRPr>
             </a:lvl7pPr>
             <a:lvl8pPr>
+              <a:buNone/>
               <a:defRPr sz="3225" b="1">
                 <a:solidFill>
                   <a:srgbClr val="173C46"/>
@@ -12161,6 +12120,7 @@
               </a:defRPr>
             </a:lvl8pPr>
             <a:lvl9pPr>
+              <a:buNone/>
               <a:defRPr sz="3225" b="1">
                 <a:solidFill>
                   <a:srgbClr val="173C46"/>
@@ -12173,6 +12133,7 @@
           </a:lstStyle>
           <a:p xmlns:a="http://schemas.openxmlformats.org/drawingml/2006/main">
             <a:pPr>
+              <a:buNone/>
               <a:defRPr sz="3225" b="1">
                 <a:solidFill>
                   <a:srgbClr val="173C46"/>
@@ -12239,6 +12200,7 @@
               </a:defRPr>
             </a:defPPr>
             <a:lvl1pPr>
+              <a:buNone/>
               <a:defRPr sz="1350" b="0">
                 <a:solidFill>
                   <a:srgbClr val="53676D"/>
@@ -12249,6 +12211,7 @@
               </a:defRPr>
             </a:lvl1pPr>
             <a:lvl2pPr>
+              <a:buNone/>
               <a:defRPr sz="1350" b="0">
                 <a:solidFill>
                   <a:srgbClr val="53676D"/>
@@ -12259,6 +12222,7 @@
               </a:defRPr>
             </a:lvl2pPr>
             <a:lvl3pPr>
+              <a:buNone/>
               <a:defRPr sz="1350" b="0">
                 <a:solidFill>
                   <a:srgbClr val="53676D"/>
@@ -12269,6 +12233,7 @@
               </a:defRPr>
             </a:lvl3pPr>
             <a:lvl4pPr>
+              <a:buNone/>
               <a:defRPr sz="1350" b="0">
                 <a:solidFill>
                   <a:srgbClr val="53676D"/>
@@ -12279,6 +12244,7 @@
               </a:defRPr>
             </a:lvl4pPr>
             <a:lvl5pPr>
+              <a:buNone/>
               <a:defRPr sz="1350" b="0">
                 <a:solidFill>
                   <a:srgbClr val="53676D"/>
@@ -12289,6 +12255,7 @@
               </a:defRPr>
             </a:lvl5pPr>
             <a:lvl6pPr>
+              <a:buNone/>
               <a:defRPr sz="1350" b="0">
                 <a:solidFill>
                   <a:srgbClr val="53676D"/>
@@ -12299,6 +12266,7 @@
               </a:defRPr>
             </a:lvl6pPr>
             <a:lvl7pPr>
+              <a:buNone/>
               <a:defRPr sz="1350" b="0">
                 <a:solidFill>
                   <a:srgbClr val="53676D"/>
@@ -12309,6 +12277,7 @@
               </a:defRPr>
             </a:lvl7pPr>
             <a:lvl8pPr>
+              <a:buNone/>
               <a:defRPr sz="1350" b="0">
                 <a:solidFill>
                   <a:srgbClr val="53676D"/>
@@ -12319,6 +12288,7 @@
               </a:defRPr>
             </a:lvl8pPr>
             <a:lvl9pPr>
+              <a:buNone/>
               <a:defRPr sz="1350" b="0">
                 <a:solidFill>
                   <a:srgbClr val="53676D"/>
@@ -12331,6 +12301,7 @@
           </a:lstStyle>
           <a:p xmlns:a="http://schemas.openxmlformats.org/drawingml/2006/main">
             <a:pPr>
+              <a:buNone/>
               <a:defRPr sz="1350" b="0">
                 <a:solidFill>
                   <a:srgbClr val="53676D"/>
@@ -12389,6 +12360,7 @@
               </a:defRPr>
             </a:defPPr>
             <a:lvl1pPr>
+              <a:buNone/>
               <a:defRPr sz="2400" b="1">
                 <a:solidFill>
                   <a:srgbClr val="15796D"/>
@@ -12399,6 +12371,7 @@
               </a:defRPr>
             </a:lvl1pPr>
             <a:lvl2pPr>
+              <a:buNone/>
               <a:defRPr sz="2400" b="1">
                 <a:solidFill>
                   <a:srgbClr val="15796D"/>
@@ -12409,6 +12382,7 @@
               </a:defRPr>
             </a:lvl2pPr>
             <a:lvl3pPr>
+              <a:buNone/>
               <a:defRPr sz="2400" b="1">
                 <a:solidFill>
                   <a:srgbClr val="15796D"/>
@@ -12419,6 +12393,7 @@
               </a:defRPr>
             </a:lvl3pPr>
             <a:lvl4pPr>
+              <a:buNone/>
               <a:defRPr sz="2400" b="1">
                 <a:solidFill>
                   <a:srgbClr val="15796D"/>
@@ -12429,6 +12404,7 @@
               </a:defRPr>
             </a:lvl4pPr>
             <a:lvl5pPr>
+              <a:buNone/>
               <a:defRPr sz="2400" b="1">
                 <a:solidFill>
                   <a:srgbClr val="15796D"/>
@@ -12439,6 +12415,7 @@
               </a:defRPr>
             </a:lvl5pPr>
             <a:lvl6pPr>
+              <a:buNone/>
               <a:defRPr sz="2400" b="1">
                 <a:solidFill>
                   <a:srgbClr val="15796D"/>
@@ -12449,6 +12426,7 @@
               </a:defRPr>
             </a:lvl6pPr>
             <a:lvl7pPr>
+              <a:buNone/>
               <a:defRPr sz="2400" b="1">
                 <a:solidFill>
                   <a:srgbClr val="15796D"/>
@@ -12459,6 +12437,7 @@
               </a:defRPr>
             </a:lvl7pPr>
             <a:lvl8pPr>
+              <a:buNone/>
               <a:defRPr sz="2400" b="1">
                 <a:solidFill>
                   <a:srgbClr val="15796D"/>
@@ -12469,6 +12448,7 @@
               </a:defRPr>
             </a:lvl8pPr>
             <a:lvl9pPr>
+              <a:buNone/>
               <a:defRPr sz="2400" b="1">
                 <a:solidFill>
                   <a:srgbClr val="15796D"/>
@@ -12481,6 +12461,7 @@
           </a:lstStyle>
           <a:p xmlns:a="http://schemas.openxmlformats.org/drawingml/2006/main">
             <a:pPr>
+              <a:buNone/>
               <a:defRPr sz="2400" b="1">
                 <a:solidFill>
                   <a:srgbClr val="15796D"/>
@@ -12504,6 +12485,7 @@
           </a:p>
           <a:p xmlns:a="http://schemas.openxmlformats.org/drawingml/2006/main">
             <a:pPr>
+              <a:buNone/>
               <a:defRPr sz="2400" b="1">
                 <a:solidFill>
                   <a:srgbClr val="15796D"/>
@@ -12570,6 +12552,7 @@
               </a:defRPr>
             </a:defPPr>
             <a:lvl1pPr>
+              <a:buNone/>
               <a:defRPr sz="1875" b="0">
                 <a:solidFill>
                   <a:srgbClr val="173C46"/>
@@ -12580,6 +12563,7 @@
               </a:defRPr>
             </a:lvl1pPr>
             <a:lvl2pPr>
+              <a:buNone/>
               <a:defRPr sz="1875" b="0">
                 <a:solidFill>
                   <a:srgbClr val="173C46"/>
@@ -12590,6 +12574,7 @@
               </a:defRPr>
             </a:lvl2pPr>
             <a:lvl3pPr>
+              <a:buNone/>
               <a:defRPr sz="1875" b="0">
                 <a:solidFill>
                   <a:srgbClr val="173C46"/>
@@ -12600,6 +12585,7 @@
               </a:defRPr>
             </a:lvl3pPr>
             <a:lvl4pPr>
+              <a:buNone/>
               <a:defRPr sz="1875" b="0">
                 <a:solidFill>
                   <a:srgbClr val="173C46"/>
@@ -12610,6 +12596,7 @@
               </a:defRPr>
             </a:lvl4pPr>
             <a:lvl5pPr>
+              <a:buNone/>
               <a:defRPr sz="1875" b="0">
                 <a:solidFill>
                   <a:srgbClr val="173C46"/>
@@ -12620,6 +12607,7 @@
               </a:defRPr>
             </a:lvl5pPr>
             <a:lvl6pPr>
+              <a:buNone/>
               <a:defRPr sz="1875" b="0">
                 <a:solidFill>
                   <a:srgbClr val="173C46"/>
@@ -12630,6 +12618,7 @@
               </a:defRPr>
             </a:lvl6pPr>
             <a:lvl7pPr>
+              <a:buNone/>
               <a:defRPr sz="1875" b="0">
                 <a:solidFill>
                   <a:srgbClr val="173C46"/>
@@ -12640,6 +12629,7 @@
               </a:defRPr>
             </a:lvl7pPr>
             <a:lvl8pPr>
+              <a:buNone/>
               <a:defRPr sz="1875" b="0">
                 <a:solidFill>
                   <a:srgbClr val="173C46"/>
@@ -12650,6 +12640,7 @@
               </a:defRPr>
             </a:lvl8pPr>
             <a:lvl9pPr>
+              <a:buNone/>
               <a:defRPr sz="1875" b="0">
                 <a:solidFill>
                   <a:srgbClr val="173C46"/>
@@ -12662,6 +12653,7 @@
           </a:lstStyle>
           <a:p xmlns:a="http://schemas.openxmlformats.org/drawingml/2006/main">
             <a:pPr>
+              <a:buNone/>
               <a:defRPr sz="1875" b="0">
                 <a:solidFill>
                   <a:srgbClr val="173C46"/>
@@ -12685,6 +12677,7 @@
           </a:p>
           <a:p xmlns:a="http://schemas.openxmlformats.org/drawingml/2006/main">
             <a:pPr>
+              <a:buNone/>
               <a:defRPr sz="1875" b="0">
                 <a:solidFill>
                   <a:srgbClr val="173C46"/>
@@ -12708,6 +12701,7 @@
           </a:p>
           <a:p xmlns:a="http://schemas.openxmlformats.org/drawingml/2006/main">
             <a:pPr>
+              <a:buNone/>
               <a:defRPr sz="1875" b="0">
                 <a:solidFill>
                   <a:srgbClr val="173C46"/>
@@ -12774,6 +12768,7 @@
               </a:defRPr>
             </a:defPPr>
             <a:lvl1pPr>
+              <a:buNone/>
               <a:defRPr sz="1500" b="0">
                 <a:solidFill>
                   <a:srgbClr val="A54E35"/>
@@ -12784,6 +12779,7 @@
               </a:defRPr>
             </a:lvl1pPr>
             <a:lvl2pPr>
+              <a:buNone/>
               <a:defRPr sz="1500" b="0">
                 <a:solidFill>
                   <a:srgbClr val="A54E35"/>
@@ -12794,6 +12790,7 @@
               </a:defRPr>
             </a:lvl2pPr>
             <a:lvl3pPr>
+              <a:buNone/>
               <a:defRPr sz="1500" b="0">
                 <a:solidFill>
                   <a:srgbClr val="A54E35"/>
@@ -12804,6 +12801,7 @@
               </a:defRPr>
             </a:lvl3pPr>
             <a:lvl4pPr>
+              <a:buNone/>
               <a:defRPr sz="1500" b="0">
                 <a:solidFill>
                   <a:srgbClr val="A54E35"/>
@@ -12814,6 +12812,7 @@
               </a:defRPr>
             </a:lvl4pPr>
             <a:lvl5pPr>
+              <a:buNone/>
               <a:defRPr sz="1500" b="0">
                 <a:solidFill>
                   <a:srgbClr val="A54E35"/>
@@ -12824,6 +12823,7 @@
               </a:defRPr>
             </a:lvl5pPr>
             <a:lvl6pPr>
+              <a:buNone/>
               <a:defRPr sz="1500" b="0">
                 <a:solidFill>
                   <a:srgbClr val="A54E35"/>
@@ -12834,6 +12834,7 @@
               </a:defRPr>
             </a:lvl6pPr>
             <a:lvl7pPr>
+              <a:buNone/>
               <a:defRPr sz="1500" b="0">
                 <a:solidFill>
                   <a:srgbClr val="A54E35"/>
@@ -12844,6 +12845,7 @@
               </a:defRPr>
             </a:lvl7pPr>
             <a:lvl8pPr>
+              <a:buNone/>
               <a:defRPr sz="1500" b="0">
                 <a:solidFill>
                   <a:srgbClr val="A54E35"/>
@@ -12854,6 +12856,7 @@
               </a:defRPr>
             </a:lvl8pPr>
             <a:lvl9pPr>
+              <a:buNone/>
               <a:defRPr sz="1500" b="0">
                 <a:solidFill>
                   <a:srgbClr val="A54E35"/>
@@ -12866,6 +12869,7 @@
           </a:lstStyle>
           <a:p xmlns:a="http://schemas.openxmlformats.org/drawingml/2006/main">
             <a:pPr>
+              <a:buNone/>
               <a:defRPr sz="1500" b="0">
                 <a:solidFill>
                   <a:srgbClr val="A54E35"/>
@@ -12889,6 +12893,7 @@
           </a:p>
           <a:p xmlns:a="http://schemas.openxmlformats.org/drawingml/2006/main">
             <a:pPr>
+              <a:buNone/>
               <a:defRPr sz="1500" b="0">
                 <a:solidFill>
                   <a:srgbClr val="A54E35"/>
@@ -12912,6 +12917,7 @@
           </a:p>
           <a:p xmlns:a="http://schemas.openxmlformats.org/drawingml/2006/main">
             <a:pPr>
+              <a:buNone/>
               <a:defRPr sz="1500" b="0">
                 <a:solidFill>
                   <a:srgbClr val="A54E35"/>
@@ -12935,6 +12941,7 @@
           </a:p>
           <a:p xmlns:a="http://schemas.openxmlformats.org/drawingml/2006/main">
             <a:pPr>
+              <a:buNone/>
               <a:defRPr sz="1500" b="0">
                 <a:solidFill>
                   <a:srgbClr val="A54E35"/>
@@ -12963,7 +12970,7 @@
           <p:cNvPr id="6" name="">
             <a:extLst xmlns:a="http://schemas.openxmlformats.org/drawingml/2006/main">
               <a:ext uri="{FF2B5EF4-FFF2-40B4-BE49-F238E27FC236}">
-                <a16:creationId xmlns:a16="http://schemas.microsoft.com/office/drawing/2014/main" id="{65B564DA-F415-47BB-B432-E75C9F74B310}"/>
+                <a16:creationId xmlns:a16="http://schemas.microsoft.com/office/drawing/2014/main" id="{A2A41CB4-8603-48A4-B3D0-38A4232A567E}"/>
               </a:ext>
             </a:extLst>
           </p:cNvPr>
@@ -12973,7 +12980,7 @@
           <p:nvPr/>
         </p:nvPicPr>
         <p:blipFill>
-          <a:blip xmlns:r="http://schemas.openxmlformats.org/officeDocument/2006/relationships" xmlns:a="http://schemas.openxmlformats.org/drawingml/2006/main" r:embed="Rd0e7fa292181442b"/>
+          <a:blip xmlns:r="http://schemas.openxmlformats.org/officeDocument/2006/relationships" xmlns:a="http://schemas.openxmlformats.org/drawingml/2006/main" r:embed="Rf55cee7ff9784345"/>
           <a:srcRect xmlns:a="http://schemas.openxmlformats.org/drawingml/2006/main" l="3115" t="67834" r="3115" b="19767"/>
           <a:stretch xmlns:a="http://schemas.openxmlformats.org/drawingml/2006/main"/>
         </p:blipFill>
@@ -12992,7 +12999,7 @@
           <p:cNvPr id="7" name="">
             <a:extLst xmlns:a="http://schemas.openxmlformats.org/drawingml/2006/main">
               <a:ext uri="{FF2B5EF4-FFF2-40B4-BE49-F238E27FC236}">
-                <a16:creationId xmlns:a16="http://schemas.microsoft.com/office/drawing/2014/main" id="{4C7CDE77-3315-409C-9804-FEF413D8B4AD}"/>
+                <a16:creationId xmlns:a16="http://schemas.microsoft.com/office/drawing/2014/main" id="{4A378DBD-BA47-4B34-BA97-0AB098F3B3D2}"/>
               </a:ext>
             </a:extLst>
           </p:cNvPr>
@@ -13002,7 +13009,7 @@
           <p:nvPr/>
         </p:nvPicPr>
         <p:blipFill>
-          <a:blip xmlns:r="http://schemas.openxmlformats.org/officeDocument/2006/relationships" xmlns:a="http://schemas.openxmlformats.org/drawingml/2006/main" r:embed="R29e3e3319d80440a"/>
+          <a:blip xmlns:r="http://schemas.openxmlformats.org/officeDocument/2006/relationships" xmlns:a="http://schemas.openxmlformats.org/drawingml/2006/main" r:embed="R2e3dfd60f0f8416b"/>
           <a:srcRect xmlns:a="http://schemas.openxmlformats.org/drawingml/2006/main" l="3115" t="83880" r="3115" b="3866"/>
           <a:stretch xmlns:a="http://schemas.openxmlformats.org/drawingml/2006/main"/>
         </p:blipFill>
@@ -13736,7 +13743,7 @@
                 <a:ea typeface="Arial Unicode MS"/>
                 <a:cs typeface="Arial Unicode MS"/>
               </a:rPr>
-              <a:t>검토 확인 후 보고서 열기</a:t>
+              <a:t>OpenAI V03: 8일치·2불일치</a:t>
             </a:r>
           </a:p>
           <a:p xmlns:a="http://schemas.openxmlformats.org/drawingml/2006/main">
@@ -13760,7 +13767,7 @@
                 <a:ea typeface="Arial Unicode MS"/>
                 <a:cs typeface="Arial Unicode MS"/>
               </a:rPr>
-              <a:t>브라우저에서 인쇄·PDF 저장</a:t>
+              <a:t>저장된 결과를 읽기 전용으로 표시</a:t>
             </a:r>
           </a:p>
           <a:p xmlns:a="http://schemas.openxmlformats.org/drawingml/2006/main">
@@ -13784,7 +13791,7 @@
                 <a:ea typeface="Arial Unicode MS"/>
                 <a:cs typeface="Arial Unicode MS"/>
               </a:rPr>
-              <a:t>저장된 결과와 근거 보존</a:t>
+              <a:t>보고서 열기는 AI 재호출 없음</a:t>
             </a:r>
           </a:p>
         </p:txBody>
@@ -13794,7 +13801,7 @@
           <p:cNvPr id="5" name="">
             <a:extLst xmlns:a="http://schemas.openxmlformats.org/drawingml/2006/main">
               <a:ext uri="{FF2B5EF4-FFF2-40B4-BE49-F238E27FC236}">
-                <a16:creationId xmlns:a16="http://schemas.microsoft.com/office/drawing/2014/main" id="{F9CE3330-7794-4720-B9EE-7096DFC6937F}"/>
+                <a16:creationId xmlns:a16="http://schemas.microsoft.com/office/drawing/2014/main" id="{5855C6AE-099C-4867-A537-092FC7A17E35}"/>
               </a:ext>
             </a:extLst>
           </p:cNvPr>
@@ -13804,13 +13811,14 @@
           <p:nvPr/>
         </p:nvPicPr>
         <p:blipFill>
-          <a:blip xmlns:r="http://schemas.openxmlformats.org/officeDocument/2006/relationships" xmlns:a="http://schemas.openxmlformats.org/drawingml/2006/main" r:embed="R6b27a662aed34c52"/>
+          <a:blip xmlns:r="http://schemas.openxmlformats.org/officeDocument/2006/relationships" xmlns:a="http://schemas.openxmlformats.org/drawingml/2006/main" r:embed="Re4e12ba588c947c3"/>
+          <a:srcRect xmlns:a="http://schemas.openxmlformats.org/drawingml/2006/main" l="0" t="12048" r="2294" b="12851"/>
           <a:stretch xmlns:a="http://schemas.openxmlformats.org/drawingml/2006/main"/>
         </p:blipFill>
         <p:spPr>
           <a:xfrm xmlns:a="http://schemas.openxmlformats.org/drawingml/2006/main">
-            <a:off x="6334125" y="2165391"/>
-            <a:ext cx="5238750" cy="2498642"/>
+            <a:off x="7067550" y="1581150"/>
+            <a:ext cx="4324350" cy="4286250"/>
           </a:xfrm>
           <a:prstGeom xmlns:a="http://schemas.openxmlformats.org/drawingml/2006/main" prst="rect">
             <a:avLst/>
@@ -14355,7 +14363,7 @@
           <p:cNvPr id="3" name="">
             <a:extLst xmlns:a="http://schemas.openxmlformats.org/drawingml/2006/main">
               <a:ext uri="{FF2B5EF4-FFF2-40B4-BE49-F238E27FC236}">
-                <a16:creationId xmlns:a16="http://schemas.microsoft.com/office/drawing/2014/main" id="{8710C8A2-D77A-4F31-BDE4-746CE05D4E87}"/>
+                <a16:creationId xmlns:a16="http://schemas.microsoft.com/office/drawing/2014/main" id="{CBA109A8-F57C-4607-A0CB-4D65BA61224B}"/>
               </a:ext>
             </a:extLst>
           </p:cNvPr>
@@ -14523,7 +14531,7 @@
                           <a:ea typeface="Arial Unicode MS"/>
                           <a:cs typeface="Arial Unicode MS"/>
                         </a:rPr>
-                        <a:t>V01·V02·V03 실제 동작과 원문 연결</a:t>
+                        <a:t>OpenAI V01·V02·V03 실제 동작과 원문 연결</a:t>
                       </a:r>
                     </a:p>
                   </a:txBody>
@@ -14683,7 +14691,7 @@
                           <a:ea typeface="Arial Unicode MS"/>
                           <a:cs typeface="Arial Unicode MS"/>
                         </a:rPr>
-                        <a:t>지원 형식, 보류 부담, 검색·로컬 실행 제약</a:t>
+                        <a:t>지원 형식·보류 부담·검색·외부 전송·비용 제약</a:t>
                       </a:r>
                     </a:p>
                   </a:txBody>
@@ -19632,6 +19640,7 @@
               </a:defRPr>
             </a:defPPr>
             <a:lvl1pPr>
+              <a:buNone/>
               <a:defRPr sz="1725" b="0">
                 <a:solidFill>
                   <a:srgbClr val="15796D"/>
@@ -19642,6 +19651,7 @@
               </a:defRPr>
             </a:lvl1pPr>
             <a:lvl2pPr>
+              <a:buNone/>
               <a:defRPr sz="1725" b="0">
                 <a:solidFill>
                   <a:srgbClr val="15796D"/>
@@ -19652,6 +19662,7 @@
               </a:defRPr>
             </a:lvl2pPr>
             <a:lvl3pPr>
+              <a:buNone/>
               <a:defRPr sz="1725" b="0">
                 <a:solidFill>
                   <a:srgbClr val="15796D"/>
@@ -19662,6 +19673,7 @@
               </a:defRPr>
             </a:lvl3pPr>
             <a:lvl4pPr>
+              <a:buNone/>
               <a:defRPr sz="1725" b="0">
                 <a:solidFill>
                   <a:srgbClr val="15796D"/>
@@ -19672,6 +19684,7 @@
               </a:defRPr>
             </a:lvl4pPr>
             <a:lvl5pPr>
+              <a:buNone/>
               <a:defRPr sz="1725" b="0">
                 <a:solidFill>
                   <a:srgbClr val="15796D"/>
@@ -19682,6 +19695,7 @@
               </a:defRPr>
             </a:lvl5pPr>
             <a:lvl6pPr>
+              <a:buNone/>
               <a:defRPr sz="1725" b="0">
                 <a:solidFill>
                   <a:srgbClr val="15796D"/>
@@ -19692,6 +19706,7 @@
               </a:defRPr>
             </a:lvl6pPr>
             <a:lvl7pPr>
+              <a:buNone/>
               <a:defRPr sz="1725" b="0">
                 <a:solidFill>
                   <a:srgbClr val="15796D"/>
@@ -19702,6 +19717,7 @@
               </a:defRPr>
             </a:lvl7pPr>
             <a:lvl8pPr>
+              <a:buNone/>
               <a:defRPr sz="1725" b="0">
                 <a:solidFill>
                   <a:srgbClr val="15796D"/>
@@ -19712,6 +19728,7 @@
               </a:defRPr>
             </a:lvl8pPr>
             <a:lvl9pPr>
+              <a:buNone/>
               <a:defRPr sz="1725" b="0">
                 <a:solidFill>
                   <a:srgbClr val="15796D"/>
@@ -19724,6 +19741,7 @@
           </a:lstStyle>
           <a:p xmlns:a="http://schemas.openxmlformats.org/drawingml/2006/main">
             <a:pPr>
+              <a:buNone/>
               <a:defRPr sz="1725" b="0">
                 <a:solidFill>
                   <a:srgbClr val="15796D"/>
@@ -20117,7 +20135,7 @@
           <p:cNvPr id="3" name="">
             <a:extLst xmlns:a="http://schemas.openxmlformats.org/drawingml/2006/main">
               <a:ext uri="{FF2B5EF4-FFF2-40B4-BE49-F238E27FC236}">
-                <a16:creationId xmlns:a16="http://schemas.microsoft.com/office/drawing/2014/main" id="{EA38BEF1-9060-49A9-90BA-D36424AD403A}"/>
+                <a16:creationId xmlns:a16="http://schemas.microsoft.com/office/drawing/2014/main" id="{2032F115-8ED5-4C76-AA82-518BF8F15AFC}"/>
               </a:ext>
             </a:extLst>
           </p:cNvPr>
@@ -20127,13 +20145,14 @@
           <p:nvPr/>
         </p:nvPicPr>
         <p:blipFill>
-          <a:blip xmlns:r="http://schemas.openxmlformats.org/officeDocument/2006/relationships" xmlns:a="http://schemas.openxmlformats.org/drawingml/2006/main" r:embed="R75b7792dfc2f4aac"/>
+          <a:blip xmlns:r="http://schemas.openxmlformats.org/officeDocument/2006/relationships" xmlns:a="http://schemas.openxmlformats.org/drawingml/2006/main" r:embed="R942db37b77864f47"/>
+          <a:srcRect xmlns:a="http://schemas.openxmlformats.org/drawingml/2006/main" l="0" t="12048" r="2294" b="12851"/>
           <a:stretch xmlns:a="http://schemas.openxmlformats.org/drawingml/2006/main"/>
         </p:blipFill>
         <p:spPr>
           <a:xfrm xmlns:a="http://schemas.openxmlformats.org/drawingml/2006/main">
-            <a:off x="2288341" y="1600200"/>
-            <a:ext cx="7615318" cy="4286250"/>
+            <a:off x="7067550" y="1581150"/>
+            <a:ext cx="4324350" cy="4286250"/>
           </a:xfrm>
           <a:prstGeom xmlns:a="http://schemas.openxmlformats.org/drawingml/2006/main" prst="rect">
             <a:avLst/>
@@ -20303,7 +20322,7 @@
                 <a:ea typeface="Arial Unicode MS"/>
                 <a:cs typeface="Arial Unicode MS"/>
               </a:rPr>
-              <a:t>V01: 9일치·1불일치  |  자동 검사 385개·화면 모의 검사 65개</a:t>
+              <a:t>2026-10-21 가상 PDF 실제 실행 · 오른쪽은 저장 보고서 발췌</a:t>
             </a:r>
           </a:p>
           <a:p xmlns:a="http://schemas.openxmlformats.org/drawingml/2006/main">
@@ -20327,7 +20346,685 @@
                 <a:ea typeface="Arial Unicode MS"/>
                 <a:cs typeface="Arial Unicode MS"/>
               </a:rPr>
-              <a:t>가상 PDF의 사전 실제 실행 화면입니다. 현업 정확도·시간 절감률은 미측정입니다.</a:t>
+              <a:t>Python 444개·화면 모의 71개 통과 | 현업 정확도·절감률 미측정</a:t>
+            </a:r>
+          </a:p>
+        </p:txBody>
+      </p:sp>
+      <p:sp>
+        <p:nvSpPr>
+          <p:cNvPr id="6" name="verified-backend">
+            <a:extLst xmlns:a="http://schemas.openxmlformats.org/drawingml/2006/main">
+              <a:ext uri="{FF2B5EF4-FFF2-40B4-BE49-F238E27FC236}">
+                <a16:creationId xmlns:a16="http://schemas.microsoft.com/office/drawing/2014/main" id="{7BB38753-E235-43F2-A4D4-21C431B59B05}"/>
+              </a:ext>
+            </a:extLst>
+          </p:cNvPr>
+          <p:cNvSpPr>
+            <a:spLocks xmlns:a="http://schemas.openxmlformats.org/drawingml/2006/main" noGrp="1"/>
+          </p:cNvSpPr>
+          <p:nvPr/>
+        </p:nvSpPr>
+        <p:spPr>
+          <a:xfrm xmlns:a="http://schemas.openxmlformats.org/drawingml/2006/main">
+            <a:off x="609600" y="1714500"/>
+            <a:ext cx="6000750" cy="514350"/>
+          </a:xfrm>
+          <a:prstGeom xmlns:a="http://schemas.openxmlformats.org/drawingml/2006/main" prst="rect">
+            <a:avLst/>
+          </a:prstGeom>
+          <a:noFill xmlns:a="http://schemas.openxmlformats.org/drawingml/2006/main"/>
+          <a:ln xmlns:a="http://schemas.openxmlformats.org/drawingml/2006/main" w="0">
+            <a:noFill/>
+          </a:ln>
+        </p:spPr>
+        <p:txBody>
+          <a:bodyPr xmlns:a="http://schemas.openxmlformats.org/drawingml/2006/main" wrap="square" lIns="0" tIns="0" rIns="0" bIns="0">
+            <a:noAutofit/>
+          </a:bodyPr>
+          <a:lstStyle xmlns:a="http://schemas.openxmlformats.org/drawingml/2006/main">
+            <a:defPPr>
+              <a:defRPr sz="2325" b="1">
+                <a:solidFill>
+                  <a:srgbClr val="15796D"/>
+                </a:solidFill>
+                <a:latin typeface="Arial Unicode MS"/>
+                <a:ea typeface="Arial Unicode MS"/>
+                <a:cs typeface="Arial Unicode MS"/>
+              </a:defRPr>
+            </a:defPPr>
+            <a:lvl1pPr>
+              <a:defRPr sz="2325" b="1">
+                <a:solidFill>
+                  <a:srgbClr val="15796D"/>
+                </a:solidFill>
+                <a:latin typeface="Arial Unicode MS"/>
+                <a:ea typeface="Arial Unicode MS"/>
+                <a:cs typeface="Arial Unicode MS"/>
+              </a:defRPr>
+            </a:lvl1pPr>
+            <a:lvl2pPr>
+              <a:defRPr sz="2325" b="1">
+                <a:solidFill>
+                  <a:srgbClr val="15796D"/>
+                </a:solidFill>
+                <a:latin typeface="Arial Unicode MS"/>
+                <a:ea typeface="Arial Unicode MS"/>
+                <a:cs typeface="Arial Unicode MS"/>
+              </a:defRPr>
+            </a:lvl2pPr>
+            <a:lvl3pPr>
+              <a:defRPr sz="2325" b="1">
+                <a:solidFill>
+                  <a:srgbClr val="15796D"/>
+                </a:solidFill>
+                <a:latin typeface="Arial Unicode MS"/>
+                <a:ea typeface="Arial Unicode MS"/>
+                <a:cs typeface="Arial Unicode MS"/>
+              </a:defRPr>
+            </a:lvl3pPr>
+            <a:lvl4pPr>
+              <a:defRPr sz="2325" b="1">
+                <a:solidFill>
+                  <a:srgbClr val="15796D"/>
+                </a:solidFill>
+                <a:latin typeface="Arial Unicode MS"/>
+                <a:ea typeface="Arial Unicode MS"/>
+                <a:cs typeface="Arial Unicode MS"/>
+              </a:defRPr>
+            </a:lvl4pPr>
+            <a:lvl5pPr>
+              <a:defRPr sz="2325" b="1">
+                <a:solidFill>
+                  <a:srgbClr val="15796D"/>
+                </a:solidFill>
+                <a:latin typeface="Arial Unicode MS"/>
+                <a:ea typeface="Arial Unicode MS"/>
+                <a:cs typeface="Arial Unicode MS"/>
+              </a:defRPr>
+            </a:lvl5pPr>
+            <a:lvl6pPr>
+              <a:defRPr sz="2325" b="1">
+                <a:solidFill>
+                  <a:srgbClr val="15796D"/>
+                </a:solidFill>
+                <a:latin typeface="Arial Unicode MS"/>
+                <a:ea typeface="Arial Unicode MS"/>
+                <a:cs typeface="Arial Unicode MS"/>
+              </a:defRPr>
+            </a:lvl6pPr>
+            <a:lvl7pPr>
+              <a:defRPr sz="2325" b="1">
+                <a:solidFill>
+                  <a:srgbClr val="15796D"/>
+                </a:solidFill>
+                <a:latin typeface="Arial Unicode MS"/>
+                <a:ea typeface="Arial Unicode MS"/>
+                <a:cs typeface="Arial Unicode MS"/>
+              </a:defRPr>
+            </a:lvl7pPr>
+            <a:lvl8pPr>
+              <a:defRPr sz="2325" b="1">
+                <a:solidFill>
+                  <a:srgbClr val="15796D"/>
+                </a:solidFill>
+                <a:latin typeface="Arial Unicode MS"/>
+                <a:ea typeface="Arial Unicode MS"/>
+                <a:cs typeface="Arial Unicode MS"/>
+              </a:defRPr>
+            </a:lvl8pPr>
+            <a:lvl9pPr>
+              <a:defRPr sz="2325" b="1">
+                <a:solidFill>
+                  <a:srgbClr val="15796D"/>
+                </a:solidFill>
+                <a:latin typeface="Arial Unicode MS"/>
+                <a:ea typeface="Arial Unicode MS"/>
+                <a:cs typeface="Arial Unicode MS"/>
+              </a:defRPr>
+            </a:lvl9pPr>
+          </a:lstStyle>
+          <a:p xmlns:a="http://schemas.openxmlformats.org/drawingml/2006/main">
+            <a:pPr>
+              <a:defRPr sz="2325" b="1">
+                <a:solidFill>
+                  <a:srgbClr val="15796D"/>
+                </a:solidFill>
+                <a:latin typeface="Arial Unicode MS"/>
+                <a:ea typeface="Arial Unicode MS"/>
+                <a:cs typeface="Arial Unicode MS"/>
+              </a:defRPr>
+            </a:pPr>
+            <a:r>
+              <a:rPr sz="2325" b="1">
+                <a:solidFill>
+                  <a:srgbClr val="15796D"/>
+                </a:solidFill>
+                <a:latin typeface="Arial Unicode MS"/>
+                <a:ea typeface="Arial Unicode MS"/>
+                <a:cs typeface="Arial Unicode MS"/>
+              </a:rPr>
+              <a:t>OpenAI API · gpt-4o-mini</a:t>
+            </a:r>
+          </a:p>
+        </p:txBody>
+      </p:sp>
+      <p:sp>
+        <p:nvSpPr>
+          <p:cNvPr id="7" name="verified-result">
+            <a:extLst xmlns:a="http://schemas.openxmlformats.org/drawingml/2006/main">
+              <a:ext uri="{FF2B5EF4-FFF2-40B4-BE49-F238E27FC236}">
+                <a16:creationId xmlns:a16="http://schemas.microsoft.com/office/drawing/2014/main" id="{B1386A4C-10E1-44E4-95A9-73596EB6469C}"/>
+              </a:ext>
+            </a:extLst>
+          </p:cNvPr>
+          <p:cNvSpPr>
+            <a:spLocks xmlns:a="http://schemas.openxmlformats.org/drawingml/2006/main" noGrp="1"/>
+          </p:cNvSpPr>
+          <p:nvPr/>
+        </p:nvSpPr>
+        <p:spPr>
+          <a:xfrm xmlns:a="http://schemas.openxmlformats.org/drawingml/2006/main">
+            <a:off x="609600" y="2400300"/>
+            <a:ext cx="6000750" cy="714375"/>
+          </a:xfrm>
+          <a:prstGeom xmlns:a="http://schemas.openxmlformats.org/drawingml/2006/main" prst="rect">
+            <a:avLst/>
+          </a:prstGeom>
+          <a:noFill xmlns:a="http://schemas.openxmlformats.org/drawingml/2006/main"/>
+          <a:ln xmlns:a="http://schemas.openxmlformats.org/drawingml/2006/main" w="0">
+            <a:noFill/>
+          </a:ln>
+        </p:spPr>
+        <p:txBody>
+          <a:bodyPr xmlns:a="http://schemas.openxmlformats.org/drawingml/2006/main" wrap="square" lIns="0" tIns="0" rIns="0" bIns="0">
+            <a:noAutofit/>
+          </a:bodyPr>
+          <a:lstStyle xmlns:a="http://schemas.openxmlformats.org/drawingml/2006/main">
+            <a:defPPr>
+              <a:defRPr sz="3150" b="1">
+                <a:solidFill>
+                  <a:srgbClr val="173C46"/>
+                </a:solidFill>
+                <a:latin typeface="Arial Unicode MS"/>
+                <a:ea typeface="Arial Unicode MS"/>
+                <a:cs typeface="Arial Unicode MS"/>
+              </a:defRPr>
+            </a:defPPr>
+            <a:lvl1pPr>
+              <a:defRPr sz="3150" b="1">
+                <a:solidFill>
+                  <a:srgbClr val="173C46"/>
+                </a:solidFill>
+                <a:latin typeface="Arial Unicode MS"/>
+                <a:ea typeface="Arial Unicode MS"/>
+                <a:cs typeface="Arial Unicode MS"/>
+              </a:defRPr>
+            </a:lvl1pPr>
+            <a:lvl2pPr>
+              <a:defRPr sz="3150" b="1">
+                <a:solidFill>
+                  <a:srgbClr val="173C46"/>
+                </a:solidFill>
+                <a:latin typeface="Arial Unicode MS"/>
+                <a:ea typeface="Arial Unicode MS"/>
+                <a:cs typeface="Arial Unicode MS"/>
+              </a:defRPr>
+            </a:lvl2pPr>
+            <a:lvl3pPr>
+              <a:defRPr sz="3150" b="1">
+                <a:solidFill>
+                  <a:srgbClr val="173C46"/>
+                </a:solidFill>
+                <a:latin typeface="Arial Unicode MS"/>
+                <a:ea typeface="Arial Unicode MS"/>
+                <a:cs typeface="Arial Unicode MS"/>
+              </a:defRPr>
+            </a:lvl3pPr>
+            <a:lvl4pPr>
+              <a:defRPr sz="3150" b="1">
+                <a:solidFill>
+                  <a:srgbClr val="173C46"/>
+                </a:solidFill>
+                <a:latin typeface="Arial Unicode MS"/>
+                <a:ea typeface="Arial Unicode MS"/>
+                <a:cs typeface="Arial Unicode MS"/>
+              </a:defRPr>
+            </a:lvl4pPr>
+            <a:lvl5pPr>
+              <a:defRPr sz="3150" b="1">
+                <a:solidFill>
+                  <a:srgbClr val="173C46"/>
+                </a:solidFill>
+                <a:latin typeface="Arial Unicode MS"/>
+                <a:ea typeface="Arial Unicode MS"/>
+                <a:cs typeface="Arial Unicode MS"/>
+              </a:defRPr>
+            </a:lvl5pPr>
+            <a:lvl6pPr>
+              <a:defRPr sz="3150" b="1">
+                <a:solidFill>
+                  <a:srgbClr val="173C46"/>
+                </a:solidFill>
+                <a:latin typeface="Arial Unicode MS"/>
+                <a:ea typeface="Arial Unicode MS"/>
+                <a:cs typeface="Arial Unicode MS"/>
+              </a:defRPr>
+            </a:lvl6pPr>
+            <a:lvl7pPr>
+              <a:defRPr sz="3150" b="1">
+                <a:solidFill>
+                  <a:srgbClr val="173C46"/>
+                </a:solidFill>
+                <a:latin typeface="Arial Unicode MS"/>
+                <a:ea typeface="Arial Unicode MS"/>
+                <a:cs typeface="Arial Unicode MS"/>
+              </a:defRPr>
+            </a:lvl7pPr>
+            <a:lvl8pPr>
+              <a:defRPr sz="3150" b="1">
+                <a:solidFill>
+                  <a:srgbClr val="173C46"/>
+                </a:solidFill>
+                <a:latin typeface="Arial Unicode MS"/>
+                <a:ea typeface="Arial Unicode MS"/>
+                <a:cs typeface="Arial Unicode MS"/>
+              </a:defRPr>
+            </a:lvl8pPr>
+            <a:lvl9pPr>
+              <a:defRPr sz="3150" b="1">
+                <a:solidFill>
+                  <a:srgbClr val="173C46"/>
+                </a:solidFill>
+                <a:latin typeface="Arial Unicode MS"/>
+                <a:ea typeface="Arial Unicode MS"/>
+                <a:cs typeface="Arial Unicode MS"/>
+              </a:defRPr>
+            </a:lvl9pPr>
+          </a:lstStyle>
+          <a:p xmlns:a="http://schemas.openxmlformats.org/drawingml/2006/main">
+            <a:pPr>
+              <a:defRPr sz="3150" b="1">
+                <a:solidFill>
+                  <a:srgbClr val="173C46"/>
+                </a:solidFill>
+                <a:latin typeface="Arial Unicode MS"/>
+                <a:ea typeface="Arial Unicode MS"/>
+                <a:cs typeface="Arial Unicode MS"/>
+              </a:defRPr>
+            </a:pPr>
+            <a:r>
+              <a:rPr sz="3150" b="1">
+                <a:solidFill>
+                  <a:srgbClr val="173C46"/>
+                </a:solidFill>
+                <a:latin typeface="Arial Unicode MS"/>
+                <a:ea typeface="Arial Unicode MS"/>
+                <a:cs typeface="Arial Unicode MS"/>
+              </a:rPr>
+              <a:t>9개 일치 · 1개 불일치</a:t>
+            </a:r>
+          </a:p>
+        </p:txBody>
+      </p:sp>
+      <p:sp>
+        <p:nvSpPr>
+          <p:cNvPr id="8" name="verified-evidence">
+            <a:extLst xmlns:a="http://schemas.openxmlformats.org/drawingml/2006/main">
+              <a:ext uri="{FF2B5EF4-FFF2-40B4-BE49-F238E27FC236}">
+                <a16:creationId xmlns:a16="http://schemas.microsoft.com/office/drawing/2014/main" id="{676CF4F6-C4EC-4AEA-AD59-4E4EFB6E73B0}"/>
+              </a:ext>
+            </a:extLst>
+          </p:cNvPr>
+          <p:cNvSpPr>
+            <a:spLocks xmlns:a="http://schemas.openxmlformats.org/drawingml/2006/main" noGrp="1"/>
+          </p:cNvSpPr>
+          <p:nvPr/>
+        </p:nvSpPr>
+        <p:spPr>
+          <a:xfrm xmlns:a="http://schemas.openxmlformats.org/drawingml/2006/main">
+            <a:off x="609600" y="3333750"/>
+            <a:ext cx="6191250" cy="1428750"/>
+          </a:xfrm>
+          <a:prstGeom xmlns:a="http://schemas.openxmlformats.org/drawingml/2006/main" prst="rect">
+            <a:avLst/>
+          </a:prstGeom>
+          <a:noFill xmlns:a="http://schemas.openxmlformats.org/drawingml/2006/main"/>
+          <a:ln xmlns:a="http://schemas.openxmlformats.org/drawingml/2006/main" w="0">
+            <a:noFill/>
+          </a:ln>
+        </p:spPr>
+        <p:txBody>
+          <a:bodyPr xmlns:a="http://schemas.openxmlformats.org/drawingml/2006/main" wrap="square" lIns="0" tIns="0" rIns="0" bIns="0">
+            <a:noAutofit/>
+          </a:bodyPr>
+          <a:lstStyle xmlns:a="http://schemas.openxmlformats.org/drawingml/2006/main">
+            <a:defPPr>
+              <a:defRPr sz="2025" b="0">
+                <a:solidFill>
+                  <a:srgbClr val="173C46"/>
+                </a:solidFill>
+                <a:latin typeface="Arial Unicode MS"/>
+                <a:ea typeface="Arial Unicode MS"/>
+                <a:cs typeface="Arial Unicode MS"/>
+              </a:defRPr>
+            </a:defPPr>
+            <a:lvl1pPr>
+              <a:defRPr sz="2025" b="0">
+                <a:solidFill>
+                  <a:srgbClr val="173C46"/>
+                </a:solidFill>
+                <a:latin typeface="Arial Unicode MS"/>
+                <a:ea typeface="Arial Unicode MS"/>
+                <a:cs typeface="Arial Unicode MS"/>
+              </a:defRPr>
+            </a:lvl1pPr>
+            <a:lvl2pPr>
+              <a:defRPr sz="2025" b="0">
+                <a:solidFill>
+                  <a:srgbClr val="173C46"/>
+                </a:solidFill>
+                <a:latin typeface="Arial Unicode MS"/>
+                <a:ea typeface="Arial Unicode MS"/>
+                <a:cs typeface="Arial Unicode MS"/>
+              </a:defRPr>
+            </a:lvl2pPr>
+            <a:lvl3pPr>
+              <a:defRPr sz="2025" b="0">
+                <a:solidFill>
+                  <a:srgbClr val="173C46"/>
+                </a:solidFill>
+                <a:latin typeface="Arial Unicode MS"/>
+                <a:ea typeface="Arial Unicode MS"/>
+                <a:cs typeface="Arial Unicode MS"/>
+              </a:defRPr>
+            </a:lvl3pPr>
+            <a:lvl4pPr>
+              <a:defRPr sz="2025" b="0">
+                <a:solidFill>
+                  <a:srgbClr val="173C46"/>
+                </a:solidFill>
+                <a:latin typeface="Arial Unicode MS"/>
+                <a:ea typeface="Arial Unicode MS"/>
+                <a:cs typeface="Arial Unicode MS"/>
+              </a:defRPr>
+            </a:lvl4pPr>
+            <a:lvl5pPr>
+              <a:defRPr sz="2025" b="0">
+                <a:solidFill>
+                  <a:srgbClr val="173C46"/>
+                </a:solidFill>
+                <a:latin typeface="Arial Unicode MS"/>
+                <a:ea typeface="Arial Unicode MS"/>
+                <a:cs typeface="Arial Unicode MS"/>
+              </a:defRPr>
+            </a:lvl5pPr>
+            <a:lvl6pPr>
+              <a:defRPr sz="2025" b="0">
+                <a:solidFill>
+                  <a:srgbClr val="173C46"/>
+                </a:solidFill>
+                <a:latin typeface="Arial Unicode MS"/>
+                <a:ea typeface="Arial Unicode MS"/>
+                <a:cs typeface="Arial Unicode MS"/>
+              </a:defRPr>
+            </a:lvl6pPr>
+            <a:lvl7pPr>
+              <a:defRPr sz="2025" b="0">
+                <a:solidFill>
+                  <a:srgbClr val="173C46"/>
+                </a:solidFill>
+                <a:latin typeface="Arial Unicode MS"/>
+                <a:ea typeface="Arial Unicode MS"/>
+                <a:cs typeface="Arial Unicode MS"/>
+              </a:defRPr>
+            </a:lvl7pPr>
+            <a:lvl8pPr>
+              <a:defRPr sz="2025" b="0">
+                <a:solidFill>
+                  <a:srgbClr val="173C46"/>
+                </a:solidFill>
+                <a:latin typeface="Arial Unicode MS"/>
+                <a:ea typeface="Arial Unicode MS"/>
+                <a:cs typeface="Arial Unicode MS"/>
+              </a:defRPr>
+            </a:lvl8pPr>
+            <a:lvl9pPr>
+              <a:defRPr sz="2025" b="0">
+                <a:solidFill>
+                  <a:srgbClr val="173C46"/>
+                </a:solidFill>
+                <a:latin typeface="Arial Unicode MS"/>
+                <a:ea typeface="Arial Unicode MS"/>
+                <a:cs typeface="Arial Unicode MS"/>
+              </a:defRPr>
+            </a:lvl9pPr>
+          </a:lstStyle>
+          <a:p xmlns:a="http://schemas.openxmlformats.org/drawingml/2006/main">
+            <a:pPr>
+              <a:defRPr sz="2025" b="0">
+                <a:solidFill>
+                  <a:srgbClr val="173C46"/>
+                </a:solidFill>
+                <a:latin typeface="Arial Unicode MS"/>
+                <a:ea typeface="Arial Unicode MS"/>
+                <a:cs typeface="Arial Unicode MS"/>
+              </a:defRPr>
+            </a:pPr>
+            <a:r>
+              <a:rPr sz="2025" b="0">
+                <a:solidFill>
+                  <a:srgbClr val="173C46"/>
+                </a:solidFill>
+                <a:latin typeface="Arial Unicode MS"/>
+                <a:ea typeface="Arial Unicode MS"/>
+                <a:cs typeface="Arial Unicode MS"/>
+              </a:rPr>
+              <a:t>팬 보조전원</a:t>
+            </a:r>
+          </a:p>
+          <a:p xmlns:a="http://schemas.openxmlformats.org/drawingml/2006/main">
+            <a:pPr>
+              <a:defRPr sz="2025" b="0">
+                <a:solidFill>
+                  <a:srgbClr val="173C46"/>
+                </a:solidFill>
+                <a:latin typeface="Arial Unicode MS"/>
+                <a:ea typeface="Arial Unicode MS"/>
+                <a:cs typeface="Arial Unicode MS"/>
+              </a:defRPr>
+            </a:pPr>
+            <a:r>
+              <a:rPr sz="2025" b="0">
+                <a:solidFill>
+                  <a:srgbClr val="173C46"/>
+                </a:solidFill>
+                <a:latin typeface="Arial Unicode MS"/>
+                <a:ea typeface="Arial Unicode MS"/>
+                <a:cs typeface="Arial Unicode MS"/>
+              </a:rPr>
+              <a:t>요구 440 V  /  인계 380 V</a:t>
+            </a:r>
+          </a:p>
+          <a:p xmlns:a="http://schemas.openxmlformats.org/drawingml/2006/main">
+            <a:pPr>
+              <a:defRPr sz="2025" b="0">
+                <a:solidFill>
+                  <a:srgbClr val="173C46"/>
+                </a:solidFill>
+                <a:latin typeface="Arial Unicode MS"/>
+                <a:ea typeface="Arial Unicode MS"/>
+                <a:cs typeface="Arial Unicode MS"/>
+              </a:defRPr>
+            </a:pPr>
+            <a:r>
+              <a:rPr sz="2025" b="0">
+                <a:solidFill>
+                  <a:srgbClr val="173C46"/>
+                </a:solidFill>
+                <a:latin typeface="Arial Unicode MS"/>
+                <a:ea typeface="Arial Unicode MS"/>
+                <a:cs typeface="Arial Unicode MS"/>
+              </a:rPr>
+              <a:t>AMD-V01 1쪽  /  HANDOFF-V01 2쪽</a:t>
+            </a:r>
+          </a:p>
+        </p:txBody>
+      </p:sp>
+      <p:sp>
+        <p:nvSpPr>
+          <p:cNvPr id="9" name="verified-calls">
+            <a:extLst xmlns:a="http://schemas.openxmlformats.org/drawingml/2006/main">
+              <a:ext uri="{FF2B5EF4-FFF2-40B4-BE49-F238E27FC236}">
+                <a16:creationId xmlns:a16="http://schemas.microsoft.com/office/drawing/2014/main" id="{4A320189-1802-4F74-A079-06B98248D77D}"/>
+              </a:ext>
+            </a:extLst>
+          </p:cNvPr>
+          <p:cNvSpPr>
+            <a:spLocks xmlns:a="http://schemas.openxmlformats.org/drawingml/2006/main" noGrp="1"/>
+          </p:cNvSpPr>
+          <p:nvPr/>
+        </p:nvSpPr>
+        <p:spPr>
+          <a:xfrm xmlns:a="http://schemas.openxmlformats.org/drawingml/2006/main">
+            <a:off x="609600" y="5029200"/>
+            <a:ext cx="6286500" cy="609600"/>
+          </a:xfrm>
+          <a:prstGeom xmlns:a="http://schemas.openxmlformats.org/drawingml/2006/main" prst="rect">
+            <a:avLst/>
+          </a:prstGeom>
+          <a:noFill xmlns:a="http://schemas.openxmlformats.org/drawingml/2006/main"/>
+          <a:ln xmlns:a="http://schemas.openxmlformats.org/drawingml/2006/main" w="0">
+            <a:noFill/>
+          </a:ln>
+        </p:spPr>
+        <p:txBody>
+          <a:bodyPr xmlns:a="http://schemas.openxmlformats.org/drawingml/2006/main" wrap="square" lIns="0" tIns="0" rIns="0" bIns="0">
+            <a:noAutofit/>
+          </a:bodyPr>
+          <a:lstStyle xmlns:a="http://schemas.openxmlformats.org/drawingml/2006/main">
+            <a:defPPr>
+              <a:defRPr sz="1800" b="0">
+                <a:solidFill>
+                  <a:srgbClr val="15796D"/>
+                </a:solidFill>
+                <a:latin typeface="Arial Unicode MS"/>
+                <a:ea typeface="Arial Unicode MS"/>
+                <a:cs typeface="Arial Unicode MS"/>
+              </a:defRPr>
+            </a:defPPr>
+            <a:lvl1pPr>
+              <a:defRPr sz="1800" b="0">
+                <a:solidFill>
+                  <a:srgbClr val="15796D"/>
+                </a:solidFill>
+                <a:latin typeface="Arial Unicode MS"/>
+                <a:ea typeface="Arial Unicode MS"/>
+                <a:cs typeface="Arial Unicode MS"/>
+              </a:defRPr>
+            </a:lvl1pPr>
+            <a:lvl2pPr>
+              <a:defRPr sz="1800" b="0">
+                <a:solidFill>
+                  <a:srgbClr val="15796D"/>
+                </a:solidFill>
+                <a:latin typeface="Arial Unicode MS"/>
+                <a:ea typeface="Arial Unicode MS"/>
+                <a:cs typeface="Arial Unicode MS"/>
+              </a:defRPr>
+            </a:lvl2pPr>
+            <a:lvl3pPr>
+              <a:defRPr sz="1800" b="0">
+                <a:solidFill>
+                  <a:srgbClr val="15796D"/>
+                </a:solidFill>
+                <a:latin typeface="Arial Unicode MS"/>
+                <a:ea typeface="Arial Unicode MS"/>
+                <a:cs typeface="Arial Unicode MS"/>
+              </a:defRPr>
+            </a:lvl3pPr>
+            <a:lvl4pPr>
+              <a:defRPr sz="1800" b="0">
+                <a:solidFill>
+                  <a:srgbClr val="15796D"/>
+                </a:solidFill>
+                <a:latin typeface="Arial Unicode MS"/>
+                <a:ea typeface="Arial Unicode MS"/>
+                <a:cs typeface="Arial Unicode MS"/>
+              </a:defRPr>
+            </a:lvl4pPr>
+            <a:lvl5pPr>
+              <a:defRPr sz="1800" b="0">
+                <a:solidFill>
+                  <a:srgbClr val="15796D"/>
+                </a:solidFill>
+                <a:latin typeface="Arial Unicode MS"/>
+                <a:ea typeface="Arial Unicode MS"/>
+                <a:cs typeface="Arial Unicode MS"/>
+              </a:defRPr>
+            </a:lvl5pPr>
+            <a:lvl6pPr>
+              <a:defRPr sz="1800" b="0">
+                <a:solidFill>
+                  <a:srgbClr val="15796D"/>
+                </a:solidFill>
+                <a:latin typeface="Arial Unicode MS"/>
+                <a:ea typeface="Arial Unicode MS"/>
+                <a:cs typeface="Arial Unicode MS"/>
+              </a:defRPr>
+            </a:lvl6pPr>
+            <a:lvl7pPr>
+              <a:defRPr sz="1800" b="0">
+                <a:solidFill>
+                  <a:srgbClr val="15796D"/>
+                </a:solidFill>
+                <a:latin typeface="Arial Unicode MS"/>
+                <a:ea typeface="Arial Unicode MS"/>
+                <a:cs typeface="Arial Unicode MS"/>
+              </a:defRPr>
+            </a:lvl7pPr>
+            <a:lvl8pPr>
+              <a:defRPr sz="1800" b="0">
+                <a:solidFill>
+                  <a:srgbClr val="15796D"/>
+                </a:solidFill>
+                <a:latin typeface="Arial Unicode MS"/>
+                <a:ea typeface="Arial Unicode MS"/>
+                <a:cs typeface="Arial Unicode MS"/>
+              </a:defRPr>
+            </a:lvl8pPr>
+            <a:lvl9pPr>
+              <a:defRPr sz="1800" b="0">
+                <a:solidFill>
+                  <a:srgbClr val="15796D"/>
+                </a:solidFill>
+                <a:latin typeface="Arial Unicode MS"/>
+                <a:ea typeface="Arial Unicode MS"/>
+                <a:cs typeface="Arial Unicode MS"/>
+              </a:defRPr>
+            </a:lvl9pPr>
+          </a:lstStyle>
+          <a:p xmlns:a="http://schemas.openxmlformats.org/drawingml/2006/main">
+            <a:pPr>
+              <a:defRPr sz="1800" b="0">
+                <a:solidFill>
+                  <a:srgbClr val="15796D"/>
+                </a:solidFill>
+                <a:latin typeface="Arial Unicode MS"/>
+                <a:ea typeface="Arial Unicode MS"/>
+                <a:cs typeface="Arial Unicode MS"/>
+              </a:defRPr>
+            </a:pPr>
+            <a:r>
+              <a:rPr sz="1800" b="0">
+                <a:solidFill>
+                  <a:srgbClr val="15796D"/>
+                </a:solidFill>
+                <a:latin typeface="Arial Unicode MS"/>
+                <a:ea typeface="Arial Unicode MS"/>
+                <a:cs typeface="Arial Unicode MS"/>
+              </a:rPr>
+              <a:t>실제 호출 2/2회 완료 · 제안 21/21개 원문 검증</a:t>
             </a:r>
           </a:p>
         </p:txBody>
@@ -20404,6 +21101,7 @@
               </a:defRPr>
             </a:defPPr>
             <a:lvl1pPr>
+              <a:buNone/>
               <a:defRPr sz="3225" b="1">
                 <a:solidFill>
                   <a:srgbClr val="173C46"/>
@@ -20414,6 +21112,7 @@
               </a:defRPr>
             </a:lvl1pPr>
             <a:lvl2pPr>
+              <a:buNone/>
               <a:defRPr sz="3225" b="1">
                 <a:solidFill>
                   <a:srgbClr val="173C46"/>
@@ -20424,6 +21123,7 @@
               </a:defRPr>
             </a:lvl2pPr>
             <a:lvl3pPr>
+              <a:buNone/>
               <a:defRPr sz="3225" b="1">
                 <a:solidFill>
                   <a:srgbClr val="173C46"/>
@@ -20434,6 +21134,7 @@
               </a:defRPr>
             </a:lvl3pPr>
             <a:lvl4pPr>
+              <a:buNone/>
               <a:defRPr sz="3225" b="1">
                 <a:solidFill>
                   <a:srgbClr val="173C46"/>
@@ -20444,6 +21145,7 @@
               </a:defRPr>
             </a:lvl4pPr>
             <a:lvl5pPr>
+              <a:buNone/>
               <a:defRPr sz="3225" b="1">
                 <a:solidFill>
                   <a:srgbClr val="173C46"/>
@@ -20454,6 +21156,7 @@
               </a:defRPr>
             </a:lvl5pPr>
             <a:lvl6pPr>
+              <a:buNone/>
               <a:defRPr sz="3225" b="1">
                 <a:solidFill>
                   <a:srgbClr val="173C46"/>
@@ -20464,6 +21167,7 @@
               </a:defRPr>
             </a:lvl6pPr>
             <a:lvl7pPr>
+              <a:buNone/>
               <a:defRPr sz="3225" b="1">
                 <a:solidFill>
                   <a:srgbClr val="173C46"/>
@@ -20474,6 +21178,7 @@
               </a:defRPr>
             </a:lvl7pPr>
             <a:lvl8pPr>
+              <a:buNone/>
               <a:defRPr sz="3225" b="1">
                 <a:solidFill>
                   <a:srgbClr val="173C46"/>
@@ -20484,6 +21189,7 @@
               </a:defRPr>
             </a:lvl8pPr>
             <a:lvl9pPr>
+              <a:buNone/>
               <a:defRPr sz="3225" b="1">
                 <a:solidFill>
                   <a:srgbClr val="173C46"/>
@@ -20496,6 +21202,7 @@
           </a:lstStyle>
           <a:p xmlns:a="http://schemas.openxmlformats.org/drawingml/2006/main">
             <a:pPr>
+              <a:buNone/>
               <a:defRPr sz="3225" b="1">
                 <a:solidFill>
                   <a:srgbClr val="173C46"/>
@@ -20562,6 +21269,7 @@
               </a:defRPr>
             </a:defPPr>
             <a:lvl1pPr>
+              <a:buNone/>
               <a:defRPr sz="1350" b="0">
                 <a:solidFill>
                   <a:srgbClr val="53676D"/>
@@ -20572,6 +21280,7 @@
               </a:defRPr>
             </a:lvl1pPr>
             <a:lvl2pPr>
+              <a:buNone/>
               <a:defRPr sz="1350" b="0">
                 <a:solidFill>
                   <a:srgbClr val="53676D"/>
@@ -20582,6 +21291,7 @@
               </a:defRPr>
             </a:lvl2pPr>
             <a:lvl3pPr>
+              <a:buNone/>
               <a:defRPr sz="1350" b="0">
                 <a:solidFill>
                   <a:srgbClr val="53676D"/>
@@ -20592,6 +21302,7 @@
               </a:defRPr>
             </a:lvl3pPr>
             <a:lvl4pPr>
+              <a:buNone/>
               <a:defRPr sz="1350" b="0">
                 <a:solidFill>
                   <a:srgbClr val="53676D"/>
@@ -20602,6 +21313,7 @@
               </a:defRPr>
             </a:lvl4pPr>
             <a:lvl5pPr>
+              <a:buNone/>
               <a:defRPr sz="1350" b="0">
                 <a:solidFill>
                   <a:srgbClr val="53676D"/>
@@ -20612,6 +21324,7 @@
               </a:defRPr>
             </a:lvl5pPr>
             <a:lvl6pPr>
+              <a:buNone/>
               <a:defRPr sz="1350" b="0">
                 <a:solidFill>
                   <a:srgbClr val="53676D"/>
@@ -20622,6 +21335,7 @@
               </a:defRPr>
             </a:lvl6pPr>
             <a:lvl7pPr>
+              <a:buNone/>
               <a:defRPr sz="1350" b="0">
                 <a:solidFill>
                   <a:srgbClr val="53676D"/>
@@ -20632,6 +21346,7 @@
               </a:defRPr>
             </a:lvl7pPr>
             <a:lvl8pPr>
+              <a:buNone/>
               <a:defRPr sz="1350" b="0">
                 <a:solidFill>
                   <a:srgbClr val="53676D"/>
@@ -20642,6 +21357,7 @@
               </a:defRPr>
             </a:lvl8pPr>
             <a:lvl9pPr>
+              <a:buNone/>
               <a:defRPr sz="1350" b="0">
                 <a:solidFill>
                   <a:srgbClr val="53676D"/>
@@ -20654,6 +21370,7 @@
           </a:lstStyle>
           <a:p xmlns:a="http://schemas.openxmlformats.org/drawingml/2006/main">
             <a:pPr>
+              <a:buNone/>
               <a:defRPr sz="1350" b="0">
                 <a:solidFill>
                   <a:srgbClr val="53676D"/>
@@ -20712,6 +21429,7 @@
               </a:defRPr>
             </a:defPPr>
             <a:lvl1pPr>
+              <a:buNone/>
               <a:defRPr sz="1650" b="0">
                 <a:solidFill>
                   <a:srgbClr val="53676D"/>
@@ -20722,6 +21440,7 @@
               </a:defRPr>
             </a:lvl1pPr>
             <a:lvl2pPr>
+              <a:buNone/>
               <a:defRPr sz="1650" b="0">
                 <a:solidFill>
                   <a:srgbClr val="53676D"/>
@@ -20732,6 +21451,7 @@
               </a:defRPr>
             </a:lvl2pPr>
             <a:lvl3pPr>
+              <a:buNone/>
               <a:defRPr sz="1650" b="0">
                 <a:solidFill>
                   <a:srgbClr val="53676D"/>
@@ -20742,6 +21462,7 @@
               </a:defRPr>
             </a:lvl3pPr>
             <a:lvl4pPr>
+              <a:buNone/>
               <a:defRPr sz="1650" b="0">
                 <a:solidFill>
                   <a:srgbClr val="53676D"/>
@@ -20752,6 +21473,7 @@
               </a:defRPr>
             </a:lvl4pPr>
             <a:lvl5pPr>
+              <a:buNone/>
               <a:defRPr sz="1650" b="0">
                 <a:solidFill>
                   <a:srgbClr val="53676D"/>
@@ -20762,6 +21484,7 @@
               </a:defRPr>
             </a:lvl5pPr>
             <a:lvl6pPr>
+              <a:buNone/>
               <a:defRPr sz="1650" b="0">
                 <a:solidFill>
                   <a:srgbClr val="53676D"/>
@@ -20772,6 +21495,7 @@
               </a:defRPr>
             </a:lvl6pPr>
             <a:lvl7pPr>
+              <a:buNone/>
               <a:defRPr sz="1650" b="0">
                 <a:solidFill>
                   <a:srgbClr val="53676D"/>
@@ -20782,6 +21506,7 @@
               </a:defRPr>
             </a:lvl7pPr>
             <a:lvl8pPr>
+              <a:buNone/>
               <a:defRPr sz="1650" b="0">
                 <a:solidFill>
                   <a:srgbClr val="53676D"/>
@@ -20792,6 +21517,7 @@
               </a:defRPr>
             </a:lvl8pPr>
             <a:lvl9pPr>
+              <a:buNone/>
               <a:defRPr sz="1650" b="0">
                 <a:solidFill>
                   <a:srgbClr val="53676D"/>
@@ -20804,6 +21530,7 @@
           </a:lstStyle>
           <a:p xmlns:a="http://schemas.openxmlformats.org/drawingml/2006/main">
             <a:pPr>
+              <a:buNone/>
               <a:defRPr sz="1650" b="0">
                 <a:solidFill>
                   <a:srgbClr val="53676D"/>
@@ -20832,7 +21559,7 @@
           <p:cNvPr id="4" name="">
             <a:extLst xmlns:a="http://schemas.openxmlformats.org/drawingml/2006/main">
               <a:ext uri="{FF2B5EF4-FFF2-40B4-BE49-F238E27FC236}">
-                <a16:creationId xmlns:a16="http://schemas.microsoft.com/office/drawing/2014/main" id="{3036A091-78F6-48D9-9B3D-26AFF74B144A}"/>
+                <a16:creationId xmlns:a16="http://schemas.microsoft.com/office/drawing/2014/main" id="{16852408-257F-4AB4-882F-A030A6FC7BF8}"/>
               </a:ext>
             </a:extLst>
           </p:cNvPr>
@@ -21470,6 +22197,7 @@
               </a:defRPr>
             </a:defPPr>
             <a:lvl1pPr>
+              <a:buNone/>
               <a:defRPr sz="1650" b="0">
                 <a:solidFill>
                   <a:srgbClr val="53676D"/>
@@ -21480,6 +22208,7 @@
               </a:defRPr>
             </a:lvl1pPr>
             <a:lvl2pPr>
+              <a:buNone/>
               <a:defRPr sz="1650" b="0">
                 <a:solidFill>
                   <a:srgbClr val="53676D"/>
@@ -21490,6 +22219,7 @@
               </a:defRPr>
             </a:lvl2pPr>
             <a:lvl3pPr>
+              <a:buNone/>
               <a:defRPr sz="1650" b="0">
                 <a:solidFill>
                   <a:srgbClr val="53676D"/>
@@ -21500,6 +22230,7 @@
               </a:defRPr>
             </a:lvl3pPr>
             <a:lvl4pPr>
+              <a:buNone/>
               <a:defRPr sz="1650" b="0">
                 <a:solidFill>
                   <a:srgbClr val="53676D"/>
@@ -21510,6 +22241,7 @@
               </a:defRPr>
             </a:lvl4pPr>
             <a:lvl5pPr>
+              <a:buNone/>
               <a:defRPr sz="1650" b="0">
                 <a:solidFill>
                   <a:srgbClr val="53676D"/>
@@ -21520,6 +22252,7 @@
               </a:defRPr>
             </a:lvl5pPr>
             <a:lvl6pPr>
+              <a:buNone/>
               <a:defRPr sz="1650" b="0">
                 <a:solidFill>
                   <a:srgbClr val="53676D"/>
@@ -21530,6 +22263,7 @@
               </a:defRPr>
             </a:lvl6pPr>
             <a:lvl7pPr>
+              <a:buNone/>
               <a:defRPr sz="1650" b="0">
                 <a:solidFill>
                   <a:srgbClr val="53676D"/>
@@ -21540,6 +22274,7 @@
               </a:defRPr>
             </a:lvl7pPr>
             <a:lvl8pPr>
+              <a:buNone/>
               <a:defRPr sz="1650" b="0">
                 <a:solidFill>
                   <a:srgbClr val="53676D"/>
@@ -21550,6 +22285,7 @@
               </a:defRPr>
             </a:lvl8pPr>
             <a:lvl9pPr>
+              <a:buNone/>
               <a:defRPr sz="1650" b="0">
                 <a:solidFill>
                   <a:srgbClr val="53676D"/>
@@ -21562,6 +22298,7 @@
           </a:lstStyle>
           <a:p xmlns:a="http://schemas.openxmlformats.org/drawingml/2006/main">
             <a:pPr>
+              <a:buNone/>
               <a:defRPr sz="1650" b="0">
                 <a:solidFill>
                   <a:srgbClr val="53676D"/>
@@ -21580,7 +22317,7 @@
                 <a:ea typeface="Arial Unicode MS"/>
                 <a:cs typeface="Arial Unicode MS"/>
               </a:rPr>
-              <a:t>extraction_agent.py · 599–604행</a:t>
+              <a:t>extraction_agent.py · 607–612행</a:t>
             </a:r>
           </a:p>
         </p:txBody>
@@ -21628,6 +22365,7 @@
               </a:defRPr>
             </a:defPPr>
             <a:lvl1pPr>
+              <a:buNone/>
               <a:defRPr sz="1500" b="0">
                 <a:solidFill>
                   <a:srgbClr val="173C46"/>
@@ -21638,6 +22376,7 @@
               </a:defRPr>
             </a:lvl1pPr>
             <a:lvl2pPr>
+              <a:buNone/>
               <a:defRPr sz="1500" b="0">
                 <a:solidFill>
                   <a:srgbClr val="173C46"/>
@@ -21648,6 +22387,7 @@
               </a:defRPr>
             </a:lvl2pPr>
             <a:lvl3pPr>
+              <a:buNone/>
               <a:defRPr sz="1500" b="0">
                 <a:solidFill>
                   <a:srgbClr val="173C46"/>
@@ -21658,6 +22398,7 @@
               </a:defRPr>
             </a:lvl3pPr>
             <a:lvl4pPr>
+              <a:buNone/>
               <a:defRPr sz="1500" b="0">
                 <a:solidFill>
                   <a:srgbClr val="173C46"/>
@@ -21668,6 +22409,7 @@
               </a:defRPr>
             </a:lvl4pPr>
             <a:lvl5pPr>
+              <a:buNone/>
               <a:defRPr sz="1500" b="0">
                 <a:solidFill>
                   <a:srgbClr val="173C46"/>
@@ -21678,6 +22420,7 @@
               </a:defRPr>
             </a:lvl5pPr>
             <a:lvl6pPr>
+              <a:buNone/>
               <a:defRPr sz="1500" b="0">
                 <a:solidFill>
                   <a:srgbClr val="173C46"/>
@@ -21688,6 +22431,7 @@
               </a:defRPr>
             </a:lvl6pPr>
             <a:lvl7pPr>
+              <a:buNone/>
               <a:defRPr sz="1500" b="0">
                 <a:solidFill>
                   <a:srgbClr val="173C46"/>
@@ -21698,6 +22442,7 @@
               </a:defRPr>
             </a:lvl7pPr>
             <a:lvl8pPr>
+              <a:buNone/>
               <a:defRPr sz="1500" b="0">
                 <a:solidFill>
                   <a:srgbClr val="173C46"/>
@@ -21708,6 +22453,7 @@
               </a:defRPr>
             </a:lvl8pPr>
             <a:lvl9pPr>
+              <a:buNone/>
               <a:defRPr sz="1500" b="0">
                 <a:solidFill>
                   <a:srgbClr val="173C46"/>
@@ -21720,6 +22466,7 @@
           </a:lstStyle>
           <a:p xmlns:a="http://schemas.openxmlformats.org/drawingml/2006/main">
             <a:pPr>
+              <a:buNone/>
               <a:defRPr sz="1500" b="0">
                 <a:solidFill>
                   <a:srgbClr val="173C46"/>
@@ -21743,6 +22490,7 @@
           </a:p>
           <a:p xmlns:a="http://schemas.openxmlformats.org/drawingml/2006/main">
             <a:pPr>
+              <a:buNone/>
               <a:defRPr sz="1500" b="0">
                 <a:solidFill>
                   <a:srgbClr val="173C46"/>
@@ -21766,6 +22514,7 @@
           </a:p>
           <a:p xmlns:a="http://schemas.openxmlformats.org/drawingml/2006/main">
             <a:pPr>
+              <a:buNone/>
               <a:defRPr sz="1500" b="0">
                 <a:solidFill>
                   <a:srgbClr val="173C46"/>
@@ -21789,6 +22538,7 @@
           </a:p>
           <a:p xmlns:a="http://schemas.openxmlformats.org/drawingml/2006/main">
             <a:pPr>
+              <a:buNone/>
               <a:defRPr sz="1500" b="0">
                 <a:solidFill>
                   <a:srgbClr val="173C46"/>
@@ -21812,6 +22562,7 @@
           </a:p>
           <a:p xmlns:a="http://schemas.openxmlformats.org/drawingml/2006/main">
             <a:pPr>
+              <a:buNone/>
               <a:defRPr sz="1500" b="0">
                 <a:solidFill>
                   <a:srgbClr val="173C46"/>
@@ -21835,6 +22586,7 @@
           </a:p>
           <a:p xmlns:a="http://schemas.openxmlformats.org/drawingml/2006/main">
             <a:pPr>
+              <a:buNone/>
               <a:defRPr sz="1500" b="0">
                 <a:solidFill>
                   <a:srgbClr val="173C46"/>
@@ -21853,7 +22605,7 @@
                 <a:ea typeface="Arial Unicode MS"/>
                 <a:cs typeface="Arial Unicode MS"/>
               </a:rPr>
-              <a:t>    value = request(payload, remaining)</a:t>
+              <a:t>    execution["calls_attempted"] += 1</a:t>
             </a:r>
           </a:p>
         </p:txBody>
@@ -21901,6 +22653,7 @@
               </a:defRPr>
             </a:defPPr>
             <a:lvl1pPr>
+              <a:buNone/>
               <a:defRPr sz="1725" b="0">
                 <a:solidFill>
                   <a:srgbClr val="15796D"/>
@@ -21911,6 +22664,7 @@
               </a:defRPr>
             </a:lvl1pPr>
             <a:lvl2pPr>
+              <a:buNone/>
               <a:defRPr sz="1725" b="0">
                 <a:solidFill>
                   <a:srgbClr val="15796D"/>
@@ -21921,6 +22675,7 @@
               </a:defRPr>
             </a:lvl2pPr>
             <a:lvl3pPr>
+              <a:buNone/>
               <a:defRPr sz="1725" b="0">
                 <a:solidFill>
                   <a:srgbClr val="15796D"/>
@@ -21931,6 +22686,7 @@
               </a:defRPr>
             </a:lvl3pPr>
             <a:lvl4pPr>
+              <a:buNone/>
               <a:defRPr sz="1725" b="0">
                 <a:solidFill>
                   <a:srgbClr val="15796D"/>
@@ -21941,6 +22697,7 @@
               </a:defRPr>
             </a:lvl4pPr>
             <a:lvl5pPr>
+              <a:buNone/>
               <a:defRPr sz="1725" b="0">
                 <a:solidFill>
                   <a:srgbClr val="15796D"/>
@@ -21951,6 +22708,7 @@
               </a:defRPr>
             </a:lvl5pPr>
             <a:lvl6pPr>
+              <a:buNone/>
               <a:defRPr sz="1725" b="0">
                 <a:solidFill>
                   <a:srgbClr val="15796D"/>
@@ -21961,6 +22719,7 @@
               </a:defRPr>
             </a:lvl6pPr>
             <a:lvl7pPr>
+              <a:buNone/>
               <a:defRPr sz="1725" b="0">
                 <a:solidFill>
                   <a:srgbClr val="15796D"/>
@@ -21971,6 +22730,7 @@
               </a:defRPr>
             </a:lvl7pPr>
             <a:lvl8pPr>
+              <a:buNone/>
               <a:defRPr sz="1725" b="0">
                 <a:solidFill>
                   <a:srgbClr val="15796D"/>
@@ -21981,6 +22741,7 @@
               </a:defRPr>
             </a:lvl8pPr>
             <a:lvl9pPr>
+              <a:buNone/>
               <a:defRPr sz="1725" b="0">
                 <a:solidFill>
                   <a:srgbClr val="15796D"/>
@@ -21993,6 +22754,7 @@
           </a:lstStyle>
           <a:p xmlns:a="http://schemas.openxmlformats.org/drawingml/2006/main">
             <a:pPr>
+              <a:buNone/>
               <a:defRPr sz="1725" b="0">
                 <a:solidFill>
                   <a:srgbClr val="15796D"/>
@@ -22011,11 +22773,12 @@
                 <a:ea typeface="Arial Unicode MS"/>
                 <a:cs typeface="Arial Unicode MS"/>
               </a:rPr>
-              <a:t>추출 한 번당 최대 2회 · 총 90초 예산</a:t>
+              <a:t>최대 2회 · 전체 90초 예산</a:t>
             </a:r>
           </a:p>
           <a:p xmlns:a="http://schemas.openxmlformats.org/drawingml/2006/main">
             <a:pPr>
+              <a:buNone/>
               <a:defRPr sz="1725" b="0">
                 <a:solidFill>
                   <a:srgbClr val="15796D"/>
@@ -22034,7 +22797,7 @@
                 <a:ea typeface="Arial Unicode MS"/>
                 <a:cs typeface="Arial Unicode MS"/>
               </a:rPr>
-              <a:t>근거 없음: 추가 추출 생략 / 검증 실패: 보류</a:t>
+              <a:t>OpenAI 선택 · 자동 대체 호출 없음</a:t>
             </a:r>
           </a:p>
         </p:txBody>
@@ -22082,6 +22845,7 @@
               </a:defRPr>
             </a:defPPr>
             <a:lvl1pPr>
+              <a:buNone/>
               <a:defRPr sz="1575" b="0">
                 <a:solidFill>
                   <a:srgbClr val="53676D"/>
@@ -22092,6 +22856,7 @@
               </a:defRPr>
             </a:lvl1pPr>
             <a:lvl2pPr>
+              <a:buNone/>
               <a:defRPr sz="1575" b="0">
                 <a:solidFill>
                   <a:srgbClr val="53676D"/>
@@ -22102,6 +22867,7 @@
               </a:defRPr>
             </a:lvl2pPr>
             <a:lvl3pPr>
+              <a:buNone/>
               <a:defRPr sz="1575" b="0">
                 <a:solidFill>
                   <a:srgbClr val="53676D"/>
@@ -22112,6 +22878,7 @@
               </a:defRPr>
             </a:lvl3pPr>
             <a:lvl4pPr>
+              <a:buNone/>
               <a:defRPr sz="1575" b="0">
                 <a:solidFill>
                   <a:srgbClr val="53676D"/>
@@ -22122,6 +22889,7 @@
               </a:defRPr>
             </a:lvl4pPr>
             <a:lvl5pPr>
+              <a:buNone/>
               <a:defRPr sz="1575" b="0">
                 <a:solidFill>
                   <a:srgbClr val="53676D"/>
@@ -22132,6 +22900,7 @@
               </a:defRPr>
             </a:lvl5pPr>
             <a:lvl6pPr>
+              <a:buNone/>
               <a:defRPr sz="1575" b="0">
                 <a:solidFill>
                   <a:srgbClr val="53676D"/>
@@ -22142,6 +22911,7 @@
               </a:defRPr>
             </a:lvl6pPr>
             <a:lvl7pPr>
+              <a:buNone/>
               <a:defRPr sz="1575" b="0">
                 <a:solidFill>
                   <a:srgbClr val="53676D"/>
@@ -22152,6 +22922,7 @@
               </a:defRPr>
             </a:lvl7pPr>
             <a:lvl8pPr>
+              <a:buNone/>
               <a:defRPr sz="1575" b="0">
                 <a:solidFill>
                   <a:srgbClr val="53676D"/>
@@ -22162,6 +22933,7 @@
               </a:defRPr>
             </a:lvl8pPr>
             <a:lvl9pPr>
+              <a:buNone/>
               <a:defRPr sz="1575" b="0">
                 <a:solidFill>
                   <a:srgbClr val="53676D"/>
@@ -22174,6 +22946,7 @@
           </a:lstStyle>
           <a:p xmlns:a="http://schemas.openxmlformats.org/drawingml/2006/main">
             <a:pPr>
+              <a:buNone/>
               <a:defRPr sz="1575" b="0">
                 <a:solidFill>
                   <a:srgbClr val="53676D"/>
@@ -22197,6 +22970,7 @@
           </a:p>
           <a:p xmlns:a="http://schemas.openxmlformats.org/drawingml/2006/main">
             <a:pPr>
+              <a:buNone/>
               <a:defRPr sz="1575" b="0">
                 <a:solidFill>
                   <a:srgbClr val="53676D"/>
@@ -22740,29 +23514,7 @@
                 <a:ea typeface="Arial Unicode MS"/>
                 <a:cs typeface="Arial Unicode MS"/>
               </a:rPr>
-              <a:t>extraction_agent.py  ·  </a:t>
-            </a:r>
-            <a:r>
-              <a:rPr sz="1650" b="0">
-                <a:solidFill>
-                  <a:srgbClr val="53676D"/>
-                </a:solidFill>
-                <a:latin typeface="Arial Unicode MS"/>
-                <a:ea typeface="Arial Unicode MS"/>
-                <a:cs typeface="Arial Unicode MS"/>
-              </a:rPr>
-              <a:t>314–322</a:t>
-            </a:r>
-            <a:r>
-              <a:rPr sz="1650" b="0">
-                <a:solidFill>
-                  <a:srgbClr val="53676D"/>
-                </a:solidFill>
-                <a:latin typeface="Arial Unicode MS"/>
-                <a:ea typeface="Arial Unicode MS"/>
-                <a:cs typeface="Arial Unicode MS"/>
-              </a:rPr>
-              <a:t>행, 실제 코드 일부</a:t>
+              <a:t>extraction_agent.py · 315–323행, 실제 코드 일부</a:t>
             </a:r>
           </a:p>
         </p:txBody>
@@ -23839,29 +24591,7 @@
                 <a:ea typeface="Arial Unicode MS"/>
                 <a:cs typeface="Arial Unicode MS"/>
               </a:rPr>
-              <a:t>extraction_agent.py  ·  </a:t>
-            </a:r>
-            <a:r>
-              <a:rPr sz="1650" b="0">
-                <a:solidFill>
-                  <a:srgbClr val="53676D"/>
-                </a:solidFill>
-                <a:latin typeface="Arial Unicode MS"/>
-                <a:ea typeface="Arial Unicode MS"/>
-                <a:cs typeface="Arial Unicode MS"/>
-              </a:rPr>
-              <a:t>544–551</a:t>
-            </a:r>
-            <a:r>
-              <a:rPr sz="1650" b="0">
-                <a:solidFill>
-                  <a:srgbClr val="53676D"/>
-                </a:solidFill>
-                <a:latin typeface="Arial Unicode MS"/>
-                <a:ea typeface="Arial Unicode MS"/>
-                <a:cs typeface="Arial Unicode MS"/>
-              </a:rPr>
-              <a:t>행, 수치 검증 분기</a:t>
+              <a:t>extraction_agent.py · 545–552행, 수치 검증 분기</a:t>
             </a:r>
           </a:p>
         </p:txBody>
@@ -25967,7 +26697,7 @@
                 <a:ea typeface="Arial Unicode MS"/>
                 <a:cs typeface="Arial Unicode MS"/>
               </a:rPr>
-              <a:t>test_extraction_agent.py  ·  86–94행, 고정 응답 시험</a:t>
+              <a:t>test_extraction_agent.py · 128–136행, 고정 응답 시험</a:t>
             </a:r>
           </a:p>
         </p:txBody>

</xml_diff>

<commit_message>
docs: polish presentation evidence and five-minute narration
</commit_message>
<xml_diff>
--- a/output/presentations/transformer-spec-review-presentation.pptx
+++ b/output/presentations/transformer-spec-review-presentation.pptx
@@ -2,30 +2,30 @@
 <file path=ppt/presentation.xml><?xml version="1.0" encoding="utf-8"?>
 <p:presentation xmlns:p="http://schemas.openxmlformats.org/presentationml/2006/main">
   <p:sldMasterIdLst>
-    <p:sldMasterId xmlns:r="http://schemas.openxmlformats.org/officeDocument/2006/relationships" id="2147483648" r:id="R4bf1340fdbf74b6a"/>
+    <p:sldMasterId xmlns:r="http://schemas.openxmlformats.org/officeDocument/2006/relationships" id="2147483648" r:id="Rdb67dd0f6dd0496a"/>
   </p:sldMasterIdLst>
   <p:notesMasterIdLst>
-    <p:notesMasterId xmlns:r="http://schemas.openxmlformats.org/officeDocument/2006/relationships" r:id="Ra5e1873709314fb8"/>
+    <p:notesMasterId xmlns:r="http://schemas.openxmlformats.org/officeDocument/2006/relationships" r:id="R24fe7a1497c14ad0"/>
   </p:notesMasterIdLst>
   <p:sldIdLst>
-    <p:sldId xmlns:r="http://schemas.openxmlformats.org/officeDocument/2006/relationships" id="256" r:id="Rbb670d6ace194cdf"/>
-    <p:sldId xmlns:r="http://schemas.openxmlformats.org/officeDocument/2006/relationships" id="257" r:id="R34703501f57f4eea"/>
-    <p:sldId xmlns:r="http://schemas.openxmlformats.org/officeDocument/2006/relationships" id="258" r:id="Rd591afa647864aec"/>
-    <p:sldId xmlns:r="http://schemas.openxmlformats.org/officeDocument/2006/relationships" id="259" r:id="R6883505e3f594929"/>
-    <p:sldId xmlns:r="http://schemas.openxmlformats.org/officeDocument/2006/relationships" id="260" r:id="R87e64e5082a54a6b"/>
-    <p:sldId xmlns:r="http://schemas.openxmlformats.org/officeDocument/2006/relationships" id="261" r:id="Re05df6207b874055"/>
-    <p:sldId xmlns:r="http://schemas.openxmlformats.org/officeDocument/2006/relationships" id="262" r:id="Re85dc68893304d5a"/>
-    <p:sldId xmlns:r="http://schemas.openxmlformats.org/officeDocument/2006/relationships" id="263" r:id="R9c4342c4c95a476f"/>
-    <p:sldId xmlns:r="http://schemas.openxmlformats.org/officeDocument/2006/relationships" id="264" r:id="R6018f2f3ed7e4402"/>
-    <p:sldId xmlns:r="http://schemas.openxmlformats.org/officeDocument/2006/relationships" id="265" r:id="Rdd90de80656745e1"/>
-    <p:sldId xmlns:r="http://schemas.openxmlformats.org/officeDocument/2006/relationships" id="266" r:id="Rc6aa489ee62d4fdc"/>
-    <p:sldId xmlns:r="http://schemas.openxmlformats.org/officeDocument/2006/relationships" id="267" r:id="R93ac106e67194b44"/>
-    <p:sldId xmlns:r="http://schemas.openxmlformats.org/officeDocument/2006/relationships" id="268" r:id="R84c06c198bb5458a"/>
-    <p:sldId xmlns:r="http://schemas.openxmlformats.org/officeDocument/2006/relationships" id="269" r:id="R0bc45d243310488a"/>
-    <p:sldId xmlns:r="http://schemas.openxmlformats.org/officeDocument/2006/relationships" id="270" r:id="R1535d811a7e244ba"/>
-    <p:sldId xmlns:r="http://schemas.openxmlformats.org/officeDocument/2006/relationships" id="271" r:id="R4aa850c92039424c"/>
-    <p:sldId xmlns:r="http://schemas.openxmlformats.org/officeDocument/2006/relationships" id="272" r:id="R6241c7b38a30450b"/>
-    <p:sldId xmlns:r="http://schemas.openxmlformats.org/officeDocument/2006/relationships" id="273" r:id="R1f8c980409ed4ddf"/>
+    <p:sldId xmlns:r="http://schemas.openxmlformats.org/officeDocument/2006/relationships" id="256" r:id="Red803c92ce1b4b21"/>
+    <p:sldId xmlns:r="http://schemas.openxmlformats.org/officeDocument/2006/relationships" id="257" r:id="R1bd31e0e0bd846f1"/>
+    <p:sldId xmlns:r="http://schemas.openxmlformats.org/officeDocument/2006/relationships" id="258" r:id="R9351da65dbfd45f3"/>
+    <p:sldId xmlns:r="http://schemas.openxmlformats.org/officeDocument/2006/relationships" id="259" r:id="R09decbf858e447c2"/>
+    <p:sldId xmlns:r="http://schemas.openxmlformats.org/officeDocument/2006/relationships" id="260" r:id="R0712ef051f3649da"/>
+    <p:sldId xmlns:r="http://schemas.openxmlformats.org/officeDocument/2006/relationships" id="261" r:id="R948db49bad4d45ad"/>
+    <p:sldId xmlns:r="http://schemas.openxmlformats.org/officeDocument/2006/relationships" id="262" r:id="R51470069d1aa4287"/>
+    <p:sldId xmlns:r="http://schemas.openxmlformats.org/officeDocument/2006/relationships" id="263" r:id="Rf2c968df3b554830"/>
+    <p:sldId xmlns:r="http://schemas.openxmlformats.org/officeDocument/2006/relationships" id="264" r:id="R481da579e277473d"/>
+    <p:sldId xmlns:r="http://schemas.openxmlformats.org/officeDocument/2006/relationships" id="265" r:id="Rd84c84f3a3d54fac"/>
+    <p:sldId xmlns:r="http://schemas.openxmlformats.org/officeDocument/2006/relationships" id="266" r:id="Re4575d7ac258430b"/>
+    <p:sldId xmlns:r="http://schemas.openxmlformats.org/officeDocument/2006/relationships" id="267" r:id="R7f8de5348db64456"/>
+    <p:sldId xmlns:r="http://schemas.openxmlformats.org/officeDocument/2006/relationships" id="268" r:id="R24493557294148c0"/>
+    <p:sldId xmlns:r="http://schemas.openxmlformats.org/officeDocument/2006/relationships" id="269" r:id="R8d7dbe2892464726"/>
+    <p:sldId xmlns:r="http://schemas.openxmlformats.org/officeDocument/2006/relationships" id="270" r:id="R0efaa03a59954418"/>
+    <p:sldId xmlns:r="http://schemas.openxmlformats.org/officeDocument/2006/relationships" id="271" r:id="Ra16dd8ae42f5435a"/>
+    <p:sldId xmlns:r="http://schemas.openxmlformats.org/officeDocument/2006/relationships" id="272" r:id="R2f1860629ffb42f2"/>
+    <p:sldId xmlns:r="http://schemas.openxmlformats.org/officeDocument/2006/relationships" id="273" r:id="R507faf08bde94571"/>
   </p:sldIdLst>
   <p:sldSz cx="12192000" cy="6858000"/>
   <p:notesSz cx="6858000" cy="9144000"/>
@@ -459,7 +459,12 @@
           <a:lstStyle xmlns:a="http://schemas.openxmlformats.org/drawingml/2006/main"/>
           <a:p xmlns:a="http://schemas.openxmlformats.org/drawingml/2006/main">
             <a:r>
-              <a:t>[0:00–0:08 / 본 발표 1장] 안녕하세요. G077 문성도입니다. 과제 2로 변압기 수주 기술사양 검토 AI를 만들었습니다. 본 발표는 9장이고 이후 9장은 질문용 부록입니다. 2분 동안 주제와 결과를 설명한 뒤 3분 동안 실제 코드를 설명합니다.</a:t>
+              <a:t>[0:00–0:08 / 본 발표 1장]</a:t>
+            </a:r>
+          </a:p>
+          <a:p xmlns:a="http://schemas.openxmlformats.org/drawingml/2006/main">
+            <a:r>
+              <a:t>안녕하세요. G077 문성도입니다. 과제 2로 변압기 수주 기술사양 검토 AI를 만들었습니다.</a:t>
             </a:r>
           </a:p>
         </p:txBody>
@@ -1244,7 +1249,22 @@
           <a:lstStyle xmlns:a="http://schemas.openxmlformats.org/drawingml/2006/main"/>
           <a:p xmlns:a="http://schemas.openxmlformats.org/drawingml/2006/main">
             <a:r>
-              <a:t>[0:08–0:25 / 본 발표 2장] 수주 확정 후 기술 인계회의 전에 고객 요구와 변경 합의가 내부 인계표에 반영됐는지 확인하는 서비스입니다. 상세 설계·구매로 넘어가기 전에 문서 차이를 찾아 담당자가 원문을 확인하도록 돕는 것이 목적입니다. 440 V와 380 V는 팬 보조전원 변경 미반영을 구성한 가상 사례이며 주회로 전압 예시가 아닙니다.</a:t>
+              <a:t>[0:08–0:25 / 본 발표 2장]</a:t>
+            </a:r>
+          </a:p>
+          <a:p xmlns:a="http://schemas.openxmlformats.org/drawingml/2006/main">
+            <a:r>
+              <a:t>수주 후 기술 인계회의 전에 고객 요구와 승인 변경이 인계표에 반영됐는지 확인하고, 담당자가 원문을 찾도록 돕는 서비스입니다.</a:t>
+            </a:r>
+          </a:p>
+          <a:p xmlns:a="http://schemas.openxmlformats.org/drawingml/2006/main">
+            <a:r>
+              <a:t/>
+            </a:r>
+          </a:p>
+          <a:p xmlns:a="http://schemas.openxmlformats.org/drawingml/2006/main">
+            <a:r>
+              <a:t>440 V와 380 V는 팬 보조전원 변경 미반영을 구성한 가상 사례이며 주회로 전압 예시가 아닙니다.</a:t>
             </a:r>
           </a:p>
         </p:txBody>
@@ -1314,7 +1334,22 @@
           <a:lstStyle xmlns:a="http://schemas.openxmlformats.org/drawingml/2006/main"/>
           <a:p xmlns:a="http://schemas.openxmlformats.org/drawingml/2006/main">
             <a:r>
-              <a:t>[0:25–0:50 / 본 발표 3장] 입력은 고객 사양서, 변경 합의서, 내부 인계표의 텍스트 PDF 세 종류입니다. 고객사를 확인하고 근거를 검색해 값을 추출한 다음, 담당자가 적용할 변경을 확인하면 열 개 사양을 비교합니다. 양쪽 원문을 연결하고 결과 저장과 회의용 보고서까지 제공합니다. 스캔·도면·임의 문서 전체를 지원한다는 뜻은 아닙니다.</a:t>
+              <a:t>[0:25–0:50 · 주요 task]</a:t>
+            </a:r>
+          </a:p>
+          <a:p xmlns:a="http://schemas.openxmlformats.org/drawingml/2006/main">
+            <a:r>
+              <a:t>입력은 고객 사양서, 변경 합의서, 내부 인계표입니다. AI가 근거와 값을 제안하고, 담당자가 적용할 변경을 확인하면 코드가 열 개 사양을 비교합니다. 양쪽 원문을 연결하고 저장한 결과를 회의용 보고서로 엽니다.</a:t>
+            </a:r>
+          </a:p>
+          <a:p xmlns:a="http://schemas.openxmlformats.org/drawingml/2006/main">
+            <a:r>
+              <a:t/>
+            </a:r>
+          </a:p>
+          <a:p xmlns:a="http://schemas.openxmlformats.org/drawingml/2006/main">
+            <a:r>
+              <a:t>지원 범위는 지정 형식의 텍스트 PDF 세 종류입니다. 스캔·도면·임의 문서 전체를 지원한다는 뜻은 아닙니다.</a:t>
             </a:r>
           </a:p>
         </p:txBody>
@@ -1384,17 +1419,42 @@
           <a:lstStyle xmlns:a="http://schemas.openxmlformats.org/drawingml/2006/main"/>
           <a:p xmlns:a="http://schemas.openxmlformats.org/drawingml/2006/main">
             <a:r>
-              <a:t>[0:50–2:00 / 본 발표 4장] 직접 만든 가상 V01 문서로 OpenAI의 gpt-4o-mini를 실제 호출한 결과입니다. 두 요청이 완료됐고 제안된 21개 값이 원문 검증을 통과했습니다. 팬 전원 요구 440 V와 인계값 380 V의 차이를 코드가 비교해 9일치·1불일치로 표시했습니다. 오른쪽은 실제 저장된 회의용 보고서 상단 발췌이고 왼쪽은 같은 기록의 핵심 값입니다.</a:t>
+              <a:t>[0:50–1:25 · 실제 실행 결과]</a:t>
             </a:r>
           </a:p>
           <a:p xmlns:a="http://schemas.openxmlformats.org/drawingml/2006/main">
             <a:r>
-              <a:t>Python 자동 검사 444개와 화면 모의 검사 71개는 코드 검증이며 현업 AI 정확도는 아닙니다. 근거 연결과 불명확한 값의 보류가 중요했습니다. 현재는 지정 형식의 가상 텍스트 PDF만 지원하고 외부 전송·과금에 동의한 자료만 사용합니다. 후속 과제는 독립 문서 평가와 검색 방식·비용·지연 비교입니다. 설계 승인은 수행하지 않습니다.</a:t>
+              <a:t>결과는 아홉 개 일치와 한 개 불일치입니다. 변경 합의서 1쪽은 팬 전원 440 V를 요구하지만 인계표 2쪽에는 380 V가 남아 있습니다. 오른쪽에서 양쪽 원문을 바로 확인할 수 있습니다. 직접 만든 가상 문서로 OpenAI의 gpt-4o-mini를 사전에 실제 호출한 뒤 저장한 결과입니다.</a:t>
             </a:r>
           </a:p>
           <a:p xmlns:a="http://schemas.openxmlformats.org/drawingml/2006/main">
             <a:r>
-              <a:t>2:00에 코드 설명으로 전환합니다. 출처: reports/openai-validation-20261021.json; output/openai-v01-result.png. 실행 코드 887da6e. 실시간 AI 대기는 본 발표에서 제외합니다.</a:t>
+              <a:t/>
+            </a:r>
+          </a:p>
+          <a:p xmlns:a="http://schemas.openxmlformats.org/drawingml/2006/main">
+            <a:r>
+              <a:t>[1:25–2:00 · 검증, 느낀 점과 개선 방향]</a:t>
+            </a:r>
+          </a:p>
+          <a:p xmlns:a="http://schemas.openxmlformats.org/drawingml/2006/main">
+            <a:r>
+              <a:t>구현하면서 답을 만드는 것만큼 근거 연결과 불명확한 값의 보류가 중요하다고 느꼈습니다. 자동검사와 가상 사례의 성공이 현업 AI 정확도를 뜻하지는 않습니다. 현재는 지정 형식의 텍스트 PDF에 한정하며 외부 전송과 과금에 동의한 자료만 사용합니다. 다음에는 독립 문서 평가와 비용·지연 비교가 필요합니다. 설계 승인은 수행하지 않습니다.</a:t>
+            </a:r>
+          </a:p>
+          <a:p xmlns:a="http://schemas.openxmlformats.org/drawingml/2006/main">
+            <a:r>
+              <a:t/>
+            </a:r>
+          </a:p>
+          <a:p xmlns:a="http://schemas.openxmlformats.org/drawingml/2006/main">
+            <a:r>
+              <a:t>오른쪽은 저장 보고서의 팬 전원 양쪽 원문을 확대한 실제 캡처입니다. 원문 이미지의 내용은 수정하지 않았습니다.</a:t>
+            </a:r>
+          </a:p>
+          <a:p xmlns:a="http://schemas.openxmlformats.org/drawingml/2006/main">
+            <a:r>
+              <a:t>출처: reports/openai-validation-20261021.json; output/openai-v01-fan-evidence.jpg. 실행 코드 887da6e. 상세 검사 수치는 부록 12장입니다.</a:t>
             </a:r>
           </a:p>
         </p:txBody>
@@ -1464,12 +1524,22 @@
           <a:lstStyle xmlns:a="http://schemas.openxmlformats.org/drawingml/2006/main"/>
           <a:p xmlns:a="http://schemas.openxmlformats.org/drawingml/2006/main">
             <a:r>
-              <a:t>[2:00–2:45 / 본 발표 5장] extract_upload에서 서버 시작 설정에 맞는 OpenAI 요청 함수를 선택합니다. 첫 호출로 검색 계획을 받고 Python이 내부 검색을 실행합니다. 근거가 있으면 두 번째 호출로 값을 제안받고 원문과 검증하며 없으면 생략합니다. 최대 2회와 전체 90초 예산을 검사하고 다른 제공업체로 자동 전환하지 않습니다. 직접 작성한 Python 제어 흐름이며 Multi-Agent·MCP·LangGraph·LangSmith는 미사용입니다. 별도 AI 구조 확인 버튼은 추가 모델 요청 경로입니다.</a:t>
+              <a:t>[2:00–2:45 · Agent 실행 구조와 미사용 기술]</a:t>
             </a:r>
           </a:p>
           <a:p xmlns:a="http://schemas.openxmlformats.org/drawingml/2006/main">
             <a:r>
-              <a:t>실제 발췌 extraction_agent.py607–612행, 요청 선택600행, 실제 요청614행, 검색 계획624행, 검색632행, 추출643행, 거절684행. OpenAI 연결은 llm_backend.py199행입니다. 서버 측 키만 사용하고 화면·보고서에 키를 포함하지 않습니다. 정형 모드는 AI 단계를 거치지 않습니다.</a:t>
+              <a:t>extract_upload가 순서를 제어합니다. 첫 호출로 검색 계획을 받고 내부 검색 함수를 실행합니다. 근거가 있으면 두 번째 호출로 값을 제안받아 검증하고, 없으면 호출을 생략합니다. 최대 두 번과 전체 90초로 제한하며 다른 제공업체로 자동 전환하지 않습니다. 별도 Graph 프레임워크나 MCP 없이 Python으로 제어합니다.</a:t>
+            </a:r>
+          </a:p>
+          <a:p xmlns:a="http://schemas.openxmlformats.org/drawingml/2006/main">
+            <a:r>
+              <a:t/>
+            </a:r>
+          </a:p>
+          <a:p xmlns:a="http://schemas.openxmlformats.org/drawingml/2006/main">
+            <a:r>
+              <a:t>코드: extraction_agent.py607–612행. 요청 선택600행, 검색 계획624행, 검색632행, 추출643행, 거절684행. OpenAI 연결 llm_backend.py199행. Multi-Agent·MCP·LangGraph·LangSmith는 미사용입니다.</a:t>
             </a:r>
           </a:p>
         </p:txBody>
@@ -1539,12 +1609,22 @@
           <a:lstStyle xmlns:a="http://schemas.openxmlformats.org/drawingml/2006/main"/>
           <a:p xmlns:a="http://schemas.openxmlformats.org/drawingml/2006/main">
             <a:r>
-              <a:t>[2:45–3:30 / 본 발표 6장] _search_documents는 문서 ID·항목·검색어를 받습니다. 지정 별칭으로 찾은 원문에 검색어 포함 점수를 매기고 페이지와 위치 순으로 정렬합니다. 요청별 상위 두 근거를 문자 예산 안에서 반환하고 문서 ID·페이지·인용문을 보존합니다. 그 근거를 다음 AI 추출 요청에 전달하는 키워드 기반 RAG입니다. 임베딩·벡터 DB는 쓰지 않았고 검색에서 놓친 정보까지 알아낸다고 보장하지 않습니다.</a:t>
+              <a:t>[2:45–3:30 · 키워드 기반 RAG]</a:t>
             </a:r>
           </a:p>
           <a:p xmlns:a="http://schemas.openxmlformats.org/drawingml/2006/main">
             <a:r>
-              <a:t>실제 발췌 extraction_agent.py315–323행. 함수301행, 근거 필드324–326행, 다음 호출의 근거 전달665행. 공통 들여쓰기만 제거했습니다.</a:t>
+              <a:t>팬 전원 사례로 보겠습니다. _search_documents는 항목 별칭으로 찾은 원문에 검색어 점수를 매깁니다. 강조한 코드가 이를 정렬하고 상위 두 구간을 선택합니다. 문서·페이지·인용문을 보존해 다음 AI 요청에 보내는 키워드 기반 RAG입니다. 벡터 검색은 아니며, 검색에서 놓친 정보를 알아낸다고 보장하지 않습니다.</a:t>
+            </a:r>
+          </a:p>
+          <a:p xmlns:a="http://schemas.openxmlformats.org/drawingml/2006/main">
+            <a:r>
+              <a:t/>
+            </a:r>
+          </a:p>
+          <a:p xmlns:a="http://schemas.openxmlformats.org/drawingml/2006/main">
+            <a:r>
+              <a:t>코드: extraction_agent.py315–323행. 함수301행, 근거 필드324–326행, 다음 요청의 근거 전달665행. 공통 들여쓰기만 제거했습니다.</a:t>
             </a:r>
           </a:p>
         </p:txBody>
@@ -1614,12 +1694,22 @@
           <a:lstStyle xmlns:a="http://schemas.openxmlformats.org/drawingml/2006/main"/>
           <a:p xmlns:a="http://schemas.openxmlformats.org/drawingml/2006/main">
             <a:r>
-              <a:t>[3:30–4:15 / 본 발표 7장] _validate_proposal은 인용이 실제 페이지와 검색 결과에 있는지 검사합니다. 화면의 수치 분기에서는 원문·인용의 값과 단위, 해당 항목명에 직접 연결되는지를 확인합니다. 숫자가 문서 어딘가에 있다는 이유만으로 채택하지 않습니다. 미확정·부정·중복·조건 충돌이면 거절 이유를 남기고 보류합니다. V02 미기재 주파수처럼 확인되지 않은 값을 코드가 대신 채우지 않습니다.</a:t>
+              <a:t>[3:30–4:15 · 원문과 제안값 검증]</a:t>
             </a:r>
           </a:p>
           <a:p xmlns:a="http://schemas.openxmlformats.org/drawingml/2006/main">
             <a:r>
-              <a:t>실제 발췌 extraction_agent.py545–552행, 함수498행, 거절된 제안 보류684행. 공통 들여쓰기만 제거했습니다.</a:t>
+              <a:t>AI가 440 V를 제안해도 바로 채택하지 않습니다. _validate_proposal은 인용이 실제 원문과 검색 결과에 있는지 확인합니다. 강조한 부분은 값·단위가 일치하고 팬 전원 항목에 직접 연결됐는지 검사합니다. 숫자가 다른 곳에 있거나 값이 미확정·상충이면 보류합니다. 코드는 확인되지 않은 값을 채워 넣지 않습니다.</a:t>
+            </a:r>
+          </a:p>
+          <a:p xmlns:a="http://schemas.openxmlformats.org/drawingml/2006/main">
+            <a:r>
+              <a:t/>
+            </a:r>
+          </a:p>
+          <a:p xmlns:a="http://schemas.openxmlformats.org/drawingml/2006/main">
+            <a:r>
+              <a:t>코드: extraction_agent.py545–552행. 함수498행, 거절된 제안 보류684행. 공통 들여쓰기만 제거했습니다.</a:t>
             </a:r>
           </a:p>
         </p:txBody>
@@ -1689,12 +1779,22 @@
           <a:lstStyle xmlns:a="http://schemas.openxmlformats.org/drawingml/2006/main"/>
           <a:p xmlns:a="http://schemas.openxmlformats.org/drawingml/2006/main">
             <a:r>
-              <a:t>[4:15–4:40 / 본 발표 8장] 최종 비교는 review_case가 수행합니다. 먼저 명시된 변경 적용 관계를 확인하고 단위와 조건을 맞춥니다. 같은 값은 일치, 다르면 불일치이고 출처나 조건이 불확실하면 확인 필요입니다. 승인 표시는 데모 메타데이터이며 실제 결재 권한을 인증하지는 않습니다.</a:t>
+              <a:t>[4:15–4:40 · 사양 비교]</a:t>
             </a:r>
           </a:p>
           <a:p xmlns:a="http://schemas.openxmlformats.org/drawingml/2006/main">
             <a:r>
-              <a:t>실제 발췌 review.py 193–200행. 함수 시작 40행, 변경 관계 122–150행. 명시적 누락 MISSING은 발췌 앞 분기입니다. 공통 들여쓰기만 제거했습니다.</a:t>
+              <a:t>review_case는 승인 변경의 적용 관계와 단위·조건을 확인한 뒤 440 V와 380 V를 비교해 불일치로 표시합니다. 출처나 조건이 불확실하면 보류합니다. 승인 표시는 가상 메타데이터이며 실제 결재 권한 인증은 아닙니다.</a:t>
+            </a:r>
+          </a:p>
+          <a:p xmlns:a="http://schemas.openxmlformats.org/drawingml/2006/main">
+            <a:r>
+              <a:t/>
+            </a:r>
+          </a:p>
+          <a:p xmlns:a="http://schemas.openxmlformats.org/drawingml/2006/main">
+            <a:r>
+              <a:t>코드: review.py193–200행. 변경 관계 확인122행. 비교 전에 출처·적용 관계·단위·조건을 확인합니다. 공통 들여쓰기만 제거했습니다.</a:t>
             </a:r>
           </a:p>
         </p:txBody>
@@ -1764,12 +1864,22 @@
           <a:lstStyle xmlns:a="http://schemas.openxmlformats.org/drawingml/2006/main"/>
           <a:p xmlns:a="http://schemas.openxmlformats.org/drawingml/2006/main">
             <a:r>
-              <a:t>[4:40–5:00 / 본 발표 9장] request_fn에 고정 응답을 넣으면 실제 API 없이 같은 조건을 반복 검사할 수 있습니다. 주입 실행은 실제 OpenAI 호출로 표시하지 않습니다. 예시 검사는 두 요청과 입력 보존을 확인합니다. PDF·추출·비교·연결 모듈을 분리했고 불확실한 값은 담당자에게 남겼습니다. 감사합니다.</a:t>
+              <a:t>[4:40–5:00 · 의존성 주입과 마무리]</a:t>
             </a:r>
           </a:p>
           <a:p xmlns:a="http://schemas.openxmlformats.org/drawingml/2006/main">
             <a:r>
-              <a:t>실제 발췌 tests/test_extraction_agent.py128–136행. 주입 지점 extraction_agent.py600행, 주입 실행 구분 테스트102행. 모의 시험은 모델 정확도를 측정하지 않습니다. 이후 9장은 질의응답용 부록입니다.</a:t>
+              <a:t>request_fn에 고정 응답을 넣어 실제 API 호출 없이 반복 검사합니다. AI는 값을 제안하고, 코드는 검증하며, 최종 판단은 담당자에게 남깁니다. 감사합니다.</a:t>
+            </a:r>
+          </a:p>
+          <a:p xmlns:a="http://schemas.openxmlformats.org/drawingml/2006/main">
+            <a:r>
+              <a:t/>
+            </a:r>
+          </a:p>
+          <a:p xmlns:a="http://schemas.openxmlformats.org/drawingml/2006/main">
+            <a:r>
+              <a:t>화면의 run_with 도우미는 고정 응답을 request_fn으로 주입합니다(tests/test_extraction_agent.py69–71행). 실제 화면 발췌128–136행. 주입 지점 extraction_agent.py600행. 호출 수·입력 보존 시험은 모델 정확도를 측정하지 않습니다. 이후 9장은 질의응답용 부록입니다.</a:t>
             </a:r>
           </a:p>
         </p:txBody>
@@ -4212,12 +4322,12 @@
   </p:cSld>
   <p:clrMap bg1="lt1" tx1="dk1" bg2="lt2" tx2="dk2" accent1="accent1" accent2="accent2" accent3="accent3" accent4="accent4" accent5="accent5" accent6="accent6" hlink="hlink" folHlink="folHlink"/>
   <p:sldLayoutIdLst>
-    <p:sldLayoutId xmlns:r="http://schemas.openxmlformats.org/officeDocument/2006/relationships" id="2147483649" r:id="Rf87fbf0c311c4b6d"/>
-    <p:sldLayoutId xmlns:r="http://schemas.openxmlformats.org/officeDocument/2006/relationships" id="2147483650" r:id="R4402ac0bdd7b4f1f"/>
-    <p:sldLayoutId xmlns:r="http://schemas.openxmlformats.org/officeDocument/2006/relationships" id="2147483651" r:id="R0220ee43c48e4fb0"/>
-    <p:sldLayoutId xmlns:r="http://schemas.openxmlformats.org/officeDocument/2006/relationships" id="2147483652" r:id="R00ca359eef0e4222"/>
-    <p:sldLayoutId xmlns:r="http://schemas.openxmlformats.org/officeDocument/2006/relationships" id="2147483653" r:id="R854c610036b3404b"/>
-    <p:sldLayoutId xmlns:r="http://schemas.openxmlformats.org/officeDocument/2006/relationships" id="2147483654" r:id="R53f8c1d817054ddc"/>
+    <p:sldLayoutId xmlns:r="http://schemas.openxmlformats.org/officeDocument/2006/relationships" id="2147483649" r:id="R08c6ce0cf278452c"/>
+    <p:sldLayoutId xmlns:r="http://schemas.openxmlformats.org/officeDocument/2006/relationships" id="2147483650" r:id="R2688b944862c4600"/>
+    <p:sldLayoutId xmlns:r="http://schemas.openxmlformats.org/officeDocument/2006/relationships" id="2147483651" r:id="R560894b8672442cc"/>
+    <p:sldLayoutId xmlns:r="http://schemas.openxmlformats.org/officeDocument/2006/relationships" id="2147483652" r:id="R50d6bea74c4447b9"/>
+    <p:sldLayoutId xmlns:r="http://schemas.openxmlformats.org/officeDocument/2006/relationships" id="2147483653" r:id="R14e1fdec3a564551"/>
+    <p:sldLayoutId xmlns:r="http://schemas.openxmlformats.org/officeDocument/2006/relationships" id="2147483654" r:id="R2aa89d44de594f31"/>
   </p:sldLayoutIdLst>
   <p:txStyles>
     <p:titleStyle>
@@ -7515,7 +7625,7 @@
           <p:cNvPr id="3" name="">
             <a:extLst xmlns:a="http://schemas.openxmlformats.org/drawingml/2006/main">
               <a:ext uri="{FF2B5EF4-FFF2-40B4-BE49-F238E27FC236}">
-                <a16:creationId xmlns:a16="http://schemas.microsoft.com/office/drawing/2014/main" id="{7383FED1-AB08-4B7B-8900-126BC5B4EDCF}"/>
+                <a16:creationId xmlns:a16="http://schemas.microsoft.com/office/drawing/2014/main" id="{E8FA80D3-276D-4114-A1D6-723248EC0BE2}"/>
               </a:ext>
             </a:extLst>
           </p:cNvPr>
@@ -8488,7 +8598,7 @@
           <p:cNvPr id="3" name="">
             <a:extLst xmlns:a="http://schemas.openxmlformats.org/drawingml/2006/main">
               <a:ext uri="{FF2B5EF4-FFF2-40B4-BE49-F238E27FC236}">
-                <a16:creationId xmlns:a16="http://schemas.microsoft.com/office/drawing/2014/main" id="{4C935696-14A1-44E3-9AC3-EDBCE62CE3D7}"/>
+                <a16:creationId xmlns:a16="http://schemas.microsoft.com/office/drawing/2014/main" id="{0A08EE74-3DA7-4A4E-87ED-679D0952CACB}"/>
               </a:ext>
             </a:extLst>
           </p:cNvPr>
@@ -10026,7 +10136,7 @@
           <p:cNvPr id="3" name="">
             <a:extLst xmlns:a="http://schemas.openxmlformats.org/drawingml/2006/main">
               <a:ext uri="{FF2B5EF4-FFF2-40B4-BE49-F238E27FC236}">
-                <a16:creationId xmlns:a16="http://schemas.microsoft.com/office/drawing/2014/main" id="{AF8CC578-602B-4229-B785-A079F1BC5118}"/>
+                <a16:creationId xmlns:a16="http://schemas.microsoft.com/office/drawing/2014/main" id="{0B814717-62F6-41A0-A439-B88A783A3A99}"/>
               </a:ext>
             </a:extLst>
           </p:cNvPr>
@@ -11094,7 +11204,7 @@
           <p:cNvPr id="3" name="">
             <a:extLst xmlns:a="http://schemas.openxmlformats.org/drawingml/2006/main">
               <a:ext uri="{FF2B5EF4-FFF2-40B4-BE49-F238E27FC236}">
-                <a16:creationId xmlns:a16="http://schemas.microsoft.com/office/drawing/2014/main" id="{F4376342-3670-48B8-8110-126ABF82545C}"/>
+                <a16:creationId xmlns:a16="http://schemas.microsoft.com/office/drawing/2014/main" id="{F62DD1F7-95FD-461D-92E9-8333F9D27C8F}"/>
               </a:ext>
             </a:extLst>
           </p:cNvPr>
@@ -12970,7 +13080,7 @@
           <p:cNvPr id="6" name="">
             <a:extLst xmlns:a="http://schemas.openxmlformats.org/drawingml/2006/main">
               <a:ext uri="{FF2B5EF4-FFF2-40B4-BE49-F238E27FC236}">
-                <a16:creationId xmlns:a16="http://schemas.microsoft.com/office/drawing/2014/main" id="{A2A41CB4-8603-48A4-B3D0-38A4232A567E}"/>
+                <a16:creationId xmlns:a16="http://schemas.microsoft.com/office/drawing/2014/main" id="{0E49729D-9FC1-43C2-9A69-54EBE25D798E}"/>
               </a:ext>
             </a:extLst>
           </p:cNvPr>
@@ -12980,7 +13090,7 @@
           <p:nvPr/>
         </p:nvPicPr>
         <p:blipFill>
-          <a:blip xmlns:r="http://schemas.openxmlformats.org/officeDocument/2006/relationships" xmlns:a="http://schemas.openxmlformats.org/drawingml/2006/main" r:embed="Rf55cee7ff9784345"/>
+          <a:blip xmlns:r="http://schemas.openxmlformats.org/officeDocument/2006/relationships" xmlns:a="http://schemas.openxmlformats.org/drawingml/2006/main" r:embed="Rf47651f9c0f641b3"/>
           <a:srcRect xmlns:a="http://schemas.openxmlformats.org/drawingml/2006/main" l="3115" t="67834" r="3115" b="19767"/>
           <a:stretch xmlns:a="http://schemas.openxmlformats.org/drawingml/2006/main"/>
         </p:blipFill>
@@ -12999,7 +13109,7 @@
           <p:cNvPr id="7" name="">
             <a:extLst xmlns:a="http://schemas.openxmlformats.org/drawingml/2006/main">
               <a:ext uri="{FF2B5EF4-FFF2-40B4-BE49-F238E27FC236}">
-                <a16:creationId xmlns:a16="http://schemas.microsoft.com/office/drawing/2014/main" id="{4A378DBD-BA47-4B34-BA97-0AB098F3B3D2}"/>
+                <a16:creationId xmlns:a16="http://schemas.microsoft.com/office/drawing/2014/main" id="{EC3A0762-5B20-4F8A-ACAA-821AD16F2FC7}"/>
               </a:ext>
             </a:extLst>
           </p:cNvPr>
@@ -13009,7 +13119,7 @@
           <p:nvPr/>
         </p:nvPicPr>
         <p:blipFill>
-          <a:blip xmlns:r="http://schemas.openxmlformats.org/officeDocument/2006/relationships" xmlns:a="http://schemas.openxmlformats.org/drawingml/2006/main" r:embed="R2e3dfd60f0f8416b"/>
+          <a:blip xmlns:r="http://schemas.openxmlformats.org/officeDocument/2006/relationships" xmlns:a="http://schemas.openxmlformats.org/drawingml/2006/main" r:embed="Rfa61084c4a6a49cf"/>
           <a:srcRect xmlns:a="http://schemas.openxmlformats.org/drawingml/2006/main" l="3115" t="83880" r="3115" b="3866"/>
           <a:stretch xmlns:a="http://schemas.openxmlformats.org/drawingml/2006/main"/>
         </p:blipFill>
@@ -13801,7 +13911,7 @@
           <p:cNvPr id="5" name="">
             <a:extLst xmlns:a="http://schemas.openxmlformats.org/drawingml/2006/main">
               <a:ext uri="{FF2B5EF4-FFF2-40B4-BE49-F238E27FC236}">
-                <a16:creationId xmlns:a16="http://schemas.microsoft.com/office/drawing/2014/main" id="{5855C6AE-099C-4867-A537-092FC7A17E35}"/>
+                <a16:creationId xmlns:a16="http://schemas.microsoft.com/office/drawing/2014/main" id="{1DED6136-48EB-434F-BE90-00044B140A7B}"/>
               </a:ext>
             </a:extLst>
           </p:cNvPr>
@@ -13811,7 +13921,7 @@
           <p:nvPr/>
         </p:nvPicPr>
         <p:blipFill>
-          <a:blip xmlns:r="http://schemas.openxmlformats.org/officeDocument/2006/relationships" xmlns:a="http://schemas.openxmlformats.org/drawingml/2006/main" r:embed="Re4e12ba588c947c3"/>
+          <a:blip xmlns:r="http://schemas.openxmlformats.org/officeDocument/2006/relationships" xmlns:a="http://schemas.openxmlformats.org/drawingml/2006/main" r:embed="Rccd250953f0a4f42"/>
           <a:srcRect xmlns:a="http://schemas.openxmlformats.org/drawingml/2006/main" l="0" t="12048" r="2294" b="12851"/>
           <a:stretch xmlns:a="http://schemas.openxmlformats.org/drawingml/2006/main"/>
         </p:blipFill>
@@ -14363,7 +14473,7 @@
           <p:cNvPr id="3" name="">
             <a:extLst xmlns:a="http://schemas.openxmlformats.org/drawingml/2006/main">
               <a:ext uri="{FF2B5EF4-FFF2-40B4-BE49-F238E27FC236}">
-                <a16:creationId xmlns:a16="http://schemas.microsoft.com/office/drawing/2014/main" id="{CBA109A8-F57C-4607-A0CB-4D65BA61224B}"/>
+                <a16:creationId xmlns:a16="http://schemas.microsoft.com/office/drawing/2014/main" id="{D12E53E5-1696-4FF0-8054-7C8867F5A57A}"/>
               </a:ext>
             </a:extLst>
           </p:cNvPr>
@@ -20135,7 +20245,7 @@
           <p:cNvPr id="3" name="">
             <a:extLst xmlns:a="http://schemas.openxmlformats.org/drawingml/2006/main">
               <a:ext uri="{FF2B5EF4-FFF2-40B4-BE49-F238E27FC236}">
-                <a16:creationId xmlns:a16="http://schemas.microsoft.com/office/drawing/2014/main" id="{2032F115-8ED5-4C76-AA82-518BF8F15AFC}"/>
+                <a16:creationId xmlns:a16="http://schemas.microsoft.com/office/drawing/2014/main" id="{E852331C-58DA-4055-8D0C-D89220599074}"/>
               </a:ext>
             </a:extLst>
           </p:cNvPr>
@@ -20145,14 +20255,14 @@
           <p:nvPr/>
         </p:nvPicPr>
         <p:blipFill>
-          <a:blip xmlns:r="http://schemas.openxmlformats.org/officeDocument/2006/relationships" xmlns:a="http://schemas.openxmlformats.org/drawingml/2006/main" r:embed="R942db37b77864f47"/>
-          <a:srcRect xmlns:a="http://schemas.openxmlformats.org/drawingml/2006/main" l="0" t="12048" r="2294" b="12851"/>
+          <a:blip xmlns:r="http://schemas.openxmlformats.org/officeDocument/2006/relationships" xmlns:a="http://schemas.openxmlformats.org/drawingml/2006/main" r:embed="Rdcce500d69fe4b85"/>
+          <a:srcRect xmlns:a="http://schemas.openxmlformats.org/drawingml/2006/main" l="5354" t="47390" r="6310" b="2008"/>
           <a:stretch xmlns:a="http://schemas.openxmlformats.org/drawingml/2006/main"/>
         </p:blipFill>
         <p:spPr>
           <a:xfrm xmlns:a="http://schemas.openxmlformats.org/drawingml/2006/main">
-            <a:off x="7067550" y="1581150"/>
-            <a:ext cx="4324350" cy="4286250"/>
+            <a:off x="6191250" y="1581150"/>
+            <a:ext cx="5238750" cy="4286250"/>
           </a:xfrm>
           <a:prstGeom xmlns:a="http://schemas.openxmlformats.org/drawingml/2006/main" prst="rect">
             <a:avLst/>
@@ -20322,7 +20432,7 @@
                 <a:ea typeface="Arial Unicode MS"/>
                 <a:cs typeface="Arial Unicode MS"/>
               </a:rPr>
-              <a:t>2026-10-21 가상 PDF 실제 실행 · 오른쪽은 저장 보고서 발췌</a:t>
+              <a:t>2026-10-21 가상 PDF 사전 실제 실행 · 오른쪽은 양쪽 원문 발췌</a:t>
             </a:r>
           </a:p>
           <a:p xmlns:a="http://schemas.openxmlformats.org/drawingml/2006/main">
@@ -20346,7 +20456,7 @@
                 <a:ea typeface="Arial Unicode MS"/>
                 <a:cs typeface="Arial Unicode MS"/>
               </a:rPr>
-              <a:t>Python 444개·화면 모의 71개 통과 | 현업 정확도·절감률 미측정</a:t>
+              <a:t>현업 정확도·시간 절감률은 미측정 · 설계 승인·제작 지시가 아닙니다.</a:t>
             </a:r>
           </a:p>
         </p:txBody>
@@ -20368,7 +20478,7 @@
         <p:spPr>
           <a:xfrm xmlns:a="http://schemas.openxmlformats.org/drawingml/2006/main">
             <a:off x="609600" y="1714500"/>
-            <a:ext cx="6000750" cy="514350"/>
+            <a:ext cx="5286375" cy="514350"/>
           </a:xfrm>
           <a:prstGeom xmlns:a="http://schemas.openxmlformats.org/drawingml/2006/main" prst="rect">
             <a:avLst/>
@@ -20394,6 +20504,7 @@
               </a:defRPr>
             </a:defPPr>
             <a:lvl1pPr>
+              <a:buNone/>
               <a:defRPr sz="2325" b="1">
                 <a:solidFill>
                   <a:srgbClr val="15796D"/>
@@ -20404,6 +20515,7 @@
               </a:defRPr>
             </a:lvl1pPr>
             <a:lvl2pPr>
+              <a:buNone/>
               <a:defRPr sz="2325" b="1">
                 <a:solidFill>
                   <a:srgbClr val="15796D"/>
@@ -20414,6 +20526,7 @@
               </a:defRPr>
             </a:lvl2pPr>
             <a:lvl3pPr>
+              <a:buNone/>
               <a:defRPr sz="2325" b="1">
                 <a:solidFill>
                   <a:srgbClr val="15796D"/>
@@ -20424,6 +20537,7 @@
               </a:defRPr>
             </a:lvl3pPr>
             <a:lvl4pPr>
+              <a:buNone/>
               <a:defRPr sz="2325" b="1">
                 <a:solidFill>
                   <a:srgbClr val="15796D"/>
@@ -20434,6 +20548,7 @@
               </a:defRPr>
             </a:lvl4pPr>
             <a:lvl5pPr>
+              <a:buNone/>
               <a:defRPr sz="2325" b="1">
                 <a:solidFill>
                   <a:srgbClr val="15796D"/>
@@ -20444,6 +20559,7 @@
               </a:defRPr>
             </a:lvl5pPr>
             <a:lvl6pPr>
+              <a:buNone/>
               <a:defRPr sz="2325" b="1">
                 <a:solidFill>
                   <a:srgbClr val="15796D"/>
@@ -20454,6 +20570,7 @@
               </a:defRPr>
             </a:lvl6pPr>
             <a:lvl7pPr>
+              <a:buNone/>
               <a:defRPr sz="2325" b="1">
                 <a:solidFill>
                   <a:srgbClr val="15796D"/>
@@ -20464,6 +20581,7 @@
               </a:defRPr>
             </a:lvl7pPr>
             <a:lvl8pPr>
+              <a:buNone/>
               <a:defRPr sz="2325" b="1">
                 <a:solidFill>
                   <a:srgbClr val="15796D"/>
@@ -20474,6 +20592,7 @@
               </a:defRPr>
             </a:lvl8pPr>
             <a:lvl9pPr>
+              <a:buNone/>
               <a:defRPr sz="2325" b="1">
                 <a:solidFill>
                   <a:srgbClr val="15796D"/>
@@ -20486,6 +20605,7 @@
           </a:lstStyle>
           <a:p xmlns:a="http://schemas.openxmlformats.org/drawingml/2006/main">
             <a:pPr>
+              <a:buNone/>
               <a:defRPr sz="2325" b="1">
                 <a:solidFill>
                   <a:srgbClr val="15796D"/>
@@ -20526,7 +20646,7 @@
         <p:spPr>
           <a:xfrm xmlns:a="http://schemas.openxmlformats.org/drawingml/2006/main">
             <a:off x="609600" y="2400300"/>
-            <a:ext cx="6000750" cy="714375"/>
+            <a:ext cx="5286375" cy="714375"/>
           </a:xfrm>
           <a:prstGeom xmlns:a="http://schemas.openxmlformats.org/drawingml/2006/main" prst="rect">
             <a:avLst/>
@@ -20552,6 +20672,7 @@
               </a:defRPr>
             </a:defPPr>
             <a:lvl1pPr>
+              <a:buNone/>
               <a:defRPr sz="3150" b="1">
                 <a:solidFill>
                   <a:srgbClr val="173C46"/>
@@ -20562,6 +20683,7 @@
               </a:defRPr>
             </a:lvl1pPr>
             <a:lvl2pPr>
+              <a:buNone/>
               <a:defRPr sz="3150" b="1">
                 <a:solidFill>
                   <a:srgbClr val="173C46"/>
@@ -20572,6 +20694,7 @@
               </a:defRPr>
             </a:lvl2pPr>
             <a:lvl3pPr>
+              <a:buNone/>
               <a:defRPr sz="3150" b="1">
                 <a:solidFill>
                   <a:srgbClr val="173C46"/>
@@ -20582,6 +20705,7 @@
               </a:defRPr>
             </a:lvl3pPr>
             <a:lvl4pPr>
+              <a:buNone/>
               <a:defRPr sz="3150" b="1">
                 <a:solidFill>
                   <a:srgbClr val="173C46"/>
@@ -20592,6 +20716,7 @@
               </a:defRPr>
             </a:lvl4pPr>
             <a:lvl5pPr>
+              <a:buNone/>
               <a:defRPr sz="3150" b="1">
                 <a:solidFill>
                   <a:srgbClr val="173C46"/>
@@ -20602,6 +20727,7 @@
               </a:defRPr>
             </a:lvl5pPr>
             <a:lvl6pPr>
+              <a:buNone/>
               <a:defRPr sz="3150" b="1">
                 <a:solidFill>
                   <a:srgbClr val="173C46"/>
@@ -20612,6 +20738,7 @@
               </a:defRPr>
             </a:lvl6pPr>
             <a:lvl7pPr>
+              <a:buNone/>
               <a:defRPr sz="3150" b="1">
                 <a:solidFill>
                   <a:srgbClr val="173C46"/>
@@ -20622,6 +20749,7 @@
               </a:defRPr>
             </a:lvl7pPr>
             <a:lvl8pPr>
+              <a:buNone/>
               <a:defRPr sz="3150" b="1">
                 <a:solidFill>
                   <a:srgbClr val="173C46"/>
@@ -20632,6 +20760,7 @@
               </a:defRPr>
             </a:lvl8pPr>
             <a:lvl9pPr>
+              <a:buNone/>
               <a:defRPr sz="3150" b="1">
                 <a:solidFill>
                   <a:srgbClr val="173C46"/>
@@ -20644,6 +20773,7 @@
           </a:lstStyle>
           <a:p xmlns:a="http://schemas.openxmlformats.org/drawingml/2006/main">
             <a:pPr>
+              <a:buNone/>
               <a:defRPr sz="3150" b="1">
                 <a:solidFill>
                   <a:srgbClr val="173C46"/>
@@ -20684,7 +20814,7 @@
         <p:spPr>
           <a:xfrm xmlns:a="http://schemas.openxmlformats.org/drawingml/2006/main">
             <a:off x="609600" y="3333750"/>
-            <a:ext cx="6191250" cy="1428750"/>
+            <a:ext cx="5286375" cy="1428750"/>
           </a:xfrm>
           <a:prstGeom xmlns:a="http://schemas.openxmlformats.org/drawingml/2006/main" prst="rect">
             <a:avLst/>
@@ -20710,6 +20840,7 @@
               </a:defRPr>
             </a:defPPr>
             <a:lvl1pPr>
+              <a:buNone/>
               <a:defRPr sz="2025" b="0">
                 <a:solidFill>
                   <a:srgbClr val="173C46"/>
@@ -20720,6 +20851,7 @@
               </a:defRPr>
             </a:lvl1pPr>
             <a:lvl2pPr>
+              <a:buNone/>
               <a:defRPr sz="2025" b="0">
                 <a:solidFill>
                   <a:srgbClr val="173C46"/>
@@ -20730,6 +20862,7 @@
               </a:defRPr>
             </a:lvl2pPr>
             <a:lvl3pPr>
+              <a:buNone/>
               <a:defRPr sz="2025" b="0">
                 <a:solidFill>
                   <a:srgbClr val="173C46"/>
@@ -20740,6 +20873,7 @@
               </a:defRPr>
             </a:lvl3pPr>
             <a:lvl4pPr>
+              <a:buNone/>
               <a:defRPr sz="2025" b="0">
                 <a:solidFill>
                   <a:srgbClr val="173C46"/>
@@ -20750,6 +20884,7 @@
               </a:defRPr>
             </a:lvl4pPr>
             <a:lvl5pPr>
+              <a:buNone/>
               <a:defRPr sz="2025" b="0">
                 <a:solidFill>
                   <a:srgbClr val="173C46"/>
@@ -20760,6 +20895,7 @@
               </a:defRPr>
             </a:lvl5pPr>
             <a:lvl6pPr>
+              <a:buNone/>
               <a:defRPr sz="2025" b="0">
                 <a:solidFill>
                   <a:srgbClr val="173C46"/>
@@ -20770,6 +20906,7 @@
               </a:defRPr>
             </a:lvl6pPr>
             <a:lvl7pPr>
+              <a:buNone/>
               <a:defRPr sz="2025" b="0">
                 <a:solidFill>
                   <a:srgbClr val="173C46"/>
@@ -20780,6 +20917,7 @@
               </a:defRPr>
             </a:lvl7pPr>
             <a:lvl8pPr>
+              <a:buNone/>
               <a:defRPr sz="2025" b="0">
                 <a:solidFill>
                   <a:srgbClr val="173C46"/>
@@ -20790,6 +20928,7 @@
               </a:defRPr>
             </a:lvl8pPr>
             <a:lvl9pPr>
+              <a:buNone/>
               <a:defRPr sz="2025" b="0">
                 <a:solidFill>
                   <a:srgbClr val="173C46"/>
@@ -20802,6 +20941,7 @@
           </a:lstStyle>
           <a:p xmlns:a="http://schemas.openxmlformats.org/drawingml/2006/main">
             <a:pPr>
+              <a:buNone/>
               <a:defRPr sz="2025" b="0">
                 <a:solidFill>
                   <a:srgbClr val="173C46"/>
@@ -20825,6 +20965,7 @@
           </a:p>
           <a:p xmlns:a="http://schemas.openxmlformats.org/drawingml/2006/main">
             <a:pPr>
+              <a:buNone/>
               <a:defRPr sz="2025" b="0">
                 <a:solidFill>
                   <a:srgbClr val="173C46"/>
@@ -20848,6 +20989,7 @@
           </a:p>
           <a:p xmlns:a="http://schemas.openxmlformats.org/drawingml/2006/main">
             <a:pPr>
+              <a:buNone/>
               <a:defRPr sz="2025" b="0">
                 <a:solidFill>
                   <a:srgbClr val="173C46"/>
@@ -20888,7 +21030,7 @@
         <p:spPr>
           <a:xfrm xmlns:a="http://schemas.openxmlformats.org/drawingml/2006/main">
             <a:off x="609600" y="5029200"/>
-            <a:ext cx="6286500" cy="609600"/>
+            <a:ext cx="5286375" cy="609600"/>
           </a:xfrm>
           <a:prstGeom xmlns:a="http://schemas.openxmlformats.org/drawingml/2006/main" prst="rect">
             <a:avLst/>
@@ -20914,6 +21056,7 @@
               </a:defRPr>
             </a:defPPr>
             <a:lvl1pPr>
+              <a:buNone/>
               <a:defRPr sz="1800" b="0">
                 <a:solidFill>
                   <a:srgbClr val="15796D"/>
@@ -20924,6 +21067,7 @@
               </a:defRPr>
             </a:lvl1pPr>
             <a:lvl2pPr>
+              <a:buNone/>
               <a:defRPr sz="1800" b="0">
                 <a:solidFill>
                   <a:srgbClr val="15796D"/>
@@ -20934,6 +21078,7 @@
               </a:defRPr>
             </a:lvl2pPr>
             <a:lvl3pPr>
+              <a:buNone/>
               <a:defRPr sz="1800" b="0">
                 <a:solidFill>
                   <a:srgbClr val="15796D"/>
@@ -20944,6 +21089,7 @@
               </a:defRPr>
             </a:lvl3pPr>
             <a:lvl4pPr>
+              <a:buNone/>
               <a:defRPr sz="1800" b="0">
                 <a:solidFill>
                   <a:srgbClr val="15796D"/>
@@ -20954,6 +21100,7 @@
               </a:defRPr>
             </a:lvl4pPr>
             <a:lvl5pPr>
+              <a:buNone/>
               <a:defRPr sz="1800" b="0">
                 <a:solidFill>
                   <a:srgbClr val="15796D"/>
@@ -20964,6 +21111,7 @@
               </a:defRPr>
             </a:lvl5pPr>
             <a:lvl6pPr>
+              <a:buNone/>
               <a:defRPr sz="1800" b="0">
                 <a:solidFill>
                   <a:srgbClr val="15796D"/>
@@ -20974,6 +21122,7 @@
               </a:defRPr>
             </a:lvl6pPr>
             <a:lvl7pPr>
+              <a:buNone/>
               <a:defRPr sz="1800" b="0">
                 <a:solidFill>
                   <a:srgbClr val="15796D"/>
@@ -20984,6 +21133,7 @@
               </a:defRPr>
             </a:lvl7pPr>
             <a:lvl8pPr>
+              <a:buNone/>
               <a:defRPr sz="1800" b="0">
                 <a:solidFill>
                   <a:srgbClr val="15796D"/>
@@ -20994,6 +21144,7 @@
               </a:defRPr>
             </a:lvl8pPr>
             <a:lvl9pPr>
+              <a:buNone/>
               <a:defRPr sz="1800" b="0">
                 <a:solidFill>
                   <a:srgbClr val="15796D"/>
@@ -21006,6 +21157,7 @@
           </a:lstStyle>
           <a:p xmlns:a="http://schemas.openxmlformats.org/drawingml/2006/main">
             <a:pPr>
+              <a:buNone/>
               <a:defRPr sz="1800" b="0">
                 <a:solidFill>
                   <a:srgbClr val="15796D"/>
@@ -21024,7 +21176,31 @@
                 <a:ea typeface="Arial Unicode MS"/>
                 <a:cs typeface="Arial Unicode MS"/>
               </a:rPr>
-              <a:t>실제 호출 2/2회 완료 · 제안 21/21개 원문 검증</a:t>
+              <a:t>변경된 요구가 인계표에</a:t>
+            </a:r>
+          </a:p>
+          <a:p xmlns:a="http://schemas.openxmlformats.org/drawingml/2006/main">
+            <a:pPr>
+              <a:buNone/>
+              <a:defRPr sz="1800" b="0">
+                <a:solidFill>
+                  <a:srgbClr val="15796D"/>
+                </a:solidFill>
+                <a:latin typeface="Arial Unicode MS"/>
+                <a:ea typeface="Arial Unicode MS"/>
+                <a:cs typeface="Arial Unicode MS"/>
+              </a:defRPr>
+            </a:pPr>
+            <a:r>
+              <a:rPr sz="1800" b="0">
+                <a:solidFill>
+                  <a:srgbClr val="15796D"/>
+                </a:solidFill>
+                <a:latin typeface="Arial Unicode MS"/>
+                <a:ea typeface="Arial Unicode MS"/>
+                <a:cs typeface="Arial Unicode MS"/>
+              </a:rPr>
+              <a:t>반영되지 않은 항목을 확인했습니다.</a:t>
             </a:r>
           </a:p>
         </p:txBody>
@@ -21559,7 +21735,7 @@
           <p:cNvPr id="4" name="">
             <a:extLst xmlns:a="http://schemas.openxmlformats.org/drawingml/2006/main">
               <a:ext uri="{FF2B5EF4-FFF2-40B4-BE49-F238E27FC236}">
-                <a16:creationId xmlns:a16="http://schemas.microsoft.com/office/drawing/2014/main" id="{16852408-257F-4AB4-882F-A030A6FC7BF8}"/>
+                <a16:creationId xmlns:a16="http://schemas.microsoft.com/office/drawing/2014/main" id="{CA6CE1EB-EFD5-4687-BCFC-285BEC8DDFF9}"/>
               </a:ext>
             </a:extLst>
           </p:cNvPr>
@@ -23722,6 +23898,17 @@
               </a:defRPr>
             </a:pPr>
             <a:r>
+              <a:rPr sz="1800" b="1">
+                <a:solidFill>
+                  <a:srgbClr val="15796D"/>
+                </a:solidFill>
+                <a:latin typeface="Arial Unicode MS"/>
+                <a:ea typeface="Arial Unicode MS"/>
+                <a:cs typeface="Arial Unicode MS"/>
+              </a:rPr>
+              <a:t>ranked.sort</a:t>
+            </a:r>
+            <a:r>
               <a:rPr sz="1800" b="0">
                 <a:solidFill>
                   <a:srgbClr val="173C46"/>
@@ -23730,7 +23917,7 @@
                 <a:ea typeface="Arial Unicode MS"/>
                 <a:cs typeface="Arial Unicode MS"/>
               </a:rPr>
-              <a:t>ranked.sort(key=lambda pair: (-pair[0], pair[1]["page"], pair[1]["start"]))</a:t>
+              <a:t>(key=lambda pair: (-pair[0], pair[1]["page"], pair[1]["start"]))</a:t>
             </a:r>
           </a:p>
           <a:p xmlns:a="http://schemas.openxmlformats.org/drawingml/2006/main">
@@ -23754,7 +23941,29 @@
                 <a:ea typeface="Arial Unicode MS"/>
                 <a:cs typeface="Arial Unicode MS"/>
               </a:rPr>
-              <a:t>for _, occurrence in ranked[:2]:</a:t>
+              <a:t>for _, occurrence in </a:t>
+            </a:r>
+            <a:r>
+              <a:rPr sz="1800" b="1">
+                <a:solidFill>
+                  <a:srgbClr val="15796D"/>
+                </a:solidFill>
+                <a:latin typeface="Arial Unicode MS"/>
+                <a:ea typeface="Arial Unicode MS"/>
+                <a:cs typeface="Arial Unicode MS"/>
+              </a:rPr>
+              <a:t>ranked[:2]</a:t>
+            </a:r>
+            <a:r>
+              <a:rPr sz="1800" b="0">
+                <a:solidFill>
+                  <a:srgbClr val="173C46"/>
+                </a:solidFill>
+                <a:latin typeface="Arial Unicode MS"/>
+                <a:ea typeface="Arial Unicode MS"/>
+                <a:cs typeface="Arial Unicode MS"/>
+              </a:rPr>
+              <a:t>:</a:t>
             </a:r>
           </a:p>
           <a:p xmlns:a="http://schemas.openxmlformats.org/drawingml/2006/main">
@@ -24042,7 +24251,7 @@
                 <a:ea typeface="Arial Unicode MS"/>
                 <a:cs typeface="Arial Unicode MS"/>
               </a:rPr>
-              <a:t>문서·항목·검색어를 받아 상위 원문을 찾습니다.</a:t>
+              <a:t>팬 전원 표현이 있는 근거를 찾아 상위 2개를 선택합니다.</a:t>
             </a:r>
           </a:p>
           <a:p xmlns:a="http://schemas.openxmlformats.org/drawingml/2006/main">
@@ -24066,7 +24275,7 @@
                 <a:ea typeface="Arial Unicode MS"/>
                 <a:cs typeface="Arial Unicode MS"/>
               </a:rPr>
-              <a:t>페이지와 인용문을 붙여 다음 AI 추출 요청에 전달합니다.</a:t>
+              <a:t>문서·페이지·인용문을 다음 AI 추출 요청에 전달합니다.</a:t>
             </a:r>
           </a:p>
         </p:txBody>
@@ -24799,9 +25008,9 @@
               </a:defRPr>
             </a:pPr>
             <a:r>
-              <a:rPr sz="1800" b="0">
-                <a:solidFill>
-                  <a:srgbClr val="173C46"/>
+              <a:rPr sz="1800" b="1">
+                <a:solidFill>
+                  <a:srgbClr val="15796D"/>
                 </a:solidFill>
                 <a:latin typeface="Arial Unicode MS"/>
                 <a:ea typeface="Arial Unicode MS"/>
@@ -24847,9 +25056,9 @@
               </a:defRPr>
             </a:pPr>
             <a:r>
-              <a:rPr sz="1800" b="0">
-                <a:solidFill>
-                  <a:srgbClr val="173C46"/>
+              <a:rPr sz="1800" b="1">
+                <a:solidFill>
+                  <a:srgbClr val="15796D"/>
                 </a:solidFill>
                 <a:latin typeface="Arial Unicode MS"/>
                 <a:ea typeface="Arial Unicode MS"/>
@@ -24903,7 +25112,29 @@
                 <a:ea typeface="Arial Unicode MS"/>
                 <a:cs typeface="Arial Unicode MS"/>
               </a:rPr>
-              <a:t>if not any(_direct_binding(field, value, unit, quote) for value, unit in quoted):</a:t>
+              <a:t>if not any(</a:t>
+            </a:r>
+            <a:r>
+              <a:rPr sz="1800" b="1">
+                <a:solidFill>
+                  <a:srgbClr val="15796D"/>
+                </a:solidFill>
+                <a:latin typeface="Arial Unicode MS"/>
+                <a:ea typeface="Arial Unicode MS"/>
+                <a:cs typeface="Arial Unicode MS"/>
+              </a:rPr>
+              <a:t>_direct_binding(field, value, unit, quote)</a:t>
+            </a:r>
+            <a:r>
+              <a:rPr sz="1800" b="0">
+                <a:solidFill>
+                  <a:srgbClr val="173C46"/>
+                </a:solidFill>
+                <a:latin typeface="Arial Unicode MS"/>
+                <a:ea typeface="Arial Unicode MS"/>
+                <a:cs typeface="Arial Unicode MS"/>
+              </a:rPr>
+              <a:t> for value, unit in quoted):</a:t>
             </a:r>
           </a:p>
           <a:p xmlns:a="http://schemas.openxmlformats.org/drawingml/2006/main">
@@ -25095,7 +25326,7 @@
                 <a:ea typeface="Arial Unicode MS"/>
                 <a:cs typeface="Arial Unicode MS"/>
               </a:rPr>
-              <a:t>원문과 인용에 같은 값·단위가 있는지 확인합니다.</a:t>
+              <a:t>440 V가 팬 전원 항목에 직접 연결되는지 확인합니다.</a:t>
             </a:r>
           </a:p>
           <a:p xmlns:a="http://schemas.openxmlformats.org/drawingml/2006/main">
@@ -25119,7 +25350,7 @@
                 <a:ea typeface="Arial Unicode MS"/>
                 <a:cs typeface="Arial Unicode MS"/>
               </a:rPr>
-              <a:t>해당 항목과 직접 연결되지 않은 값은 보류합니다.</a:t>
+              <a:t>다른 항목의 숫자나 불명확한 값은 채택하지 않습니다.</a:t>
             </a:r>
           </a:p>
         </p:txBody>
@@ -25812,7 +26043,29 @@
                 <a:ea typeface="Arial Unicode MS"/>
                 <a:cs typeface="Arial Unicode MS"/>
               </a:rPr>
-              <a:t>        if expected.condition != actual.condition:</a:t>
+              <a:t>        if </a:t>
+            </a:r>
+            <a:r>
+              <a:rPr sz="1725" b="1">
+                <a:solidFill>
+                  <a:srgbClr val="15796D"/>
+                </a:solidFill>
+                <a:latin typeface="Arial Unicode MS"/>
+                <a:ea typeface="Arial Unicode MS"/>
+                <a:cs typeface="Arial Unicode MS"/>
+              </a:rPr>
+              <a:t>expected.condition != actual.condition</a:t>
+            </a:r>
+            <a:r>
+              <a:rPr sz="1725" b="0">
+                <a:solidFill>
+                  <a:srgbClr val="173C46"/>
+                </a:solidFill>
+                <a:latin typeface="Arial Unicode MS"/>
+                <a:ea typeface="Arial Unicode MS"/>
+                <a:cs typeface="Arial Unicode MS"/>
+              </a:rPr>
+              <a:t>:</a:t>
             </a:r>
           </a:p>
           <a:p xmlns:a="http://schemas.openxmlformats.org/drawingml/2006/main">
@@ -25860,7 +26113,29 @@
                 <a:ea typeface="Arial Unicode MS"/>
                 <a:cs typeface="Arial Unicode MS"/>
               </a:rPr>
-              <a:t>        if expected.comparable == actual.comparable:</a:t>
+              <a:t>        if </a:t>
+            </a:r>
+            <a:r>
+              <a:rPr sz="1725" b="1">
+                <a:solidFill>
+                  <a:srgbClr val="15796D"/>
+                </a:solidFill>
+                <a:latin typeface="Arial Unicode MS"/>
+                <a:ea typeface="Arial Unicode MS"/>
+                <a:cs typeface="Arial Unicode MS"/>
+              </a:rPr>
+              <a:t>expected.comparable == actual.comparable</a:t>
+            </a:r>
+            <a:r>
+              <a:rPr sz="1725" b="0">
+                <a:solidFill>
+                  <a:srgbClr val="173C46"/>
+                </a:solidFill>
+                <a:latin typeface="Arial Unicode MS"/>
+                <a:ea typeface="Arial Unicode MS"/>
+                <a:cs typeface="Arial Unicode MS"/>
+              </a:rPr>
+              <a:t>:</a:t>
             </a:r>
           </a:p>
           <a:p xmlns:a="http://schemas.openxmlformats.org/drawingml/2006/main">
@@ -25884,7 +26159,29 @@
                 <a:ea typeface="Arial Unicode MS"/>
                 <a:cs typeface="Arial Unicode MS"/>
               </a:rPr>
-              <a:t>            item.update(status="MATCH", reason="명시된 동일 항목·조건에서 단위 정규화 후 값이 같습니다.")</a:t>
+              <a:t>            item.update(status=</a:t>
+            </a:r>
+            <a:r>
+              <a:rPr sz="1725" b="1">
+                <a:solidFill>
+                  <a:srgbClr val="15796D"/>
+                </a:solidFill>
+                <a:latin typeface="Arial Unicode MS"/>
+                <a:ea typeface="Arial Unicode MS"/>
+                <a:cs typeface="Arial Unicode MS"/>
+              </a:rPr>
+              <a:t>"MATCH"</a:t>
+            </a:r>
+            <a:r>
+              <a:rPr sz="1725" b="0">
+                <a:solidFill>
+                  <a:srgbClr val="173C46"/>
+                </a:solidFill>
+                <a:latin typeface="Arial Unicode MS"/>
+                <a:ea typeface="Arial Unicode MS"/>
+                <a:cs typeface="Arial Unicode MS"/>
+              </a:rPr>
+              <a:t>, reason="명시된 동일 항목·조건에서 단위 정규화 후 값이 같습니다.")</a:t>
             </a:r>
           </a:p>
           <a:p xmlns:a="http://schemas.openxmlformats.org/drawingml/2006/main">
@@ -25932,7 +26229,29 @@
                 <a:ea typeface="Arial Unicode MS"/>
                 <a:cs typeface="Arial Unicode MS"/>
               </a:rPr>
-              <a:t>            item.update(status="MISMATCH", reason="명시된 동일 항목·조건에서 단위 정규화 후 값이 다릅니다.")</a:t>
+              <a:t>            item.update(status=</a:t>
+            </a:r>
+            <a:r>
+              <a:rPr sz="1725" b="1">
+                <a:solidFill>
+                  <a:srgbClr val="A54E35"/>
+                </a:solidFill>
+                <a:latin typeface="Arial Unicode MS"/>
+                <a:ea typeface="Arial Unicode MS"/>
+                <a:cs typeface="Arial Unicode MS"/>
+              </a:rPr>
+              <a:t>"MISMATCH"</a:t>
+            </a:r>
+            <a:r>
+              <a:rPr sz="1725" b="0">
+                <a:solidFill>
+                  <a:srgbClr val="173C46"/>
+                </a:solidFill>
+                <a:latin typeface="Arial Unicode MS"/>
+                <a:ea typeface="Arial Unicode MS"/>
+                <a:cs typeface="Arial Unicode MS"/>
+              </a:rPr>
+              <a:t>, reason="명시된 동일 항목·조건에서 단위 정규화 후 값이 다릅니다.")</a:t>
             </a:r>
           </a:p>
           <a:p xmlns:a="http://schemas.openxmlformats.org/drawingml/2006/main">
@@ -25980,7 +26299,29 @@
                 <a:ea typeface="Arial Unicode MS"/>
                 <a:cs typeface="Arial Unicode MS"/>
               </a:rPr>
-              <a:t>    item.update(status="NEEDS_REVIEW", reason=str(exc))</a:t>
+              <a:t>    item.update(status=</a:t>
+            </a:r>
+            <a:r>
+              <a:rPr sz="1725" b="1">
+                <a:solidFill>
+                  <a:srgbClr val="A54E35"/>
+                </a:solidFill>
+                <a:latin typeface="Arial Unicode MS"/>
+                <a:ea typeface="Arial Unicode MS"/>
+                <a:cs typeface="Arial Unicode MS"/>
+              </a:rPr>
+              <a:t>"NEEDS_REVIEW"</a:t>
+            </a:r>
+            <a:r>
+              <a:rPr sz="1725" b="0">
+                <a:solidFill>
+                  <a:srgbClr val="173C46"/>
+                </a:solidFill>
+                <a:latin typeface="Arial Unicode MS"/>
+                <a:ea typeface="Arial Unicode MS"/>
+                <a:cs typeface="Arial Unicode MS"/>
+              </a:rPr>
+              <a:t>, reason=str(exc))</a:t>
             </a:r>
           </a:p>
         </p:txBody>
@@ -26148,7 +26489,7 @@
                 <a:ea typeface="Arial Unicode MS"/>
                 <a:cs typeface="Arial Unicode MS"/>
               </a:rPr>
-              <a:t>같은 운전조건에서 정규화된 사양값을 비교합니다.</a:t>
+              <a:t>같은 항목·조건의 440 V와 380 V를 불일치로 표시합니다.</a:t>
             </a:r>
           </a:p>
           <a:p xmlns:a="http://schemas.openxmlformats.org/drawingml/2006/main">
@@ -26172,7 +26513,7 @@
                 <a:ea typeface="Arial Unicode MS"/>
                 <a:cs typeface="Arial Unicode MS"/>
               </a:rPr>
-              <a:t>출처·값·조건이 불확실하면 확인 필요로 남깁니다.</a:t>
+              <a:t>출처나 비교 조건이 불확실하면 확인 필요로 보류합니다.</a:t>
             </a:r>
           </a:p>
         </p:txBody>
@@ -26889,7 +27230,18 @@
                 <a:ea typeface="Arial Unicode MS"/>
                 <a:cs typeface="Arial Unicode MS"/>
               </a:rPr>
-              <a:t>result, request = run_with(self.documents, self.proposals)</a:t>
+              <a:t>result, request = </a:t>
+            </a:r>
+            <a:r>
+              <a:rPr sz="1875" b="1">
+                <a:solidFill>
+                  <a:srgbClr val="15796D"/>
+                </a:solidFill>
+                <a:latin typeface="Arial Unicode MS"/>
+                <a:ea typeface="Arial Unicode MS"/>
+                <a:cs typeface="Arial Unicode MS"/>
+              </a:rPr>
+              <a:t>run_with(self.documents, self.proposals)</a:t>
             </a:r>
           </a:p>
           <a:p xmlns:a="http://schemas.openxmlformats.org/drawingml/2006/main">
@@ -27009,7 +27361,29 @@
                 <a:ea typeface="Arial Unicode MS"/>
                 <a:cs typeface="Arial Unicode MS"/>
               </a:rPr>
-              <a:t>self.assertEqual(request.call_count, 2)</a:t>
+              <a:t>self.assertEqual(</a:t>
+            </a:r>
+            <a:r>
+              <a:rPr sz="1875" b="1">
+                <a:solidFill>
+                  <a:srgbClr val="15796D"/>
+                </a:solidFill>
+                <a:latin typeface="Arial Unicode MS"/>
+                <a:ea typeface="Arial Unicode MS"/>
+                <a:cs typeface="Arial Unicode MS"/>
+              </a:rPr>
+              <a:t>request.call_count, 2</a:t>
+            </a:r>
+            <a:r>
+              <a:rPr sz="1875" b="0">
+                <a:solidFill>
+                  <a:srgbClr val="173C46"/>
+                </a:solidFill>
+                <a:latin typeface="Arial Unicode MS"/>
+                <a:ea typeface="Arial Unicode MS"/>
+                <a:cs typeface="Arial Unicode MS"/>
+              </a:rPr>
+              <a:t>)</a:t>
             </a:r>
           </a:p>
           <a:p xmlns:a="http://schemas.openxmlformats.org/drawingml/2006/main">
@@ -27033,7 +27407,29 @@
                 <a:ea typeface="Arial Unicode MS"/>
                 <a:cs typeface="Arial Unicode MS"/>
               </a:rPr>
-              <a:t>self.assertEqual(self.documents, before)</a:t>
+              <a:t>self.assertEqual(</a:t>
+            </a:r>
+            <a:r>
+              <a:rPr sz="1875" b="1">
+                <a:solidFill>
+                  <a:srgbClr val="15796D"/>
+                </a:solidFill>
+                <a:latin typeface="Arial Unicode MS"/>
+                <a:ea typeface="Arial Unicode MS"/>
+                <a:cs typeface="Arial Unicode MS"/>
+              </a:rPr>
+              <a:t>self.documents, before</a:t>
+            </a:r>
+            <a:r>
+              <a:rPr sz="1875" b="0">
+                <a:solidFill>
+                  <a:srgbClr val="173C46"/>
+                </a:solidFill>
+                <a:latin typeface="Arial Unicode MS"/>
+                <a:ea typeface="Arial Unicode MS"/>
+                <a:cs typeface="Arial Unicode MS"/>
+              </a:rPr>
+              <a:t>)</a:t>
             </a:r>
           </a:p>
           <a:p xmlns:a="http://schemas.openxmlformats.org/drawingml/2006/main">
@@ -27225,7 +27621,7 @@
                 <a:ea typeface="Arial Unicode MS"/>
                 <a:cs typeface="Arial Unicode MS"/>
               </a:rPr>
-              <a:t>모델 요청 함수를 교체해 같은 조건으로 검사합니다.</a:t>
+              <a:t>고정 응답으로 호출 수와 입력 보존을 반복 검사합니다.</a:t>
             </a:r>
           </a:p>
           <a:p xmlns:a="http://schemas.openxmlformats.org/drawingml/2006/main">
@@ -27249,7 +27645,7 @@
                 <a:ea typeface="Arial Unicode MS"/>
                 <a:cs typeface="Arial Unicode MS"/>
               </a:rPr>
-              <a:t>2회 호출과 입력 보존을 확인하며, AI 정확도와 구분합니다.</a:t>
+              <a:t>AI는 제안하고, 코드는 검증하며, 최종 판단은 담당자가 합니다.</a:t>
             </a:r>
           </a:p>
         </p:txBody>

</xml_diff>